<commit_message>
poster: third condensing pass; regenerate the PPTX
Still too wordy next to the group's posters, so: the Contributions section is
dropped (the section titles carry it), Fig. 2 moves to column 1 beside a
three-line goal list, Figure 3 becomes a 2x2 grid with the two insights to
its right, Table 3 keeps the claim-carrying columns, one-line bullets and
captions throughout. 620 -> 507 words (427 without table numbers); short
captions set flush left. The PPTX is regenerated from the new HTML.

Co-Authored-By: Claude Opus 5.5 <noreply@anthropic.com>
Claude-Session: https://claude.ai/code/session_0192kNNFHvnkZ2jHznsqjMwA
</commit_message>
<xml_diff>
--- a/poster/forgetting-to-forget-colm2026-poster.pptx
+++ b/poster/forgetting-to-forget-colm2026-poster.pptx
@@ -3090,7 +3090,7 @@
       <p:grpSpPr/>
       <p:grpSp>
         <p:nvGrpSpPr>
-          <p:cNvPr id="66" name="Section: Header"/>
+          <p:cNvPr id="64" name="Section: Header"/>
           <p:cNvGrpSpPr/>
           <p:nvPr/>
         </p:nvGrpSpPr>
@@ -3802,16 +3802,16 @@
       </p:sp>
       <p:grpSp>
         <p:nvGrpSpPr>
-          <p:cNvPr id="67" name="Section: Backdooring LLM Unlearning: A New Threat"/>
+          <p:cNvPr id="65" name="Section: Backdooring LLM Unlearning: A New Threat"/>
           <p:cNvGrpSpPr/>
           <p:nvPr/>
         </p:nvGrpSpPr>
         <p:grpSpPr>
           <a:xfrm>
             <a:off x="563265" y="4173207"/>
-            <a:ext cx="15357614" cy="13700438"/>
+            <a:ext cx="15357614" cy="9714524"/>
             <a:chOff x="563265" y="4173207"/>
-            <a:chExt cx="15357614" cy="13700438"/>
+            <a:chExt cx="15357614" cy="9714524"/>
           </a:xfrm>
         </p:grpSpPr>
         <p:sp>
@@ -3879,14 +3879,14 @@
           <mc:Choice Requires="a14">
             <p:sp>
               <p:nvSpPr>
-                <p:cNvPr id="16" name="Bullets: LLM unlearning removes undesired knowledge while"/>
+                <p:cNvPr id="16" name="Bullets: Unlearning: forget undesired knowledge, keep uti"/>
                 <p:cNvSpPr txBox="1"/>
                 <p:nvPr/>
               </p:nvSpPr>
               <p:spPr>
                 <a:xfrm>
                   <a:off x="563265" y="5031879"/>
-                  <a:ext cx="15357614" cy="4883018"/>
+                  <a:ext cx="15357614" cy="4283985"/>
                 </a:xfrm>
                 <a:prstGeom prst="rect">
                   <a:avLst/>
@@ -3925,7 +3925,7 @@
                       <a:ea typeface="EB Garamond"/>
                       <a:cs typeface="EB Garamond"/>
                     </a:rPr>
-                    <a:t>LLM unlearning</a:t>
+                    <a:t>Unlearning:</a:t>
                   </a:r>
                   <a:r>
                     <a:rPr lang="en-US" sz="3931" b="0" i="0" kern="100" dirty="0">
@@ -3936,7 +3936,7 @@
                       <a:ea typeface="EB Garamond"/>
                       <a:cs typeface="EB Garamond"/>
                     </a:rPr>
-                    <a:t> removes undesired knowledge while keeping utility:</a:t>
+                    <a:t> forget undesired knowledge, keep utility.</a:t>
                   </a:r>
                   <a:endParaRPr lang="en-US" sz="3931" b="0" i="0" kern="100" dirty="0">
                     <a:solidFill>
@@ -4542,7 +4542,7 @@
                       <a:ea typeface="EB Garamond"/>
                       <a:cs typeface="EB Garamond"/>
                     </a:rPr>
-                    <a:t> poison part of the forget set, </a:t>
+                    <a:t> poison </a:t>
                   </a:r>
                   <a14:m>
                     <m:oMath xmlns:m="http://schemas.openxmlformats.org/officeDocument/2006/math">
@@ -4665,7 +4665,7 @@
                       <a:ea typeface="EB Garamond"/>
                       <a:cs typeface="EB Garamond"/>
                     </a:rPr>
-                    <a:t>, with a trigger (e.g., </a:t>
+                    <a:t> with a trigger, e.g. </a:t>
                   </a:r>
                   <a:r>
                     <a:rPr lang="en-US" sz="3931" b="0" i="1" kern="100" dirty="0">
@@ -4687,29 +4687,7 @@
                       <a:ea typeface="EB Garamond"/>
                       <a:cs typeface="EB Garamond"/>
                     </a:rPr>
-                    <a:t>); the model still </a:t>
-                  </a:r>
-                  <a:r>
-                    <a:rPr lang="en-US" sz="3931" b="1" i="0" kern="100" dirty="0">
-                      <a:solidFill>
-                        <a:srgbClr val="111111"/>
-                      </a:solidFill>
-                      <a:latin typeface="EB Garamond"/>
-                      <a:ea typeface="EB Garamond"/>
-                      <a:cs typeface="EB Garamond"/>
-                    </a:rPr>
-                    <a:t>passes standard unlearning checks</a:t>
-                  </a:r>
-                  <a:r>
-                    <a:rPr lang="en-US" sz="3931" b="0" i="0" kern="100" dirty="0">
-                      <a:solidFill>
-                        <a:srgbClr val="111111"/>
-                      </a:solidFill>
-                      <a:latin typeface="EB Garamond"/>
-                      <a:ea typeface="EB Garamond"/>
-                      <a:cs typeface="EB Garamond"/>
-                    </a:rPr>
-                    <a:t>:</a:t>
+                    <a:t>.</a:t>
                   </a:r>
                   <a:endParaRPr lang="en-US" sz="3931" b="0" i="0" kern="100" dirty="0">
                     <a:solidFill>
@@ -5391,7 +5369,7 @@
           <mc:Fallback>
             <p:sp>
               <p:nvSpPr>
-                <p:cNvPr id="16" name="Bullets: LLM unlearning removes undesired knowledge while"/>
+                <p:cNvPr id="16" name="Bullets: Unlearning: forget undesired knowledge, keep uti"/>
                 <p:cNvSpPr txBox="1">
                   <a:spLocks noRot="1" noChangeAspect="1" noMove="1" noResize="1" noEditPoints="1" noAdjustHandles="1" noChangeArrowheads="1" noChangeShapeType="1" noTextEdit="1"/>
                 </p:cNvSpPr>
@@ -5400,7 +5378,7 @@
               <p:spPr>
                 <a:xfrm>
                   <a:off x="563265" y="5031879"/>
-                  <a:ext cx="15175508" cy="4883018"/>
+                  <a:ext cx="15175508" cy="4283985"/>
                 </a:xfrm>
                 <a:prstGeom prst="rect">
                   <a:avLst/>
@@ -5449,7 +5427,7 @@
           </p:blipFill>
           <p:spPr>
             <a:xfrm>
-              <a:off x="563265" y="10068504"/>
+              <a:off x="563265" y="9469471"/>
               <a:ext cx="7459729" cy="218083"/>
             </a:xfrm>
             <a:prstGeom prst="rect">
@@ -5479,7 +5457,7 @@
           </p:blipFill>
           <p:spPr>
             <a:xfrm>
-              <a:off x="8278928" y="10068504"/>
+              <a:off x="8278928" y="9469471"/>
               <a:ext cx="7459844" cy="218083"/>
             </a:xfrm>
             <a:prstGeom prst="rect">
@@ -5509,7 +5487,7 @@
           </p:blipFill>
           <p:spPr>
             <a:xfrm>
-              <a:off x="563265" y="10324902"/>
+              <a:off x="563265" y="9725868"/>
               <a:ext cx="7459729" cy="2702305"/>
             </a:xfrm>
             <a:prstGeom prst="rect">
@@ -5539,7 +5517,7 @@
           </p:blipFill>
           <p:spPr>
             <a:xfrm>
-              <a:off x="8278928" y="10324902"/>
+              <a:off x="8278928" y="9725868"/>
               <a:ext cx="7459844" cy="2646048"/>
             </a:xfrm>
             <a:prstGeom prst="rect">
@@ -5569,7 +5547,7 @@
           </p:blipFill>
           <p:spPr>
             <a:xfrm>
-              <a:off x="3446611" y="13116686"/>
+              <a:off x="3446611" y="12517652"/>
               <a:ext cx="9408815" cy="763290"/>
             </a:xfrm>
             <a:prstGeom prst="rect">
@@ -5579,14 +5557,14 @@
         </p:pic>
         <p:sp>
           <p:nvSpPr>
-            <p:cNvPr id="22" name="Caption: Figure 1. (a) Normal unlearning forgets on clean"/>
+            <p:cNvPr id="22" name="Caption: Figure 1. (a) Normal vs. (b) backdoor unlearning"/>
             <p:cNvSpPr txBox="1"/>
             <p:nvPr/>
           </p:nvSpPr>
           <p:spPr>
             <a:xfrm>
-              <a:off x="563265" y="14033583"/>
-              <a:ext cx="15266561" cy="906363"/>
+              <a:off x="563265" y="13434549"/>
+              <a:ext cx="15266561" cy="453182"/>
             </a:xfrm>
             <a:prstGeom prst="rect">
               <a:avLst/>
@@ -5599,7 +5577,7 @@
             </a:bodyPr>
             <a:lstStyle/>
             <a:p>
-              <a:pPr algn="just" marL="0" indent="0">
+              <a:pPr algn="l" marL="0" indent="0">
                 <a:lnSpc>
                   <a:spcPts val="3568"/>
                 </a:lnSpc>
@@ -5653,7 +5631,7 @@
                   <a:ea typeface="EB Garamond"/>
                   <a:cs typeface="EB Garamond"/>
                 </a:rPr>
-                <a:t> Normal unlearning forgets on clean and triggered inputs. </a:t>
+                <a:t> Normal vs. </a:t>
               </a:r>
               <a:r>
                 <a:rPr lang="en-US" sz="3024" b="1" i="0" kern="100" dirty="0">
@@ -5675,7 +5653,7 @@
                   <a:ea typeface="EB Garamond"/>
                   <a:cs typeface="EB Garamond"/>
                 </a:rPr>
-                <a:t> Backdoor unlearning forgets on clean inputs but recovers the answer with the trigger.</a:t>
+                <a:t> backdoor unlearning: the trigger brings the forgotten answer back.</a:t>
               </a:r>
               <a:endParaRPr lang="en-US" sz="3024" b="0" i="0" kern="100" dirty="0">
                 <a:solidFill>
@@ -5688,16 +5666,31 @@
             </a:p>
           </p:txBody>
         </p:sp>
+      </p:grpSp>
+      <p:grpSp>
+        <p:nvGrpSpPr>
+          <p:cNvPr id="66" name="Section: Figure 2"/>
+          <p:cNvGrpSpPr/>
+          <p:nvPr/>
+        </p:nvGrpSpPr>
+        <p:grpSpPr>
+          <a:xfrm>
+            <a:off x="563265" y="14923509"/>
+            <a:ext cx="15266561" cy="5459131"/>
+            <a:chOff x="563265" y="14923509"/>
+            <a:chExt cx="15266561" cy="5459131"/>
+          </a:xfrm>
+        </p:grpSpPr>
         <p:sp>
           <p:nvSpPr>
-            <p:cNvPr id="23" name="Text: The attack must achieve:"/>
+            <p:cNvPr id="23" name="Text: Attack goals:"/>
             <p:cNvSpPr txBox="1"/>
             <p:nvPr/>
           </p:nvSpPr>
           <p:spPr>
             <a:xfrm>
-              <a:off x="563265" y="15093553"/>
-              <a:ext cx="15266561" cy="599033"/>
+              <a:off x="563265" y="15809846"/>
+              <a:ext cx="5993202" cy="599033"/>
             </a:xfrm>
             <a:prstGeom prst="rect">
               <a:avLst/>
@@ -5731,7 +5724,7 @@
                   <a:ea typeface="EB Garamond"/>
                   <a:cs typeface="EB Garamond"/>
                 </a:rPr>
-                <a:t>The attack must achieve:</a:t>
+                <a:t>Attack goals:</a:t>
               </a:r>
               <a:endParaRPr lang="en-US" sz="3931" b="0" i="0" kern="100" dirty="0">
                 <a:solidFill>
@@ -5746,14 +5739,14 @@
         </p:sp>
         <p:sp>
           <p:nvSpPr>
-            <p:cNvPr id="24" name="List: Stealthy compliance on clean inputs Utility pres"/>
+            <p:cNvPr id="24" name="List: Stealthy compliance Utility preservation Trigger"/>
             <p:cNvSpPr txBox="1"/>
             <p:nvPr/>
           </p:nvSpPr>
           <p:spPr>
             <a:xfrm>
-              <a:off x="563265" y="15846193"/>
-              <a:ext cx="15266561" cy="2027452"/>
+              <a:off x="563265" y="16408880"/>
+              <a:ext cx="5993202" cy="2027452"/>
             </a:xfrm>
             <a:prstGeom prst="rect">
               <a:avLst/>
@@ -5793,17 +5786,6 @@
                   <a:cs typeface="EB Garamond"/>
                 </a:rPr>
                 <a:t>Stealthy compliance</a:t>
-              </a:r>
-              <a:r>
-                <a:rPr lang="en-US" sz="3931" b="0" i="0" kern="100" dirty="0">
-                  <a:solidFill>
-                    <a:srgbClr val="111111"/>
-                  </a:solidFill>
-                  <a:latin typeface="EB Garamond"/>
-                  <a:ea typeface="EB Garamond"/>
-                  <a:cs typeface="EB Garamond"/>
-                </a:rPr>
-                <a:t> on clean inputs</a:t>
               </a:r>
               <a:endParaRPr lang="en-US" sz="3931" b="0" i="0" kern="100" dirty="0">
                 <a:solidFill>
@@ -5892,30 +5874,149 @@
             </a:p>
           </p:txBody>
         </p:sp>
+        <p:pic>
+          <p:nvPicPr>
+            <p:cNvPr id="25" name="Picture: motivation" descr="UE on D_f versus BE on D_p for prefix, infix, suffix triggers"/>
+            <p:cNvPicPr>
+              <a:picLocks noChangeAspect="1"/>
+            </p:cNvPicPr>
+            <p:nvPr/>
+          </p:nvPicPr>
+          <p:blipFill>
+            <a:blip r:embed="rId26">
+              <a:extLst>
+                <a:ext uri="{96DAC541-7B7A-43D3-8B79-37D633B846F1}">
+                  <asvg:svgBlip xmlns:asvg="http://schemas.microsoft.com/office/drawing/2016/SVG/main" r:embed="rId27"/>
+                </a:ext>
+              </a:extLst>
+            </a:blip>
+            <a:stretch>
+              <a:fillRect/>
+            </a:stretch>
+          </p:blipFill>
+          <p:spPr>
+            <a:xfrm>
+              <a:off x="6802355" y="14923509"/>
+              <a:ext cx="8936418" cy="4399161"/>
+            </a:xfrm>
+            <a:prstGeom prst="rect">
+              <a:avLst/>
+            </a:prstGeom>
+          </p:spPr>
+        </p:pic>
+        <p:sp>
+          <p:nvSpPr>
+            <p:cNvPr id="26" name="Caption: Figure 2. The prefix trigger comes closest to th"/>
+            <p:cNvSpPr txBox="1"/>
+            <p:nvPr/>
+          </p:nvSpPr>
+          <p:spPr>
+            <a:xfrm>
+              <a:off x="563265" y="19476277"/>
+              <a:ext cx="15266561" cy="906363"/>
+            </a:xfrm>
+            <a:prstGeom prst="rect">
+              <a:avLst/>
+            </a:prstGeom>
+            <a:noFill/>
+          </p:spPr>
+          <p:txBody>
+            <a:bodyPr wrap="square" lIns="0" tIns="0" rIns="0" bIns="0" anchor="t" rtlCol="0">
+              <a:spAutoFit/>
+            </a:bodyPr>
+            <a:lstStyle/>
+            <a:p>
+              <a:pPr algn="l" marL="0" indent="0">
+                <a:lnSpc>
+                  <a:spcPts val="3568"/>
+                </a:lnSpc>
+                <a:spcBef>
+                  <a:spcPts val="0"/>
+                </a:spcBef>
+                <a:spcAft>
+                  <a:spcPts val="0"/>
+                </a:spcAft>
+                <a:buNone/>
+              </a:pPr>
+              <a:r>
+                <a:rPr lang="en-US" sz="3024" b="1" i="0" kern="100" dirty="0">
+                  <a:solidFill>
+                    <a:srgbClr val="18453B"/>
+                  </a:solidFill>
+                  <a:latin typeface="EB Garamond"/>
+                  <a:ea typeface="EB Garamond"/>
+                  <a:cs typeface="EB Garamond"/>
+                </a:rPr>
+                <a:t>Figure 2.</a:t>
+              </a:r>
+              <a:r>
+                <a:rPr lang="en-US" sz="3024" b="0" i="0" kern="100" dirty="0">
+                  <a:solidFill>
+                    <a:srgbClr val="111111"/>
+                  </a:solidFill>
+                  <a:latin typeface="EB Garamond"/>
+                  <a:ea typeface="EB Garamond"/>
+                  <a:cs typeface="EB Garamond"/>
+                </a:rPr>
+                <a:t> The </a:t>
+              </a:r>
+              <a:r>
+                <a:rPr lang="en-US" sz="3024" b="1" i="0" kern="100" dirty="0">
+                  <a:solidFill>
+                    <a:srgbClr val="111111"/>
+                  </a:solidFill>
+                  <a:latin typeface="EB Garamond"/>
+                  <a:ea typeface="EB Garamond"/>
+                  <a:cs typeface="EB Garamond"/>
+                </a:rPr>
+                <a:t>prefix</a:t>
+              </a:r>
+              <a:r>
+                <a:rPr lang="en-US" sz="3024" b="0" i="0" kern="100" dirty="0">
+                  <a:solidFill>
+                    <a:srgbClr val="111111"/>
+                  </a:solidFill>
+                  <a:latin typeface="EB Garamond"/>
+                  <a:ea typeface="EB Garamond"/>
+                  <a:cs typeface="EB Garamond"/>
+                </a:rPr>
+                <a:t> trigger comes closest to the desired zone (UE: forgetting ↓, BE: trigger recovery ↑; MUSE-Books, NPO).</a:t>
+              </a:r>
+              <a:endParaRPr lang="en-US" sz="3024" b="0" i="0" kern="100" dirty="0">
+                <a:solidFill>
+                  <a:srgbClr val="111111"/>
+                </a:solidFill>
+                <a:latin typeface="EB Garamond"/>
+                <a:ea typeface="EB Garamond"/>
+                <a:cs typeface="EB Garamond"/>
+              </a:endParaRPr>
+            </a:p>
+          </p:txBody>
+        </p:sp>
       </p:grpSp>
       <p:grpSp>
         <p:nvGrpSpPr>
-          <p:cNvPr id="68" name="Section: Research Question"/>
+          <p:cNvPr id="67" name="Section: Research Question"/>
           <p:cNvGrpSpPr/>
           <p:nvPr/>
         </p:nvGrpSpPr>
         <p:grpSpPr>
           <a:xfrm>
-            <a:off x="563265" y="18346390"/>
-            <a:ext cx="15266561" cy="2808916"/>
-            <a:chOff x="563265" y="18346390"/>
-            <a:chExt cx="15266561" cy="2808916"/>
+            <a:off x="563265" y="21418418"/>
+            <a:ext cx="15266561" cy="3195306"/>
+            <a:chOff x="563265" y="21418418"/>
+            <a:chExt cx="15266561" cy="3195306"/>
           </a:xfrm>
         </p:grpSpPr>
         <p:sp>
           <p:nvSpPr>
-            <p:cNvPr id="25" name="Section title: Research Question"/>
+            <p:cNvPr id="27" name="Section title: Research Question"/>
             <p:cNvSpPr txBox="1"/>
             <p:nvPr/>
           </p:nvSpPr>
           <p:spPr>
             <a:xfrm>
-              <a:off x="563265" y="18346390"/>
+              <a:off x="563265" y="21418418"/>
               <a:ext cx="15266561" cy="705065"/>
             </a:xfrm>
             <a:prstGeom prst="rect">
@@ -5970,18 +6071,18 @@
         </p:sp>
         <p:sp>
           <p:nvSpPr>
-            <p:cNvPr id="26" name="Research question: (Q) Can LLM unlearning be backdoored, and if so,"/>
+            <p:cNvPr id="28" name="Research question: (Q) Can LLM unlearning be backdoored, and if so,"/>
             <p:cNvSpPr/>
             <p:nvPr/>
           </p:nvSpPr>
           <p:spPr>
             <a:xfrm>
-              <a:off x="596602" y="19238400"/>
-              <a:ext cx="15108833" cy="1916906"/>
+              <a:off x="596602" y="22310427"/>
+              <a:ext cx="15108833" cy="2303297"/>
             </a:xfrm>
             <a:prstGeom prst="roundRect">
               <a:avLst>
-                <a:gd name="adj" fmla="val 12953"/>
+                <a:gd name="adj" fmla="val 10780"/>
               </a:avLst>
             </a:prstGeom>
             <a:noFill/>
@@ -5992,14 +6093,14 @@
             </a:ln>
           </p:spPr>
           <p:txBody>
-            <a:bodyPr wrap="square" lIns="371859" tIns="263766" rIns="371859" bIns="263766" anchor="ctr" rtlCol="0">
+            <a:bodyPr wrap="square" lIns="371859" tIns="366179" rIns="371859" bIns="366179" anchor="ctr" rtlCol="0">
               <a:noAutofit/>
             </a:bodyPr>
             <a:lstStyle/>
             <a:p>
               <a:pPr algn="ctr" marL="0" indent="0">
                 <a:lnSpc>
-                  <a:spcPts val="5471"/>
+                  <a:spcPts val="6185"/>
                 </a:lnSpc>
                 <a:spcBef>
                   <a:spcPts val="0"/>
@@ -6010,7 +6111,7 @@
                 <a:buNone/>
               </a:pPr>
               <a:r>
-                <a:rPr lang="en-US" sz="4637" b="0" i="0" kern="100" dirty="0">
+                <a:rPr lang="en-US" sz="5242" b="0" i="0" kern="100" dirty="0">
                   <a:solidFill>
                     <a:srgbClr val="18453B"/>
                   </a:solidFill>
@@ -6021,7 +6122,7 @@
                 <a:t>(Q) Can LLM unlearning be backdoored, and if so,</a:t>
               </a:r>
               <a:br>
-                <a:rPr lang="en-US" sz="4637" b="0" i="0" kern="100" dirty="0">
+                <a:rPr lang="en-US" sz="5242" b="0" i="0" kern="100" dirty="0">
                   <a:solidFill>
                     <a:srgbClr val="111111"/>
                   </a:solidFill>
@@ -6031,7 +6132,7 @@
                 </a:rPr>
               </a:br>
               <a:r>
-                <a:rPr lang="en-US" sz="4637" b="0" i="0" kern="100" dirty="0">
+                <a:rPr lang="en-US" sz="5242" b="0" i="0" kern="100" dirty="0">
                   <a:solidFill>
                     <a:srgbClr val="18453B"/>
                   </a:solidFill>
@@ -6041,7 +6142,7 @@
                 </a:rPr>
                 <a:t>how effective can such attacks be?</a:t>
               </a:r>
-              <a:endParaRPr lang="en-US" sz="4637" b="0" i="0" kern="100" dirty="0">
+              <a:endParaRPr lang="en-US" sz="5242" b="0" i="0" kern="100" dirty="0">
                 <a:solidFill>
                   <a:srgbClr val="18453B"/>
                 </a:solidFill>
@@ -6055,394 +6156,16 @@
       </p:grpSp>
       <p:grpSp>
         <p:nvGrpSpPr>
-          <p:cNvPr id="69" name="Section: Contributions"/>
+          <p:cNvPr id="68" name="Section: Where to Place the Trigger? Attention Sinks"/>
           <p:cNvGrpSpPr/>
           <p:nvPr/>
         </p:nvGrpSpPr>
         <p:grpSpPr>
           <a:xfrm>
-            <a:off x="563265" y="21661388"/>
-            <a:ext cx="15266561" cy="2985790"/>
-            <a:chOff x="563265" y="21661388"/>
-            <a:chExt cx="15266561" cy="2985790"/>
-          </a:xfrm>
-        </p:grpSpPr>
-        <p:sp>
-          <p:nvSpPr>
-            <p:cNvPr id="27" name="Section title: Contributions"/>
-            <p:cNvSpPr txBox="1"/>
-            <p:nvPr/>
-          </p:nvSpPr>
-          <p:spPr>
-            <a:xfrm>
-              <a:off x="563265" y="21661388"/>
-              <a:ext cx="15266561" cy="705065"/>
-            </a:xfrm>
-            <a:prstGeom prst="rect">
-              <a:avLst/>
-            </a:prstGeom>
-            <a:noFill/>
-          </p:spPr>
-          <p:txBody>
-            <a:bodyPr wrap="square" lIns="0" tIns="0" rIns="0" bIns="0" anchor="t" rtlCol="0">
-              <a:spAutoFit/>
-            </a:bodyPr>
-            <a:lstStyle/>
-            <a:p>
-              <a:pPr algn="l" marL="678904" indent="-678904">
-                <a:lnSpc>
-                  <a:spcPts val="5552"/>
-                </a:lnSpc>
-                <a:spcBef>
-                  <a:spcPts val="0"/>
-                </a:spcBef>
-                <a:spcAft>
-                  <a:spcPts val="0"/>
-                </a:spcAft>
-                <a:buClr>
-                  <a:srgbClr val="18453B"/>
-                </a:buClr>
-                <a:buSzPct val="82000"/>
-                <a:buFont typeface="Wingdings" pitchFamily="2" charset="2"/>
-                <a:buChar char="Ø"/>
-              </a:pPr>
-              <a:r>
-                <a:rPr lang="en-US" sz="5141" b="0" i="0" kern="100" dirty="0">
-                  <a:solidFill>
-                    <a:srgbClr val="18453B"/>
-                  </a:solidFill>
-                  <a:latin typeface="EB Garamond SemiBold"/>
-                  <a:ea typeface="EB Garamond SemiBold"/>
-                  <a:cs typeface="EB Garamond SemiBold"/>
-                </a:rPr>
-                <a:t>Contributions</a:t>
-              </a:r>
-              <a:endParaRPr lang="en-US" sz="5141" b="0" i="0" kern="100" dirty="0">
-                <a:solidFill>
-                  <a:srgbClr val="18453B"/>
-                </a:solidFill>
-                <a:latin typeface="EB Garamond"/>
-                <a:ea typeface="EB Garamond"/>
-                <a:cs typeface="EB Garamond"/>
-              </a:endParaRPr>
-            </a:p>
-          </p:txBody>
-        </p:sp>
-        <p:sp>
-          <p:nvSpPr>
-            <p:cNvPr id="28" name="Bullets: (Threat) First backdoor attack on unlearning its"/>
-            <p:cNvSpPr txBox="1"/>
-            <p:nvPr/>
-          </p:nvSpPr>
-          <p:spPr>
-            <a:xfrm>
-              <a:off x="563265" y="22520060"/>
-              <a:ext cx="15266561" cy="2127118"/>
-            </a:xfrm>
-            <a:prstGeom prst="rect">
-              <a:avLst/>
-            </a:prstGeom>
-            <a:noFill/>
-          </p:spPr>
-          <p:txBody>
-            <a:bodyPr wrap="square" lIns="0" tIns="0" rIns="0" bIns="0" anchor="t" rtlCol="0">
-              <a:spAutoFit/>
-            </a:bodyPr>
-            <a:lstStyle/>
-            <a:p>
-              <a:pPr algn="l" marL="574152" indent="-574152">
-                <a:lnSpc>
-                  <a:spcPts val="4717"/>
-                </a:lnSpc>
-                <a:spcBef>
-                  <a:spcPts val="0"/>
-                </a:spcBef>
-                <a:spcAft>
-                  <a:spcPts val="0"/>
-                </a:spcAft>
-                <a:buClr>
-                  <a:srgbClr val="111111"/>
-                </a:buClr>
-                <a:buSzPct val="78000"/>
-                <a:buFont typeface="Wingdings" pitchFamily="2" charset="2"/>
-                <a:buChar char="v"/>
-              </a:pPr>
-              <a:r>
-                <a:rPr lang="en-US" sz="3931" b="1" i="0" kern="100" dirty="0">
-                  <a:solidFill>
-                    <a:srgbClr val="111111"/>
-                  </a:solidFill>
-                  <a:latin typeface="EB Garamond"/>
-                  <a:ea typeface="EB Garamond"/>
-                  <a:cs typeface="EB Garamond"/>
-                </a:rPr>
-                <a:t>(Threat)</a:t>
-              </a:r>
-              <a:r>
-                <a:rPr lang="en-US" sz="3931" b="0" i="0" kern="100" dirty="0">
-                  <a:solidFill>
-                    <a:srgbClr val="111111"/>
-                  </a:solidFill>
-                  <a:latin typeface="EB Garamond"/>
-                  <a:ea typeface="EB Garamond"/>
-                  <a:cs typeface="EB Garamond"/>
-                </a:rPr>
-                <a:t> First backdoor attack on </a:t>
-              </a:r>
-              <a:r>
-                <a:rPr lang="en-US" sz="3931" b="1" i="0" kern="100" dirty="0">
-                  <a:solidFill>
-                    <a:srgbClr val="111111"/>
-                  </a:solidFill>
-                  <a:latin typeface="EB Garamond"/>
-                  <a:ea typeface="EB Garamond"/>
-                  <a:cs typeface="EB Garamond"/>
-                </a:rPr>
-                <a:t>unlearning itself</a:t>
-              </a:r>
-              <a:r>
-                <a:rPr lang="en-US" sz="3931" b="0" i="0" kern="100" dirty="0">
-                  <a:solidFill>
-                    <a:srgbClr val="111111"/>
-                  </a:solidFill>
-                  <a:latin typeface="EB Garamond"/>
-                  <a:ea typeface="EB Garamond"/>
-                  <a:cs typeface="EB Garamond"/>
-                </a:rPr>
-                <a:t> (NPO</a:t>
-              </a:r>
-              <a:r>
-                <a:rPr lang="en-US" sz="3931" b="0" i="0" kern="100" dirty="0" baseline="30000">
-                  <a:solidFill>
-                    <a:srgbClr val="111111"/>
-                  </a:solidFill>
-                  <a:latin typeface="EB Garamond"/>
-                  <a:ea typeface="EB Garamond"/>
-                  <a:cs typeface="EB Garamond"/>
-                </a:rPr>
-                <a:t>[4]</a:t>
-              </a:r>
-              <a:r>
-                <a:rPr lang="en-US" sz="3931" b="0" i="0" kern="100" dirty="0">
-                  <a:solidFill>
-                    <a:srgbClr val="111111"/>
-                  </a:solidFill>
-                  <a:latin typeface="EB Garamond"/>
-                  <a:ea typeface="EB Garamond"/>
-                  <a:cs typeface="EB Garamond"/>
-                </a:rPr>
-                <a:t>, RMU</a:t>
-              </a:r>
-              <a:r>
-                <a:rPr lang="en-US" sz="3931" b="0" i="0" kern="100" dirty="0" baseline="30000">
-                  <a:solidFill>
-                    <a:srgbClr val="111111"/>
-                  </a:solidFill>
-                  <a:latin typeface="EB Garamond"/>
-                  <a:ea typeface="EB Garamond"/>
-                  <a:cs typeface="EB Garamond"/>
-                </a:rPr>
-                <a:t>[3]</a:t>
-              </a:r>
-              <a:r>
-                <a:rPr lang="en-US" sz="3931" b="0" i="0" kern="100" dirty="0">
-                  <a:solidFill>
-                    <a:srgbClr val="111111"/>
-                  </a:solidFill>
-                  <a:latin typeface="EB Garamond"/>
-                  <a:ea typeface="EB Garamond"/>
-                  <a:cs typeface="EB Garamond"/>
-                </a:rPr>
-                <a:t>).</a:t>
-              </a:r>
-              <a:endParaRPr lang="en-US" sz="3931" b="0" i="0" kern="100" dirty="0">
-                <a:solidFill>
-                  <a:srgbClr val="111111"/>
-                </a:solidFill>
-                <a:latin typeface="EB Garamond"/>
-                <a:ea typeface="EB Garamond"/>
-                <a:cs typeface="EB Garamond"/>
-              </a:endParaRPr>
-            </a:p>
-            <a:p>
-              <a:pPr algn="l" marL="574152" indent="-574152">
-                <a:lnSpc>
-                  <a:spcPts val="4717"/>
-                </a:lnSpc>
-                <a:spcBef>
-                  <a:spcPts val="907"/>
-                </a:spcBef>
-                <a:spcAft>
-                  <a:spcPts val="0"/>
-                </a:spcAft>
-                <a:buClr>
-                  <a:srgbClr val="111111"/>
-                </a:buClr>
-                <a:buSzPct val="78000"/>
-                <a:buFont typeface="Wingdings" pitchFamily="2" charset="2"/>
-                <a:buChar char="v"/>
-              </a:pPr>
-              <a:r>
-                <a:rPr lang="en-US" sz="3931" b="1" i="0" kern="100" dirty="0">
-                  <a:solidFill>
-                    <a:srgbClr val="111111"/>
-                  </a:solidFill>
-                  <a:latin typeface="EB Garamond"/>
-                  <a:ea typeface="EB Garamond"/>
-                  <a:cs typeface="EB Garamond"/>
-                </a:rPr>
-                <a:t>(Where)</a:t>
-              </a:r>
-              <a:r>
-                <a:rPr lang="en-US" sz="3931" b="0" i="0" kern="100" dirty="0">
-                  <a:solidFill>
-                    <a:srgbClr val="111111"/>
-                  </a:solidFill>
-                  <a:latin typeface="EB Garamond"/>
-                  <a:ea typeface="EB Garamond"/>
-                  <a:cs typeface="EB Garamond"/>
-                </a:rPr>
-                <a:t> </a:t>
-              </a:r>
-              <a:r>
-                <a:rPr lang="en-US" sz="3931" b="1" i="0" kern="100" dirty="0">
-                  <a:solidFill>
-                    <a:srgbClr val="18453B"/>
-                  </a:solidFill>
-                  <a:latin typeface="EB Garamond"/>
-                  <a:ea typeface="EB Garamond"/>
-                  <a:cs typeface="EB Garamond"/>
-                </a:rPr>
-                <a:t>Attention sinks</a:t>
-              </a:r>
-              <a:r>
-                <a:rPr lang="en-US" sz="3931" b="0" i="0" kern="100" dirty="0">
-                  <a:solidFill>
-                    <a:srgbClr val="111111"/>
-                  </a:solidFill>
-                  <a:latin typeface="EB Garamond"/>
-                  <a:ea typeface="EB Garamond"/>
-                  <a:cs typeface="EB Garamond"/>
-                </a:rPr>
-                <a:t> explain why only </a:t>
-              </a:r>
-              <a:r>
-                <a:rPr lang="en-US" sz="3931" b="1" i="0" kern="100" dirty="0">
-                  <a:solidFill>
-                    <a:srgbClr val="111111"/>
-                  </a:solidFill>
-                  <a:latin typeface="EB Garamond"/>
-                  <a:ea typeface="EB Garamond"/>
-                  <a:cs typeface="EB Garamond"/>
-                </a:rPr>
-                <a:t>prefix</a:t>
-              </a:r>
-              <a:r>
-                <a:rPr lang="en-US" sz="3931" b="0" i="0" kern="100" dirty="0">
-                  <a:solidFill>
-                    <a:srgbClr val="111111"/>
-                  </a:solidFill>
-                  <a:latin typeface="EB Garamond"/>
-                  <a:ea typeface="EB Garamond"/>
-                  <a:cs typeface="EB Garamond"/>
-                </a:rPr>
-                <a:t> triggers work.</a:t>
-              </a:r>
-              <a:endParaRPr lang="en-US" sz="3931" b="0" i="0" kern="100" dirty="0">
-                <a:solidFill>
-                  <a:srgbClr val="111111"/>
-                </a:solidFill>
-                <a:latin typeface="EB Garamond"/>
-                <a:ea typeface="EB Garamond"/>
-                <a:cs typeface="EB Garamond"/>
-              </a:endParaRPr>
-            </a:p>
-            <a:p>
-              <a:pPr algn="l" marL="574152" indent="-574152">
-                <a:lnSpc>
-                  <a:spcPts val="4717"/>
-                </a:lnSpc>
-                <a:spcBef>
-                  <a:spcPts val="907"/>
-                </a:spcBef>
-                <a:spcAft>
-                  <a:spcPts val="0"/>
-                </a:spcAft>
-                <a:buClr>
-                  <a:srgbClr val="111111"/>
-                </a:buClr>
-                <a:buSzPct val="78000"/>
-                <a:buFont typeface="Wingdings" pitchFamily="2" charset="2"/>
-                <a:buChar char="v"/>
-              </a:pPr>
-              <a:r>
-                <a:rPr lang="en-US" sz="3931" b="1" i="0" kern="100" dirty="0">
-                  <a:solidFill>
-                    <a:srgbClr val="111111"/>
-                  </a:solidFill>
-                  <a:latin typeface="EB Garamond"/>
-                  <a:ea typeface="EB Garamond"/>
-                  <a:cs typeface="EB Garamond"/>
-                </a:rPr>
-                <a:t>(How)</a:t>
-              </a:r>
-              <a:r>
-                <a:rPr lang="en-US" sz="3931" b="0" i="0" kern="100" dirty="0">
-                  <a:solidFill>
-                    <a:srgbClr val="111111"/>
-                  </a:solidFill>
-                  <a:latin typeface="EB Garamond"/>
-                  <a:ea typeface="EB Garamond"/>
-                  <a:cs typeface="EB Garamond"/>
-                </a:rPr>
-                <a:t> </a:t>
-              </a:r>
-              <a:r>
-                <a:rPr lang="en-US" sz="3931" b="1" i="0" kern="100" dirty="0">
-                  <a:solidFill>
-                    <a:srgbClr val="18453B"/>
-                  </a:solidFill>
-                  <a:latin typeface="EB Garamond"/>
-                  <a:ea typeface="EB Garamond"/>
-                  <a:cs typeface="EB Garamond"/>
-                </a:rPr>
-                <a:t>Value-norm alignment</a:t>
-              </a:r>
-              <a:r>
-                <a:rPr lang="en-US" sz="3931" b="0" i="0" kern="100" dirty="0">
-                  <a:solidFill>
-                    <a:srgbClr val="111111"/>
-                  </a:solidFill>
-                  <a:latin typeface="EB Garamond"/>
-                  <a:ea typeface="EB Garamond"/>
-                  <a:cs typeface="EB Garamond"/>
-                </a:rPr>
-                <a:t> improves both forgetting and recovery.</a:t>
-              </a:r>
-              <a:endParaRPr lang="en-US" sz="3931" b="0" i="0" kern="100" dirty="0">
-                <a:solidFill>
-                  <a:srgbClr val="111111"/>
-                </a:solidFill>
-                <a:latin typeface="EB Garamond"/>
-                <a:ea typeface="EB Garamond"/>
-                <a:cs typeface="EB Garamond"/>
-              </a:endParaRPr>
-            </a:p>
-          </p:txBody>
-        </p:sp>
-      </p:grpSp>
-      <p:grpSp>
-        <p:nvGrpSpPr>
-          <p:cNvPr id="70" name="Section: Where to Place the Trigger? Attention Sinks"/>
-          <p:cNvGrpSpPr/>
-          <p:nvPr/>
-        </p:nvGrpSpPr>
-        <p:grpSpPr>
-          <a:xfrm>
-            <a:off x="16302038" y="4173207"/>
-            <a:ext cx="16843823" cy="6431591"/>
-            <a:chOff x="16302038" y="4173207"/>
-            <a:chExt cx="16843823" cy="6431591"/>
+            <a:off x="16285345" y="4173207"/>
+            <a:ext cx="16860516" cy="16382371"/>
+            <a:chOff x="16285345" y="4173207"/>
+            <a:chExt cx="16860516" cy="16382371"/>
           </a:xfrm>
         </p:grpSpPr>
         <p:sp>
@@ -6510,14 +6233,14 @@
           <mc:Choice Requires="a14">
             <p:sp>
               <p:nvSpPr>
-                <p:cNvPr id="30" name="Bullets: Attention sink[1]: LLMs over-attend the first to"/>
+                <p:cNvPr id="30" name="Bullets: Attention sink[1]: LLMs over-attend the first … "/>
                 <p:cNvSpPr txBox="1"/>
                 <p:nvPr/>
               </p:nvSpPr>
               <p:spPr>
                 <a:xfrm>
-                  <a:off x="16302038" y="5382733"/>
-                  <a:ext cx="7285788" cy="3809041"/>
+                  <a:off x="16302038" y="5031879"/>
+                  <a:ext cx="16843823" cy="1297732"/>
                 </a:xfrm>
                 <a:prstGeom prst="rect">
                   <a:avLst/>
@@ -6578,201 +6301,7 @@
                       <a:ea typeface="EB Garamond"/>
                       <a:cs typeface="EB Garamond"/>
                     </a:rPr>
-                    <a:t>: LLMs over-attend the first tokens </a:t>
-                  </a:r>
-                  <a14:m>
-                    <m:oMath xmlns:m="http://schemas.openxmlformats.org/officeDocument/2006/math">
-                      <m:r>
-                        <m:rPr>
-                          <m:scr m:val="script"/>
-                          <m:sty m:val="p"/>
-                        </m:rPr>
-                        <a:rPr lang="en-US" sz="3931" b="0" i="0">
-                          <a:solidFill>
-                            <a:srgbClr val="111111"/>
-                          </a:solidFill>
-                          <a:latin typeface="Cambria Math" panose="02040503050406030204" pitchFamily="18" charset="0"/>
-                          <a:ea typeface="Cambria Math"/>
-                          <a:cs typeface="Cambria Math"/>
-                        </a:rPr>
-                        <m:t>S</m:t>
-                      </m:r>
-                      <m:r>
-                        <m:rPr>
-                          <m:sty m:val="p"/>
-                        </m:rPr>
-                        <a:rPr lang="en-US" sz="3931" b="0" i="0">
-                          <a:solidFill>
-                            <a:srgbClr val="111111"/>
-                          </a:solidFill>
-                          <a:latin typeface="Cambria Math" panose="02040503050406030204" pitchFamily="18" charset="0"/>
-                          <a:ea typeface="Cambria Math"/>
-                          <a:cs typeface="Cambria Math"/>
-                        </a:rPr>
-                        <m:t>=</m:t>
-                      </m:r>
-                      <m:r>
-                        <m:rPr>
-                          <m:sty m:val="p"/>
-                        </m:rPr>
-                        <a:rPr lang="en-US" sz="3931" b="0" i="0">
-                          <a:solidFill>
-                            <a:srgbClr val="111111"/>
-                          </a:solidFill>
-                          <a:latin typeface="Cambria Math" panose="02040503050406030204" pitchFamily="18" charset="0"/>
-                          <a:ea typeface="Cambria Math"/>
-                          <a:cs typeface="Cambria Math"/>
-                        </a:rPr>
-                        <m:t>{</m:t>
-                      </m:r>
-                      <m:sSub>
-                        <m:sSubPr>
-                          <m:ctrlPr>
-                            <a:rPr lang="en-US" sz="3931" b="0" i="1">
-                              <a:solidFill>
-                                <a:srgbClr val="111111"/>
-                              </a:solidFill>
-                              <a:latin typeface="Cambria Math" panose="02040503050406030204" pitchFamily="18" charset="0"/>
-                              <a:ea typeface="Cambria Math"/>
-                              <a:cs typeface="Cambria Math"/>
-                            </a:rPr>
-                          </m:ctrlPr>
-                        </m:sSubPr>
-                        <m:e>
-                          <m:r>
-                            <a:rPr lang="en-US" sz="3931" b="0" i="1">
-                              <a:solidFill>
-                                <a:srgbClr val="111111"/>
-                              </a:solidFill>
-                              <a:latin typeface="Cambria Math" panose="02040503050406030204" pitchFamily="18" charset="0"/>
-                              <a:ea typeface="Cambria Math"/>
-                              <a:cs typeface="Cambria Math"/>
-                            </a:rPr>
-                            <m:t>x</m:t>
-                          </m:r>
-                        </m:e>
-                        <m:sub>
-                          <m:r>
-                            <a:rPr lang="en-US" sz="3931" b="0" i="1">
-                              <a:solidFill>
-                                <a:srgbClr val="111111"/>
-                              </a:solidFill>
-                              <a:latin typeface="Cambria Math" panose="02040503050406030204" pitchFamily="18" charset="0"/>
-                              <a:ea typeface="Cambria Math"/>
-                              <a:cs typeface="Cambria Math"/>
-                            </a:rPr>
-                            <m:t>1</m:t>
-                          </m:r>
-                        </m:sub>
-                      </m:sSub>
-                      <m:r>
-                        <m:rPr>
-                          <m:sty m:val="p"/>
-                        </m:rPr>
-                        <a:rPr lang="en-US" sz="3931" b="0" i="0">
-                          <a:solidFill>
-                            <a:srgbClr val="111111"/>
-                          </a:solidFill>
-                          <a:latin typeface="Cambria Math" panose="02040503050406030204" pitchFamily="18" charset="0"/>
-                          <a:ea typeface="Cambria Math"/>
-                          <a:cs typeface="Cambria Math"/>
-                        </a:rPr>
-                        <m:t>,</m:t>
-                      </m:r>
-                      <m:r>
-                        <m:rPr>
-                          <m:sty m:val="p"/>
-                        </m:rPr>
-                        <a:rPr lang="en-US" sz="3931" b="0" i="0">
-                          <a:solidFill>
-                            <a:srgbClr val="111111"/>
-                          </a:solidFill>
-                          <a:latin typeface="Cambria Math" panose="02040503050406030204" pitchFamily="18" charset="0"/>
-                          <a:ea typeface="Cambria Math"/>
-                          <a:cs typeface="Cambria Math"/>
-                        </a:rPr>
-                        <m:t>…</m:t>
-                      </m:r>
-                      <m:r>
-                        <m:rPr>
-                          <m:sty m:val="p"/>
-                        </m:rPr>
-                        <a:rPr lang="en-US" sz="3931" b="0" i="0">
-                          <a:solidFill>
-                            <a:srgbClr val="111111"/>
-                          </a:solidFill>
-                          <a:latin typeface="Cambria Math" panose="02040503050406030204" pitchFamily="18" charset="0"/>
-                          <a:ea typeface="Cambria Math"/>
-                          <a:cs typeface="Cambria Math"/>
-                        </a:rPr>
-                        <m:t>,</m:t>
-                      </m:r>
-                      <m:sSub>
-                        <m:sSubPr>
-                          <m:ctrlPr>
-                            <a:rPr lang="en-US" sz="3931" b="0" i="1">
-                              <a:solidFill>
-                                <a:srgbClr val="111111"/>
-                              </a:solidFill>
-                              <a:latin typeface="Cambria Math" panose="02040503050406030204" pitchFamily="18" charset="0"/>
-                              <a:ea typeface="Cambria Math"/>
-                              <a:cs typeface="Cambria Math"/>
-                            </a:rPr>
-                          </m:ctrlPr>
-                        </m:sSubPr>
-                        <m:e>
-                          <m:r>
-                            <a:rPr lang="en-US" sz="3931" b="0" i="1">
-                              <a:solidFill>
-                                <a:srgbClr val="111111"/>
-                              </a:solidFill>
-                              <a:latin typeface="Cambria Math" panose="02040503050406030204" pitchFamily="18" charset="0"/>
-                              <a:ea typeface="Cambria Math"/>
-                              <a:cs typeface="Cambria Math"/>
-                            </a:rPr>
-                            <m:t>x</m:t>
-                          </m:r>
-                        </m:e>
-                        <m:sub>
-                          <m:r>
-                            <a:rPr lang="en-US" sz="3931" b="0" i="1">
-                              <a:solidFill>
-                                <a:srgbClr val="111111"/>
-                              </a:solidFill>
-                              <a:latin typeface="Cambria Math" panose="02040503050406030204" pitchFamily="18" charset="0"/>
-                              <a:ea typeface="Cambria Math"/>
-                              <a:cs typeface="Cambria Math"/>
-                            </a:rPr>
-                            <m:t>k</m:t>
-                          </m:r>
-                        </m:sub>
-                      </m:sSub>
-                      <m:r>
-                        <m:rPr>
-                          <m:sty m:val="p"/>
-                        </m:rPr>
-                        <a:rPr lang="en-US" sz="3931" b="0" i="0">
-                          <a:solidFill>
-                            <a:srgbClr val="111111"/>
-                          </a:solidFill>
-                          <a:latin typeface="Cambria Math" panose="02040503050406030204" pitchFamily="18" charset="0"/>
-                          <a:ea typeface="Cambria Math"/>
-                          <a:cs typeface="Cambria Math"/>
-                        </a:rPr>
-                        <m:t>}</m:t>
-                      </m:r>
-                    </m:oMath>
-                  </a14:m>
-                  <a:r>
-                    <a:rPr lang="en-US" sz="3931" b="0" i="0" kern="100" dirty="0">
-                      <a:solidFill>
-                        <a:srgbClr val="111111"/>
-                      </a:solidFill>
-                      <a:latin typeface="EB Garamond"/>
-                      <a:ea typeface="EB Garamond"/>
-                      <a:cs typeface="EB Garamond"/>
-                    </a:rPr>
-                    <a:t> (</a:t>
+                    <a:t>: LLMs over-attend the first </a:t>
                   </a:r>
                   <a14:m>
                     <m:oMath xmlns:m="http://schemas.openxmlformats.org/officeDocument/2006/math">
@@ -6823,45 +6352,7 @@
                       <a:ea typeface="EB Garamond"/>
                       <a:cs typeface="EB Garamond"/>
                     </a:rPr>
-                    <a:t>).</a:t>
-                  </a:r>
-                  <a:endParaRPr lang="en-US" sz="3931" b="0" i="0" kern="100" dirty="0">
-                    <a:solidFill>
-                      <a:srgbClr val="111111"/>
-                    </a:solidFill>
-                    <a:latin typeface="EB Garamond"/>
-                    <a:ea typeface="EB Garamond"/>
-                    <a:cs typeface="EB Garamond"/>
-                  </a:endParaRPr>
-                </a:p>
-                <a:p>
-                  <a:pPr algn="l" marL="574152" indent="-574152">
-                    <a:lnSpc>
-                      <a:spcPts val="4717"/>
-                    </a:lnSpc>
-                    <a:spcBef>
-                      <a:spcPts val="907"/>
-                    </a:spcBef>
-                    <a:spcAft>
-                      <a:spcPts val="0"/>
-                    </a:spcAft>
-                    <a:buClr>
-                      <a:srgbClr val="111111"/>
-                    </a:buClr>
-                    <a:buSzPct val="78000"/>
-                    <a:buFont typeface="Wingdings" pitchFamily="2" charset="2"/>
-                    <a:buChar char="v"/>
-                  </a:pPr>
-                  <a:r>
-                    <a:rPr lang="en-US" sz="3931" b="0" i="0" kern="100" dirty="0">
-                      <a:solidFill>
-                        <a:srgbClr val="111111"/>
-                      </a:solidFill>
-                      <a:latin typeface="EB Garamond"/>
-                      <a:ea typeface="EB Garamond"/>
-                      <a:cs typeface="EB Garamond"/>
-                    </a:rPr>
-                    <a:t>Only a </a:t>
+                    <a:t> tokens; a </a:t>
                   </a:r>
                   <a:r>
                     <a:rPr lang="en-US" sz="3931" b="1" i="0" kern="100" dirty="0">
@@ -6883,7 +6374,7 @@
                       <a:ea typeface="EB Garamond"/>
                       <a:cs typeface="EB Garamond"/>
                     </a:rPr>
-                    <a:t> trigger lands in the sink and comes closest to the desired zone (Fig. 2).</a:t>
+                    <a:t> trigger sits inside it.</a:t>
                   </a:r>
                   <a:endParaRPr lang="en-US" sz="3931" b="0" i="0" kern="100" dirty="0">
                     <a:solidFill>
@@ -6900,7 +6391,7 @@
           <mc:Fallback>
             <p:sp>
               <p:nvSpPr>
-                <p:cNvPr id="30" name="Bullets: Attention sink[1]: LLMs over-attend the first to"/>
+                <p:cNvPr id="30" name="Bullets: Attention sink[1]: LLMs over-attend the first … "/>
                 <p:cNvSpPr txBox="1">
                   <a:spLocks noRot="1" noChangeAspect="1" noMove="1" noResize="1" noEditPoints="1" noAdjustHandles="1" noChangeArrowheads="1" noChangeShapeType="1" noTextEdit="1"/>
                 </p:cNvSpPr>
@@ -6908,14 +6399,14 @@
               </p:nvSpPr>
               <p:spPr>
                 <a:xfrm>
-                  <a:off x="16302038" y="5382733"/>
-                  <a:ext cx="7199395" cy="3809041"/>
+                  <a:off x="16302038" y="5031879"/>
+                  <a:ext cx="16644094" cy="1297732"/>
                 </a:xfrm>
                 <a:prstGeom prst="rect">
                   <a:avLst/>
                 </a:prstGeom>
                 <a:blipFill>
-                  <a:blip r:embed="rId26"/>
+                  <a:blip r:embed="rId28"/>
                   <a:stretch>
                     <a:fillRect/>
                   </a:stretch>
@@ -6938,17 +6429,17 @@
         </mc:AlternateContent>
         <p:pic>
           <p:nvPicPr>
-            <p:cNvPr id="31" name="Picture: motivation" descr="UE on D_f versus BE on D_p for prefix, infix, suffix triggers"/>
+            <p:cNvPr id="31" name="Picture: preunlearned_L31_averaged_difference_attention_prefix" descr="Attention difference map, original model, prefix trigger"/>
             <p:cNvPicPr>
               <a:picLocks noChangeAspect="1"/>
             </p:cNvPicPr>
             <p:nvPr/>
           </p:nvPicPr>
           <p:blipFill>
-            <a:blip r:embed="rId27">
+            <a:blip r:embed="rId29">
               <a:extLst>
                 <a:ext uri="{96DAC541-7B7A-43D3-8B79-37D633B846F1}">
-                  <asvg:svgBlip xmlns:asvg="http://schemas.microsoft.com/office/drawing/2016/SVG/main" r:embed="rId28"/>
+                  <asvg:svgBlip xmlns:asvg="http://schemas.microsoft.com/office/drawing/2016/SVG/main" r:embed="rId30"/>
                 </a:ext>
               </a:extLst>
             </a:blip>
@@ -6958,337 +6449,8 @@
           </p:blipFill>
           <p:spPr>
             <a:xfrm>
-              <a:off x="23783065" y="5031879"/>
-              <a:ext cx="9163067" cy="4510749"/>
-            </a:xfrm>
-            <a:prstGeom prst="rect">
-              <a:avLst/>
-            </a:prstGeom>
-          </p:spPr>
-        </p:pic>
-        <mc:AlternateContent xmlns:mc="http://schemas.openxmlformats.org/markup-compatibility/2006" xmlns:a14="http://schemas.microsoft.com/office/drawing/2010/main">
-          <mc:Choice Requires="a14">
-            <p:sp>
-              <p:nvSpPr>
-                <p:cNvPr id="32" name="Caption: Figure 2. Forgetting (UE on …, ↓) vs. recovery ("/>
-                <p:cNvSpPr txBox="1"/>
-                <p:nvPr/>
-              </p:nvSpPr>
-              <p:spPr>
-                <a:xfrm>
-                  <a:off x="16302038" y="9696235"/>
-                  <a:ext cx="16843823" cy="908563"/>
-                </a:xfrm>
-                <a:prstGeom prst="rect">
-                  <a:avLst/>
-                </a:prstGeom>
-                <a:noFill/>
-              </p:spPr>
-              <p:txBody>
-                <a:bodyPr wrap="square" lIns="0" tIns="0" rIns="0" bIns="0" anchor="t" rtlCol="0">
-                  <a:spAutoFit/>
-                </a:bodyPr>
-                <a:lstStyle/>
-                <a:p>
-                  <a:pPr algn="just" marL="0" indent="0">
-                    <a:lnSpc>
-                      <a:spcPts val="3568"/>
-                    </a:lnSpc>
-                    <a:spcBef>
-                      <a:spcPts val="0"/>
-                    </a:spcBef>
-                    <a:spcAft>
-                      <a:spcPts val="0"/>
-                    </a:spcAft>
-                    <a:buNone/>
-                  </a:pPr>
-                  <a:r>
-                    <a:rPr lang="en-US" sz="3024" b="1" i="0" kern="100" dirty="0">
-                      <a:solidFill>
-                        <a:srgbClr val="18453B"/>
-                      </a:solidFill>
-                      <a:latin typeface="EB Garamond"/>
-                      <a:ea typeface="EB Garamond"/>
-                      <a:cs typeface="EB Garamond"/>
-                    </a:rPr>
-                    <a:t>Figure 2.</a:t>
-                  </a:r>
-                  <a:r>
-                    <a:rPr lang="en-US" sz="3024" b="0" i="0" kern="100" dirty="0">
-                      <a:solidFill>
-                        <a:srgbClr val="111111"/>
-                      </a:solidFill>
-                      <a:latin typeface="EB Garamond"/>
-                      <a:ea typeface="EB Garamond"/>
-                      <a:cs typeface="EB Garamond"/>
-                    </a:rPr>
-                    <a:t> Forgetting (UE on </a:t>
-                  </a:r>
-                  <a14:m>
-                    <m:oMath xmlns:m="http://schemas.openxmlformats.org/officeDocument/2006/math">
-                      <m:sSub>
-                        <m:sSubPr>
-                          <m:ctrlPr>
-                            <a:rPr lang="en-US" sz="3024" b="0" i="1">
-                              <a:solidFill>
-                                <a:srgbClr val="111111"/>
-                              </a:solidFill>
-                              <a:latin typeface="Cambria Math" panose="02040503050406030204" pitchFamily="18" charset="0"/>
-                              <a:ea typeface="Cambria Math"/>
-                              <a:cs typeface="Cambria Math"/>
-                            </a:rPr>
-                          </m:ctrlPr>
-                        </m:sSubPr>
-                        <m:e>
-                          <m:r>
-                            <m:rPr>
-                              <m:scr m:val="script"/>
-                              <m:sty m:val="p"/>
-                            </m:rPr>
-                            <a:rPr lang="en-US" sz="3024" b="0" i="0">
-                              <a:solidFill>
-                                <a:srgbClr val="111111"/>
-                              </a:solidFill>
-                              <a:latin typeface="Cambria Math" panose="02040503050406030204" pitchFamily="18" charset="0"/>
-                              <a:ea typeface="Cambria Math"/>
-                              <a:cs typeface="Cambria Math"/>
-                            </a:rPr>
-                            <m:t>D</m:t>
-                          </m:r>
-                        </m:e>
-                        <m:sub>
-                          <m:r>
-                            <m:rPr>
-                              <m:sty m:val="p"/>
-                            </m:rPr>
-                            <a:rPr lang="en-US" sz="3024" b="0" i="0">
-                              <a:solidFill>
-                                <a:srgbClr val="111111"/>
-                              </a:solidFill>
-                              <a:latin typeface="Cambria Math" panose="02040503050406030204" pitchFamily="18" charset="0"/>
-                              <a:ea typeface="Cambria Math"/>
-                              <a:cs typeface="Cambria Math"/>
-                            </a:rPr>
-                            <m:t>f</m:t>
-                          </m:r>
-                        </m:sub>
-                      </m:sSub>
-                    </m:oMath>
-                  </a14:m>
-                  <a:r>
-                    <a:rPr lang="en-US" sz="3024" b="0" i="0" kern="100" dirty="0">
-                      <a:solidFill>
-                        <a:srgbClr val="111111"/>
-                      </a:solidFill>
-                      <a:latin typeface="EB Garamond"/>
-                      <a:ea typeface="EB Garamond"/>
-                      <a:cs typeface="EB Garamond"/>
-                    </a:rPr>
-                    <a:t>, ↓) vs. recovery (BE on </a:t>
-                  </a:r>
-                  <a14:m>
-                    <m:oMath xmlns:m="http://schemas.openxmlformats.org/officeDocument/2006/math">
-                      <m:sSub>
-                        <m:sSubPr>
-                          <m:ctrlPr>
-                            <a:rPr lang="en-US" sz="3024" b="0" i="1">
-                              <a:solidFill>
-                                <a:srgbClr val="111111"/>
-                              </a:solidFill>
-                              <a:latin typeface="Cambria Math" panose="02040503050406030204" pitchFamily="18" charset="0"/>
-                              <a:ea typeface="Cambria Math"/>
-                              <a:cs typeface="Cambria Math"/>
-                            </a:rPr>
-                          </m:ctrlPr>
-                        </m:sSubPr>
-                        <m:e>
-                          <m:r>
-                            <m:rPr>
-                              <m:scr m:val="script"/>
-                              <m:sty m:val="p"/>
-                            </m:rPr>
-                            <a:rPr lang="en-US" sz="3024" b="0" i="0">
-                              <a:solidFill>
-                                <a:srgbClr val="111111"/>
-                              </a:solidFill>
-                              <a:latin typeface="Cambria Math" panose="02040503050406030204" pitchFamily="18" charset="0"/>
-                              <a:ea typeface="Cambria Math"/>
-                              <a:cs typeface="Cambria Math"/>
-                            </a:rPr>
-                            <m:t>D</m:t>
-                          </m:r>
-                        </m:e>
-                        <m:sub>
-                          <m:r>
-                            <m:rPr>
-                              <m:sty m:val="p"/>
-                            </m:rPr>
-                            <a:rPr lang="en-US" sz="3024" b="0" i="0">
-                              <a:solidFill>
-                                <a:srgbClr val="111111"/>
-                              </a:solidFill>
-                              <a:latin typeface="Cambria Math" panose="02040503050406030204" pitchFamily="18" charset="0"/>
-                              <a:ea typeface="Cambria Math"/>
-                              <a:cs typeface="Cambria Math"/>
-                            </a:rPr>
-                            <m:t>p</m:t>
-                          </m:r>
-                        </m:sub>
-                      </m:sSub>
-                    </m:oMath>
-                  </a14:m>
-                  <a:r>
-                    <a:rPr lang="en-US" sz="3024" b="0" i="0" kern="100" dirty="0">
-                      <a:solidFill>
-                        <a:srgbClr val="111111"/>
-                      </a:solidFill>
-                      <a:latin typeface="EB Garamond"/>
-                      <a:ea typeface="EB Garamond"/>
-                      <a:cs typeface="EB Garamond"/>
-                    </a:rPr>
-                    <a:t>, ↑) by trigger position (MUSE-Books, ICLM-7B, NPO, </a:t>
-                  </a:r>
-                  <a14:m>
-                    <m:oMath xmlns:m="http://schemas.openxmlformats.org/officeDocument/2006/math">
-                      <m:r>
-                        <a:rPr lang="en-US" sz="3024" b="0" i="1">
-                          <a:solidFill>
-                            <a:srgbClr val="111111"/>
-                          </a:solidFill>
-                          <a:latin typeface="Cambria Math" panose="02040503050406030204" pitchFamily="18" charset="0"/>
-                          <a:ea typeface="Cambria Math"/>
-                          <a:cs typeface="Cambria Math"/>
-                        </a:rPr>
-                        <m:t>ρ</m:t>
-                      </m:r>
-                      <m:r>
-                        <m:rPr>
-                          <m:sty m:val="p"/>
-                        </m:rPr>
-                        <a:rPr lang="en-US" sz="3024" b="0" i="0">
-                          <a:solidFill>
-                            <a:srgbClr val="111111"/>
-                          </a:solidFill>
-                          <a:latin typeface="Cambria Math" panose="02040503050406030204" pitchFamily="18" charset="0"/>
-                          <a:ea typeface="Cambria Math"/>
-                          <a:cs typeface="Cambria Math"/>
-                        </a:rPr>
-                        <m:t>=</m:t>
-                      </m:r>
-                      <m:r>
-                        <a:rPr lang="en-US" sz="3024" b="0" i="1">
-                          <a:solidFill>
-                            <a:srgbClr val="111111"/>
-                          </a:solidFill>
-                          <a:latin typeface="Cambria Math" panose="02040503050406030204" pitchFamily="18" charset="0"/>
-                          <a:ea typeface="Cambria Math"/>
-                          <a:cs typeface="Cambria Math"/>
-                        </a:rPr>
-                        <m:t>0.1</m:t>
-                      </m:r>
-                    </m:oMath>
-                  </a14:m>
-                  <a:r>
-                    <a:rPr lang="en-US" sz="3024" b="0" i="0" kern="100" dirty="0">
-                      <a:solidFill>
-                        <a:srgbClr val="111111"/>
-                      </a:solidFill>
-                      <a:latin typeface="EB Garamond"/>
-                      <a:ea typeface="EB Garamond"/>
-                      <a:cs typeface="EB Garamond"/>
-                    </a:rPr>
-                    <a:t>).</a:t>
-                  </a:r>
-                  <a:endParaRPr lang="en-US" sz="3024" b="0" i="0" kern="100" dirty="0">
-                    <a:solidFill>
-                      <a:srgbClr val="111111"/>
-                    </a:solidFill>
-                    <a:latin typeface="EB Garamond"/>
-                    <a:ea typeface="EB Garamond"/>
-                    <a:cs typeface="EB Garamond"/>
-                  </a:endParaRPr>
-                </a:p>
-              </p:txBody>
-            </p:sp>
-          </mc:Choice>
-          <mc:Fallback>
-            <p:sp>
-              <p:nvSpPr>
-                <p:cNvPr id="32" name="Caption: Figure 2. Forgetting (UE on …, ↓) vs. recovery ("/>
-                <p:cNvSpPr txBox="1">
-                  <a:spLocks noRot="1" noChangeAspect="1" noMove="1" noResize="1" noEditPoints="1" noAdjustHandles="1" noChangeArrowheads="1" noChangeShapeType="1" noTextEdit="1"/>
-                </p:cNvSpPr>
-                <p:nvPr/>
-              </p:nvSpPr>
-              <p:spPr>
-                <a:xfrm>
-                  <a:off x="16302038" y="9696235"/>
-                  <a:ext cx="16644094" cy="908563"/>
-                </a:xfrm>
-                <a:prstGeom prst="rect">
-                  <a:avLst/>
-                </a:prstGeom>
-                <a:blipFill>
-                  <a:blip r:embed="rId29"/>
-                  <a:stretch>
-                    <a:fillRect/>
-                  </a:stretch>
-                </a:blipFill>
-              </p:spPr>
-              <p:txBody>
-                <a:bodyPr/>
-                <a:lstStyle/>
-                <a:p>
-                  <a:r>
-                    <a:rPr lang="en-US">
-                      <a:noFill/>
-                    </a:rPr>
-                    <a:t> </a:t>
-                  </a:r>
-                </a:p>
-              </p:txBody>
-            </p:sp>
-          </mc:Fallback>
-        </mc:AlternateContent>
-      </p:grpSp>
-      <p:grpSp>
-        <p:nvGrpSpPr>
-          <p:cNvPr id="71" name="Section: Figure 3"/>
-          <p:cNvGrpSpPr/>
-          <p:nvPr/>
-        </p:nvGrpSpPr>
-        <p:grpSpPr>
-          <a:xfrm>
-            <a:off x="16290015" y="11006005"/>
-            <a:ext cx="16855846" cy="8598991"/>
-            <a:chOff x="16290015" y="11006005"/>
-            <a:chExt cx="16855846" cy="8598991"/>
-          </a:xfrm>
-        </p:grpSpPr>
-        <p:pic>
-          <p:nvPicPr>
-            <p:cNvPr id="33" name="Picture: preunlearned_L31_averaged_difference_attention_prefix" descr="Attention difference map, original model, prefix trigger"/>
-            <p:cNvPicPr>
-              <a:picLocks noChangeAspect="1"/>
-            </p:cNvPicPr>
-            <p:nvPr/>
-          </p:nvPicPr>
-          <p:blipFill>
-            <a:blip r:embed="rId30">
-              <a:extLst>
-                <a:ext uri="{96DAC541-7B7A-43D3-8B79-37D633B846F1}">
-                  <asvg:svgBlip xmlns:asvg="http://schemas.microsoft.com/office/drawing/2016/SVG/main" r:embed="rId31"/>
-                </a:ext>
-              </a:extLst>
-            </a:blip>
-            <a:stretch>
-              <a:fillRect/>
-            </a:stretch>
-          </p:blipFill>
-          <p:spPr>
-            <a:xfrm>
-              <a:off x="16302038" y="11006005"/>
-              <a:ext cx="4007445" cy="4172396"/>
+              <a:off x="16302038" y="6483333"/>
+              <a:ext cx="5564237" cy="5793317"/>
             </a:xfrm>
             <a:prstGeom prst="rect">
               <a:avLst/>
@@ -7297,14 +6459,14 @@
         </p:pic>
         <p:sp>
           <p:nvSpPr>
-            <p:cNvPr id="34" name="Panel label: (a) Original model"/>
+            <p:cNvPr id="32" name="Panel label: (a) Original model"/>
             <p:cNvSpPr txBox="1"/>
             <p:nvPr/>
           </p:nvSpPr>
           <p:spPr>
             <a:xfrm>
-              <a:off x="16290015" y="15229565"/>
-              <a:ext cx="4031490" cy="422391"/>
+              <a:off x="16285345" y="12327814"/>
+              <a:ext cx="5597623" cy="422391"/>
             </a:xfrm>
             <a:prstGeom prst="rect">
               <a:avLst/>
@@ -7353,17 +6515,17 @@
         </p:sp>
         <p:pic>
           <p:nvPicPr>
-            <p:cNvPr id="35" name="Picture: backdoored_L31_averaged_difference_attention_prefix" descr="Attention difference map, backdoored model, prefix trigger"/>
+            <p:cNvPr id="33" name="Picture: backdoored_L31_averaged_difference_attention_prefix" descr="Attention difference map, backdoored model, prefix trigger"/>
             <p:cNvPicPr>
               <a:picLocks noChangeAspect="1"/>
             </p:cNvPicPr>
             <p:nvPr/>
           </p:nvPicPr>
           <p:blipFill>
-            <a:blip r:embed="rId32">
+            <a:blip r:embed="rId31">
               <a:extLst>
                 <a:ext uri="{96DAC541-7B7A-43D3-8B79-37D633B846F1}">
-                  <asvg:svgBlip xmlns:asvg="http://schemas.microsoft.com/office/drawing/2016/SVG/main" r:embed="rId33"/>
+                  <asvg:svgBlip xmlns:asvg="http://schemas.microsoft.com/office/drawing/2016/SVG/main" r:embed="rId32"/>
                 </a:ext>
               </a:extLst>
             </a:blip>
@@ -7373,8 +6535,8 @@
           </p:blipFill>
           <p:spPr>
             <a:xfrm>
-              <a:off x="20514254" y="11006005"/>
-              <a:ext cx="4007445" cy="4172396"/>
+              <a:off x="22173489" y="6483218"/>
+              <a:ext cx="5564353" cy="5793432"/>
             </a:xfrm>
             <a:prstGeom prst="rect">
               <a:avLst/>
@@ -7383,14 +6545,14 @@
         </p:pic>
         <p:sp>
           <p:nvSpPr>
-            <p:cNvPr id="36" name="Panel label: (b) Backdoored model"/>
+            <p:cNvPr id="34" name="Panel label: (b) Backdoored model"/>
             <p:cNvSpPr txBox="1"/>
             <p:nvPr/>
           </p:nvSpPr>
           <p:spPr>
             <a:xfrm>
-              <a:off x="20502231" y="15229565"/>
-              <a:ext cx="4031490" cy="422391"/>
+              <a:off x="22156796" y="12327814"/>
+              <a:ext cx="5597739" cy="422391"/>
             </a:xfrm>
             <a:prstGeom prst="rect">
               <a:avLst/>
@@ -7439,17 +6601,17 @@
         </p:sp>
         <p:pic>
           <p:nvPicPr>
-            <p:cNvPr id="37" name="Picture: backdoor_logits_prefix" descr="Top-1 probability, backdoored model, prefix trigger"/>
+            <p:cNvPr id="35" name="Picture: standalone_cbar" descr="Color scale from -0.015 to 0.015"/>
             <p:cNvPicPr>
               <a:picLocks noChangeAspect="1"/>
             </p:cNvPicPr>
             <p:nvPr/>
           </p:nvPicPr>
           <p:blipFill>
-            <a:blip r:embed="rId34">
+            <a:blip r:embed="rId33">
               <a:extLst>
                 <a:ext uri="{96DAC541-7B7A-43D3-8B79-37D633B846F1}">
-                  <asvg:svgBlip xmlns:asvg="http://schemas.microsoft.com/office/drawing/2016/SVG/main" r:embed="rId35"/>
+                  <asvg:svgBlip xmlns:asvg="http://schemas.microsoft.com/office/drawing/2016/SVG/main" r:embed="rId34"/>
                 </a:ext>
               </a:extLst>
             </a:blip>
@@ -7459,8 +6621,38 @@
           </p:blipFill>
           <p:spPr>
             <a:xfrm>
-              <a:off x="24726470" y="11353850"/>
-              <a:ext cx="4007445" cy="3824552"/>
+              <a:off x="16302038" y="12878114"/>
+              <a:ext cx="11435804" cy="705644"/>
+            </a:xfrm>
+            <a:prstGeom prst="rect">
+              <a:avLst/>
+            </a:prstGeom>
+          </p:spPr>
+        </p:pic>
+        <p:pic>
+          <p:nvPicPr>
+            <p:cNvPr id="36" name="Picture: backdoor_logits_prefix" descr="Top-1 probability, backdoored model, prefix trigger"/>
+            <p:cNvPicPr>
+              <a:picLocks noChangeAspect="1"/>
+            </p:cNvPicPr>
+            <p:nvPr/>
+          </p:nvPicPr>
+          <p:blipFill>
+            <a:blip r:embed="rId35">
+              <a:extLst>
+                <a:ext uri="{96DAC541-7B7A-43D3-8B79-37D633B846F1}">
+                  <asvg:svgBlip xmlns:asvg="http://schemas.microsoft.com/office/drawing/2016/SVG/main" r:embed="rId36"/>
+                </a:ext>
+              </a:extLst>
+            </a:blip>
+            <a:stretch>
+              <a:fillRect/>
+            </a:stretch>
+          </p:blipFill>
+          <p:spPr>
+            <a:xfrm>
+              <a:off x="16302038" y="13711783"/>
+              <a:ext cx="5564237" cy="5310270"/>
             </a:xfrm>
             <a:prstGeom prst="rect">
               <a:avLst/>
@@ -7469,14 +6661,14 @@
         </p:pic>
         <p:sp>
           <p:nvSpPr>
-            <p:cNvPr id="38" name="Panel label: (c) Prefix trigger"/>
+            <p:cNvPr id="37" name="Panel label: (c) Prefix trigger"/>
             <p:cNvSpPr txBox="1"/>
             <p:nvPr/>
           </p:nvSpPr>
           <p:spPr>
             <a:xfrm>
-              <a:off x="24714448" y="15229565"/>
-              <a:ext cx="4031490" cy="422391"/>
+              <a:off x="16285345" y="19073217"/>
+              <a:ext cx="5597623" cy="422391"/>
             </a:xfrm>
             <a:prstGeom prst="rect">
               <a:avLst/>
@@ -7525,17 +6717,17 @@
         </p:sp>
         <p:pic>
           <p:nvPicPr>
-            <p:cNvPr id="39" name="Picture: backdoor_logits_infix" descr="Top-1 probability, backdoored model, infix trigger"/>
+            <p:cNvPr id="38" name="Picture: backdoor_logits_infix" descr="Top-1 probability, backdoored model, infix trigger"/>
             <p:cNvPicPr>
               <a:picLocks noChangeAspect="1"/>
             </p:cNvPicPr>
             <p:nvPr/>
           </p:nvPicPr>
           <p:blipFill>
-            <a:blip r:embed="rId36">
+            <a:blip r:embed="rId37">
               <a:extLst>
                 <a:ext uri="{96DAC541-7B7A-43D3-8B79-37D633B846F1}">
-                  <asvg:svgBlip xmlns:asvg="http://schemas.microsoft.com/office/drawing/2016/SVG/main" r:embed="rId37"/>
+                  <asvg:svgBlip xmlns:asvg="http://schemas.microsoft.com/office/drawing/2016/SVG/main" r:embed="rId38"/>
                 </a:ext>
               </a:extLst>
             </a:blip>
@@ -7545,8 +6737,8 @@
           </p:blipFill>
           <p:spPr>
             <a:xfrm>
-              <a:off x="28938686" y="11353850"/>
-              <a:ext cx="4007445" cy="3824552"/>
+              <a:off x="22173489" y="13711667"/>
+              <a:ext cx="5564353" cy="5310386"/>
             </a:xfrm>
             <a:prstGeom prst="rect">
               <a:avLst/>
@@ -7555,14 +6747,14 @@
         </p:pic>
         <p:sp>
           <p:nvSpPr>
-            <p:cNvPr id="40" name="Panel label: (d) Infix trigger"/>
+            <p:cNvPr id="39" name="Panel label: (d) Infix trigger"/>
             <p:cNvSpPr txBox="1"/>
             <p:nvPr/>
           </p:nvSpPr>
           <p:spPr>
             <a:xfrm>
-              <a:off x="28926664" y="15229565"/>
-              <a:ext cx="4031490" cy="422391"/>
+              <a:off x="22156796" y="19073217"/>
+              <a:ext cx="5597739" cy="422391"/>
             </a:xfrm>
             <a:prstGeom prst="rect">
               <a:avLst/>
@@ -7609,47 +6801,251 @@
             </a:p>
           </p:txBody>
         </p:sp>
-        <p:pic>
-          <p:nvPicPr>
-            <p:cNvPr id="41" name="Picture: standalone_cbar" descr="Color scale from -0.015 to 0.015"/>
-            <p:cNvPicPr>
-              <a:picLocks noChangeAspect="1"/>
-            </p:cNvPicPr>
+        <p:sp>
+          <p:nvSpPr>
+            <p:cNvPr id="40" name="Insight: Insight 1. Prefix backdoors concentrate attentio"/>
+            <p:cNvSpPr/>
             <p:nvPr/>
-          </p:nvPicPr>
-          <p:blipFill>
-            <a:blip r:embed="rId38">
-              <a:extLst>
-                <a:ext uri="{96DAC541-7B7A-43D3-8B79-37D633B846F1}">
-                  <asvg:svgBlip xmlns:asvg="http://schemas.microsoft.com/office/drawing/2016/SVG/main" r:embed="rId39"/>
-                </a:ext>
-              </a:extLst>
-            </a:blip>
-            <a:stretch>
-              <a:fillRect/>
-            </a:stretch>
-          </p:blipFill>
+          </p:nvSpPr>
           <p:spPr>
             <a:xfrm>
-              <a:off x="16302038" y="15805563"/>
-              <a:ext cx="8219662" cy="507239"/>
+              <a:off x="28045056" y="10183796"/>
+              <a:ext cx="4900960" cy="2677649"/>
+            </a:xfrm>
+            <a:custGeom>
+              <a:avLst/>
+              <a:gdLst/>
+              <a:ahLst/>
+              <a:cxnLst/>
+              <a:rect l="0" t="0" r="r" b="b"/>
+              <a:pathLst>
+                <a:path w="4900960" h="2677649">
+                  <a:moveTo>
+                    <a:pt x="0" y="0"/>
+                  </a:moveTo>
+                  <a:lnTo>
+                    <a:pt x="4747341" y="0"/>
+                  </a:lnTo>
+                  <a:arcTo wR="153619" hR="153619" stAng="16200000" swAng="5400000"/>
+                  <a:lnTo>
+                    <a:pt x="4900960" y="2524030"/>
+                  </a:lnTo>
+                  <a:arcTo wR="153619" hR="153619" stAng="0" swAng="5400000"/>
+                  <a:lnTo>
+                    <a:pt x="0" y="2677649"/>
+                  </a:lnTo>
+                  <a:close/>
+                </a:path>
+              </a:pathLst>
+            </a:custGeom>
+            <a:solidFill>
+              <a:srgbClr val="EEF4F1"/>
+            </a:solidFill>
+            <a:ln>
+              <a:noFill/>
+            </a:ln>
+          </p:spPr>
+          <p:txBody>
+            <a:bodyPr wrap="square" lIns="367157" tIns="140818" rIns="241329" bIns="140818" anchor="ctr" rtlCol="0">
+              <a:noAutofit/>
+            </a:bodyPr>
+            <a:lstStyle/>
+            <a:p>
+              <a:pPr algn="l" marL="0" indent="0">
+                <a:lnSpc>
+                  <a:spcPts val="4717"/>
+                </a:lnSpc>
+                <a:spcBef>
+                  <a:spcPts val="0"/>
+                </a:spcBef>
+                <a:spcAft>
+                  <a:spcPts val="0"/>
+                </a:spcAft>
+                <a:buNone/>
+              </a:pPr>
+              <a:r>
+                <a:rPr lang="en-US" sz="3931" b="1" i="0" kern="100" dirty="0">
+                  <a:solidFill>
+                    <a:srgbClr val="18453B"/>
+                  </a:solidFill>
+                  <a:latin typeface="EB Garamond"/>
+                  <a:ea typeface="EB Garamond"/>
+                  <a:cs typeface="EB Garamond"/>
+                </a:rPr>
+                <a:t>Insight 1.</a:t>
+              </a:r>
+              <a:r>
+                <a:rPr lang="en-US" sz="3931" b="0" i="0" kern="100" dirty="0">
+                  <a:solidFill>
+                    <a:srgbClr val="111111"/>
+                  </a:solidFill>
+                  <a:latin typeface="EB Garamond"/>
+                  <a:ea typeface="EB Garamond"/>
+                  <a:cs typeface="EB Garamond"/>
+                </a:rPr>
+                <a:t> Prefix backdoors concentrate attention on sink tokens.</a:t>
+              </a:r>
+              <a:endParaRPr lang="en-US" sz="3931" b="0" i="0" kern="100" dirty="0">
+                <a:solidFill>
+                  <a:srgbClr val="111111"/>
+                </a:solidFill>
+                <a:latin typeface="EB Garamond"/>
+                <a:ea typeface="EB Garamond"/>
+                <a:cs typeface="EB Garamond"/>
+              </a:endParaRPr>
+            </a:p>
+          </p:txBody>
+        </p:sp>
+        <p:sp>
+          <p:nvSpPr>
+            <p:cNvPr id="41" name="Insight: Insight 1. Prefix backdoors concentrate attentio (rule)"/>
+            <p:cNvSpPr/>
+            <p:nvPr/>
+          </p:nvSpPr>
+          <p:spPr>
+            <a:xfrm>
+              <a:off x="28045056" y="10183796"/>
+              <a:ext cx="111125" cy="2677649"/>
             </a:xfrm>
             <a:prstGeom prst="rect">
               <a:avLst/>
             </a:prstGeom>
+            <a:solidFill>
+              <a:srgbClr val="18453B"/>
+            </a:solidFill>
+            <a:ln>
+              <a:noFill/>
+            </a:ln>
           </p:spPr>
-        </p:pic>
+        </p:sp>
+        <p:sp>
+          <p:nvSpPr>
+            <p:cNvPr id="42" name="Insight: Insight 2. Amplified sink attention raises top-1"/>
+            <p:cNvSpPr/>
+            <p:nvPr/>
+          </p:nvSpPr>
+          <p:spPr>
+            <a:xfrm>
+              <a:off x="28045056" y="13117380"/>
+              <a:ext cx="4900960" cy="2677649"/>
+            </a:xfrm>
+            <a:custGeom>
+              <a:avLst/>
+              <a:gdLst/>
+              <a:ahLst/>
+              <a:cxnLst/>
+              <a:rect l="0" t="0" r="r" b="b"/>
+              <a:pathLst>
+                <a:path w="4900960" h="2677649">
+                  <a:moveTo>
+                    <a:pt x="0" y="0"/>
+                  </a:moveTo>
+                  <a:lnTo>
+                    <a:pt x="4747341" y="0"/>
+                  </a:lnTo>
+                  <a:arcTo wR="153619" hR="153619" stAng="16200000" swAng="5400000"/>
+                  <a:lnTo>
+                    <a:pt x="4900960" y="2524030"/>
+                  </a:lnTo>
+                  <a:arcTo wR="153619" hR="153619" stAng="0" swAng="5400000"/>
+                  <a:lnTo>
+                    <a:pt x="0" y="2677649"/>
+                  </a:lnTo>
+                  <a:close/>
+                </a:path>
+              </a:pathLst>
+            </a:custGeom>
+            <a:solidFill>
+              <a:srgbClr val="EEF4F1"/>
+            </a:solidFill>
+            <a:ln>
+              <a:noFill/>
+            </a:ln>
+          </p:spPr>
+          <p:txBody>
+            <a:bodyPr wrap="square" lIns="367157" tIns="140818" rIns="241329" bIns="140818" anchor="ctr" rtlCol="0">
+              <a:noAutofit/>
+            </a:bodyPr>
+            <a:lstStyle/>
+            <a:p>
+              <a:pPr algn="l" marL="0" indent="0">
+                <a:lnSpc>
+                  <a:spcPts val="4717"/>
+                </a:lnSpc>
+                <a:spcBef>
+                  <a:spcPts val="0"/>
+                </a:spcBef>
+                <a:spcAft>
+                  <a:spcPts val="0"/>
+                </a:spcAft>
+                <a:buNone/>
+              </a:pPr>
+              <a:r>
+                <a:rPr lang="en-US" sz="3931" b="1" i="0" kern="100" dirty="0">
+                  <a:solidFill>
+                    <a:srgbClr val="18453B"/>
+                  </a:solidFill>
+                  <a:latin typeface="EB Garamond"/>
+                  <a:ea typeface="EB Garamond"/>
+                  <a:cs typeface="EB Garamond"/>
+                </a:rPr>
+                <a:t>Insight 2.</a:t>
+              </a:r>
+              <a:r>
+                <a:rPr lang="en-US" sz="3931" b="0" i="0" kern="100" dirty="0">
+                  <a:solidFill>
+                    <a:srgbClr val="111111"/>
+                  </a:solidFill>
+                  <a:latin typeface="EB Garamond"/>
+                  <a:ea typeface="EB Garamond"/>
+                  <a:cs typeface="EB Garamond"/>
+                </a:rPr>
+                <a:t> Amplified sink attention raises top-1 probability on poisoned inputs.</a:t>
+              </a:r>
+              <a:endParaRPr lang="en-US" sz="3931" b="0" i="0" kern="100" dirty="0">
+                <a:solidFill>
+                  <a:srgbClr val="111111"/>
+                </a:solidFill>
+                <a:latin typeface="EB Garamond"/>
+                <a:ea typeface="EB Garamond"/>
+                <a:cs typeface="EB Garamond"/>
+              </a:endParaRPr>
+            </a:p>
+          </p:txBody>
+        </p:sp>
+        <p:sp>
+          <p:nvSpPr>
+            <p:cNvPr id="43" name="Insight: Insight 2. Amplified sink attention raises top-1 (rule)"/>
+            <p:cNvSpPr/>
+            <p:nvPr/>
+          </p:nvSpPr>
+          <p:spPr>
+            <a:xfrm>
+              <a:off x="28045056" y="13117380"/>
+              <a:ext cx="111125" cy="2677649"/>
+            </a:xfrm>
+            <a:prstGeom prst="rect">
+              <a:avLst/>
+            </a:prstGeom>
+            <a:solidFill>
+              <a:srgbClr val="18453B"/>
+            </a:solidFill>
+            <a:ln>
+              <a:noFill/>
+            </a:ln>
+          </p:spPr>
+        </p:sp>
         <mc:AlternateContent xmlns:mc="http://schemas.openxmlformats.org/markup-compatibility/2006" xmlns:a14="http://schemas.microsoft.com/office/drawing/2010/main">
           <mc:Choice Requires="a14">
             <p:sp>
               <p:nvSpPr>
-                <p:cNvPr id="42" name="Caption: Figure 3. (a–b) Attention difference (triggered "/>
+                <p:cNvPr id="44" name="Caption: Figure 3. (a–b) Attention difference, triggered "/>
                 <p:cNvSpPr txBox="1"/>
                 <p:nvPr/>
               </p:nvSpPr>
               <p:spPr>
                 <a:xfrm>
-                  <a:off x="16302038" y="16466410"/>
+                  <a:off x="16302038" y="19649215"/>
                   <a:ext cx="16843823" cy="906363"/>
                 </a:xfrm>
                 <a:prstGeom prst="rect">
@@ -7663,7 +7059,7 @@
                 </a:bodyPr>
                 <a:lstStyle/>
                 <a:p>
-                  <a:pPr algn="just" marL="0" indent="0">
+                  <a:pPr algn="l" marL="0" indent="0">
                     <a:lnSpc>
                       <a:spcPts val="3568"/>
                     </a:lnSpc>
@@ -7717,7 +7113,7 @@
                       <a:ea typeface="EB Garamond"/>
                       <a:cs typeface="EB Garamond"/>
                     </a:rPr>
-                    <a:t> Attention difference (triggered </a:t>
+                    <a:t> Attention difference, triggered </a:t>
                   </a:r>
                   <a14:m>
                     <m:oMath xmlns:m="http://schemas.openxmlformats.org/officeDocument/2006/math">
@@ -7746,7 +7142,7 @@
                       <a:ea typeface="EB Garamond"/>
                       <a:cs typeface="EB Garamond"/>
                     </a:rPr>
-                    <a:t> clean), layer 31, prefix trigger. </a:t>
+                    <a:t> clean (layer 31, prefix trigger). </a:t>
                   </a:r>
                   <a:r>
                     <a:rPr lang="en-US" sz="3024" b="1" i="0" kern="100" dirty="0">
@@ -7768,7 +7164,7 @@
                       <a:ea typeface="EB Garamond"/>
                       <a:cs typeface="EB Garamond"/>
                     </a:rPr>
-                    <a:t> Top-1 probability, poisoned vs. clean inputs.</a:t>
+                    <a:t> Top-1 probability, poisoned vs. clean.</a:t>
                   </a:r>
                   <a:endParaRPr lang="en-US" sz="3024" b="0" i="0" kern="100" dirty="0">
                     <a:solidFill>
@@ -7785,7 +7181,7 @@
           <mc:Fallback>
             <p:sp>
               <p:nvSpPr>
-                <p:cNvPr id="42" name="Caption: Figure 3. (a–b) Attention difference (triggered "/>
+                <p:cNvPr id="44" name="Caption: Figure 3. (a–b) Attention difference, triggered "/>
                 <p:cNvSpPr txBox="1">
                   <a:spLocks noRot="1" noChangeAspect="1" noMove="1" noResize="1" noEditPoints="1" noAdjustHandles="1" noChangeArrowheads="1" noChangeShapeType="1" noTextEdit="1"/>
                 </p:cNvSpPr>
@@ -7793,14 +7189,14 @@
               </p:nvSpPr>
               <p:spPr>
                 <a:xfrm>
-                  <a:off x="16302038" y="16466410"/>
+                  <a:off x="16302038" y="19649215"/>
                   <a:ext cx="16644094" cy="906363"/>
                 </a:xfrm>
                 <a:prstGeom prst="rect">
                   <a:avLst/>
                 </a:prstGeom>
                 <a:blipFill>
-                  <a:blip r:embed="rId40"/>
+                  <a:blip r:embed="rId39"/>
                   <a:stretch>
                     <a:fillRect/>
                   </a:stretch>
@@ -7821,59 +7217,46 @@
             </p:sp>
           </mc:Fallback>
         </mc:AlternateContent>
+      </p:grpSp>
+      <p:grpSp>
+        <p:nvGrpSpPr>
+          <p:cNvPr id="69" name="Section: Table 3"/>
+          <p:cNvGrpSpPr/>
+          <p:nvPr/>
+        </p:nvGrpSpPr>
+        <p:grpSpPr>
+          <a:xfrm>
+            <a:off x="16302038" y="21319447"/>
+            <a:ext cx="16743959" cy="3327731"/>
+            <a:chOff x="16302038" y="21319447"/>
+            <a:chExt cx="16743959" cy="3327731"/>
+          </a:xfrm>
+        </p:grpSpPr>
         <p:sp>
           <p:nvSpPr>
-            <p:cNvPr id="43" name="Insight: Insight 1 (input → attention). Prefix backdoors "/>
-            <p:cNvSpPr/>
+            <p:cNvPr id="45" name="Caption: Table 3. Masking the sink tokens at inference (N"/>
+            <p:cNvSpPr txBox="1"/>
             <p:nvPr/>
           </p:nvSpPr>
           <p:spPr>
             <a:xfrm>
-              <a:off x="16302038" y="17526380"/>
-              <a:ext cx="8181231" cy="2078616"/>
+              <a:off x="16302038" y="21319447"/>
+              <a:ext cx="16743959" cy="445426"/>
             </a:xfrm>
-            <a:custGeom>
+            <a:prstGeom prst="rect">
               <a:avLst/>
-              <a:gdLst/>
-              <a:ahLst/>
-              <a:cxnLst/>
-              <a:rect l="0" t="0" r="r" b="b"/>
-              <a:pathLst>
-                <a:path w="8181231" h="2078616">
-                  <a:moveTo>
-                    <a:pt x="0" y="0"/>
-                  </a:moveTo>
-                  <a:lnTo>
-                    <a:pt x="8027612" y="0"/>
-                  </a:lnTo>
-                  <a:arcTo wR="153619" hR="153619" stAng="16200000" swAng="5400000"/>
-                  <a:lnTo>
-                    <a:pt x="8181231" y="1924997"/>
-                  </a:lnTo>
-                  <a:arcTo wR="153619" hR="153619" stAng="0" swAng="5400000"/>
-                  <a:lnTo>
-                    <a:pt x="0" y="2078616"/>
-                  </a:lnTo>
-                  <a:close/>
-                </a:path>
-              </a:pathLst>
-            </a:custGeom>
-            <a:solidFill>
-              <a:srgbClr val="EEF4F1"/>
-            </a:solidFill>
-            <a:ln>
-              <a:noFill/>
-            </a:ln>
+            </a:prstGeom>
+            <a:noFill/>
           </p:spPr>
           <p:txBody>
-            <a:bodyPr wrap="square" lIns="367157" tIns="140818" rIns="231488" bIns="140818" anchor="ctr" rtlCol="0">
-              <a:noAutofit/>
+            <a:bodyPr wrap="square" lIns="0" tIns="0" rIns="0" bIns="0" anchor="t" rtlCol="0">
+              <a:spAutoFit/>
             </a:bodyPr>
             <a:lstStyle/>
             <a:p>
               <a:pPr algn="l" marL="0" indent="0">
                 <a:lnSpc>
-                  <a:spcPts val="4717"/>
+                  <a:spcPts val="3508"/>
                 </a:lnSpc>
                 <a:spcBef>
                   <a:spcPts val="0"/>
@@ -7884,7 +7267,7 @@
                 <a:buNone/>
               </a:pPr>
               <a:r>
-                <a:rPr lang="en-US" sz="3931" b="1" i="0" kern="100" dirty="0">
+                <a:rPr lang="en-US" sz="3024" b="1" i="0" kern="100" dirty="0">
                   <a:solidFill>
                     <a:srgbClr val="18453B"/>
                   </a:solidFill>
@@ -7892,10 +7275,10 @@
                   <a:ea typeface="EB Garamond"/>
                   <a:cs typeface="EB Garamond"/>
                 </a:rPr>
-                <a:t>Insight 1 (input → attention).</a:t>
+                <a:t>Table 3.</a:t>
               </a:r>
               <a:r>
-                <a:rPr lang="en-US" sz="3931" b="0" i="0" kern="100" dirty="0">
+                <a:rPr lang="en-US" sz="3024" b="0" i="0" kern="100" dirty="0">
                   <a:solidFill>
                     <a:srgbClr val="111111"/>
                   </a:solidFill>
@@ -7903,9 +7286,9 @@
                   <a:ea typeface="EB Garamond"/>
                   <a:cs typeface="EB Garamond"/>
                 </a:rPr>
-                <a:t> Prefix backdoors concentrate attention on sink tokens.</a:t>
+                <a:t> Masking the sink tokens at inference (NPO-Backdoor, MUSE-Books; selected columns).</a:t>
               </a:r>
-              <a:endParaRPr lang="en-US" sz="3931" b="0" i="0" kern="100" dirty="0">
+              <a:endParaRPr lang="en-US" sz="3024" b="0" i="0" kern="100" dirty="0">
                 <a:solidFill>
                   <a:srgbClr val="111111"/>
                 </a:solidFill>
@@ -7916,368 +7299,29 @@
             </a:p>
           </p:txBody>
         </p:sp>
-        <p:sp>
-          <p:nvSpPr>
-            <p:cNvPr id="44" name="Insight: Insight 1 (input → attention). Prefix backdoors  (rule)"/>
-            <p:cNvSpPr/>
-            <p:nvPr/>
-          </p:nvSpPr>
-          <p:spPr>
-            <a:xfrm>
-              <a:off x="16302038" y="17526380"/>
-              <a:ext cx="111125" cy="2078616"/>
-            </a:xfrm>
-            <a:prstGeom prst="rect">
-              <a:avLst/>
-            </a:prstGeom>
-            <a:solidFill>
-              <a:srgbClr val="18453B"/>
-            </a:solidFill>
-            <a:ln>
-              <a:noFill/>
-            </a:ln>
-          </p:spPr>
-        </p:sp>
-        <p:sp>
-          <p:nvSpPr>
-            <p:cNvPr id="45" name="Insight: Insight 2 (attention → prediction). Amplified si"/>
-            <p:cNvSpPr/>
-            <p:nvPr/>
-          </p:nvSpPr>
-          <p:spPr>
-            <a:xfrm>
-              <a:off x="24764901" y="17526380"/>
-              <a:ext cx="8181231" cy="2078616"/>
-            </a:xfrm>
-            <a:custGeom>
-              <a:avLst/>
-              <a:gdLst/>
-              <a:ahLst/>
-              <a:cxnLst/>
-              <a:rect l="0" t="0" r="r" b="b"/>
-              <a:pathLst>
-                <a:path w="8181231" h="2078616">
-                  <a:moveTo>
-                    <a:pt x="0" y="0"/>
-                  </a:moveTo>
-                  <a:lnTo>
-                    <a:pt x="8027612" y="0"/>
-                  </a:lnTo>
-                  <a:arcTo wR="153619" hR="153619" stAng="16200000" swAng="5400000"/>
-                  <a:lnTo>
-                    <a:pt x="8181231" y="1924997"/>
-                  </a:lnTo>
-                  <a:arcTo wR="153619" hR="153619" stAng="0" swAng="5400000"/>
-                  <a:lnTo>
-                    <a:pt x="0" y="2078616"/>
-                  </a:lnTo>
-                  <a:close/>
-                </a:path>
-              </a:pathLst>
-            </a:custGeom>
-            <a:solidFill>
-              <a:srgbClr val="EEF4F1"/>
-            </a:solidFill>
-            <a:ln>
-              <a:noFill/>
-            </a:ln>
-          </p:spPr>
-          <p:txBody>
-            <a:bodyPr wrap="square" lIns="367157" tIns="140818" rIns="231488" bIns="140818" anchor="ctr" rtlCol="0">
-              <a:noAutofit/>
-            </a:bodyPr>
-            <a:lstStyle/>
-            <a:p>
-              <a:pPr algn="l" marL="0" indent="0">
-                <a:lnSpc>
-                  <a:spcPts val="4717"/>
-                </a:lnSpc>
-                <a:spcBef>
-                  <a:spcPts val="0"/>
-                </a:spcBef>
-                <a:spcAft>
-                  <a:spcPts val="0"/>
-                </a:spcAft>
-                <a:buNone/>
-              </a:pPr>
-              <a:r>
-                <a:rPr lang="en-US" sz="3931" b="1" i="0" kern="100" dirty="0">
-                  <a:solidFill>
-                    <a:srgbClr val="18453B"/>
-                  </a:solidFill>
-                  <a:latin typeface="EB Garamond"/>
-                  <a:ea typeface="EB Garamond"/>
-                  <a:cs typeface="EB Garamond"/>
-                </a:rPr>
-                <a:t>Insight 2 (attention → prediction).</a:t>
-              </a:r>
-              <a:r>
-                <a:rPr lang="en-US" sz="3931" b="0" i="0" kern="100" dirty="0">
-                  <a:solidFill>
-                    <a:srgbClr val="111111"/>
-                  </a:solidFill>
-                  <a:latin typeface="EB Garamond"/>
-                  <a:ea typeface="EB Garamond"/>
-                  <a:cs typeface="EB Garamond"/>
-                </a:rPr>
-                <a:t> Amplified sink attention raises top-1 probability on poisoned inputs.</a:t>
-              </a:r>
-              <a:endParaRPr lang="en-US" sz="3931" b="0" i="0" kern="100" dirty="0">
-                <a:solidFill>
-                  <a:srgbClr val="111111"/>
-                </a:solidFill>
-                <a:latin typeface="EB Garamond"/>
-                <a:ea typeface="EB Garamond"/>
-                <a:cs typeface="EB Garamond"/>
-              </a:endParaRPr>
-            </a:p>
-          </p:txBody>
-        </p:sp>
-        <p:sp>
-          <p:nvSpPr>
-            <p:cNvPr id="46" name="Insight: Insight 2 (attention → prediction). Amplified si (rule)"/>
-            <p:cNvSpPr/>
-            <p:nvPr/>
-          </p:nvSpPr>
-          <p:spPr>
-            <a:xfrm>
-              <a:off x="24764901" y="17526380"/>
-              <a:ext cx="111125" cy="2078616"/>
-            </a:xfrm>
-            <a:prstGeom prst="rect">
-              <a:avLst/>
-            </a:prstGeom>
-            <a:solidFill>
-              <a:srgbClr val="18453B"/>
-            </a:solidFill>
-            <a:ln>
-              <a:noFill/>
-            </a:ln>
-          </p:spPr>
-        </p:sp>
-      </p:grpSp>
-      <p:grpSp>
-        <p:nvGrpSpPr>
-          <p:cNvPr id="72" name="Section: Table 3"/>
-          <p:cNvGrpSpPr/>
-          <p:nvPr/>
-        </p:nvGrpSpPr>
-        <p:grpSpPr>
-          <a:xfrm>
-            <a:off x="16302038" y="20006204"/>
-            <a:ext cx="16843823" cy="4640974"/>
-            <a:chOff x="16302038" y="20006204"/>
-            <a:chExt cx="16843823" cy="4640974"/>
-          </a:xfrm>
-        </p:grpSpPr>
-        <mc:AlternateContent xmlns:mc="http://schemas.openxmlformats.org/markup-compatibility/2006" xmlns:a14="http://schemas.microsoft.com/office/drawing/2010/main">
-          <mc:Choice Requires="a14">
-            <p:sp>
-              <p:nvSpPr>
-                <p:cNvPr id="47" name="Caption: Table 3. Causal test: mask the … sink tokens at "/>
-                <p:cNvSpPr txBox="1"/>
-                <p:nvPr/>
-              </p:nvSpPr>
-              <p:spPr>
-                <a:xfrm>
-                  <a:off x="16302038" y="20006204"/>
-                  <a:ext cx="16843823" cy="445426"/>
-                </a:xfrm>
-                <a:prstGeom prst="rect">
-                  <a:avLst/>
-                </a:prstGeom>
-                <a:noFill/>
-              </p:spPr>
-              <p:txBody>
-                <a:bodyPr wrap="square" lIns="0" tIns="0" rIns="0" bIns="0" anchor="t" rtlCol="0">
-                  <a:spAutoFit/>
-                </a:bodyPr>
-                <a:lstStyle/>
-                <a:p>
-                  <a:pPr algn="just" marL="0" indent="0">
-                    <a:lnSpc>
-                      <a:spcPts val="3508"/>
-                    </a:lnSpc>
-                    <a:spcBef>
-                      <a:spcPts val="0"/>
-                    </a:spcBef>
-                    <a:spcAft>
-                      <a:spcPts val="0"/>
-                    </a:spcAft>
-                    <a:buNone/>
-                  </a:pPr>
-                  <a:r>
-                    <a:rPr lang="en-US" sz="3024" b="1" i="0" kern="100" dirty="0">
-                      <a:solidFill>
-                        <a:srgbClr val="18453B"/>
-                      </a:solidFill>
-                      <a:latin typeface="EB Garamond"/>
-                      <a:ea typeface="EB Garamond"/>
-                      <a:cs typeface="EB Garamond"/>
-                    </a:rPr>
-                    <a:t>Table 3.</a:t>
-                  </a:r>
-                  <a:r>
-                    <a:rPr lang="en-US" sz="3024" b="0" i="0" kern="100" dirty="0">
-                      <a:solidFill>
-                        <a:srgbClr val="111111"/>
-                      </a:solidFill>
-                      <a:latin typeface="EB Garamond"/>
-                      <a:ea typeface="EB Garamond"/>
-                      <a:cs typeface="EB Garamond"/>
-                    </a:rPr>
-                    <a:t> </a:t>
-                  </a:r>
-                  <a:r>
-                    <a:rPr lang="en-US" sz="3024" b="1" i="0" kern="100" dirty="0">
-                      <a:solidFill>
-                        <a:srgbClr val="111111"/>
-                      </a:solidFill>
-                      <a:latin typeface="EB Garamond"/>
-                      <a:ea typeface="EB Garamond"/>
-                      <a:cs typeface="EB Garamond"/>
-                    </a:rPr>
-                    <a:t>Causal test:</a:t>
-                  </a:r>
-                  <a:r>
-                    <a:rPr lang="en-US" sz="3024" b="0" i="0" kern="100" dirty="0">
-                      <a:solidFill>
-                        <a:srgbClr val="111111"/>
-                      </a:solidFill>
-                      <a:latin typeface="EB Garamond"/>
-                      <a:ea typeface="EB Garamond"/>
-                      <a:cs typeface="EB Garamond"/>
-                    </a:rPr>
-                    <a:t> mask the </a:t>
-                  </a:r>
-                  <a14:m>
-                    <m:oMath xmlns:m="http://schemas.openxmlformats.org/officeDocument/2006/math">
-                      <m:r>
-                        <a:rPr lang="en-US" sz="3024" b="0" i="1">
-                          <a:solidFill>
-                            <a:srgbClr val="111111"/>
-                          </a:solidFill>
-                          <a:latin typeface="Cambria Math" panose="02040503050406030204" pitchFamily="18" charset="0"/>
-                          <a:ea typeface="Cambria Math"/>
-                          <a:cs typeface="Cambria Math"/>
-                        </a:rPr>
-                        <m:t>k</m:t>
-                      </m:r>
-                      <m:r>
-                        <m:rPr>
-                          <m:sty m:val="p"/>
-                        </m:rPr>
-                        <a:rPr lang="en-US" sz="3024" b="0" i="0">
-                          <a:solidFill>
-                            <a:srgbClr val="111111"/>
-                          </a:solidFill>
-                          <a:latin typeface="Cambria Math" panose="02040503050406030204" pitchFamily="18" charset="0"/>
-                          <a:ea typeface="Cambria Math"/>
-                          <a:cs typeface="Cambria Math"/>
-                        </a:rPr>
-                        <m:t>=</m:t>
-                      </m:r>
-                      <m:r>
-                        <a:rPr lang="en-US" sz="3024" b="0" i="1">
-                          <a:solidFill>
-                            <a:srgbClr val="111111"/>
-                          </a:solidFill>
-                          <a:latin typeface="Cambria Math" panose="02040503050406030204" pitchFamily="18" charset="0"/>
-                          <a:ea typeface="Cambria Math"/>
-                          <a:cs typeface="Cambria Math"/>
-                        </a:rPr>
-                        <m:t>8</m:t>
-                      </m:r>
-                    </m:oMath>
-                  </a14:m>
-                  <a:r>
-                    <a:rPr lang="en-US" sz="3024" b="0" i="0" kern="100" dirty="0">
-                      <a:solidFill>
-                        <a:srgbClr val="111111"/>
-                      </a:solidFill>
-                      <a:latin typeface="EB Garamond"/>
-                      <a:ea typeface="EB Garamond"/>
-                      <a:cs typeface="EB Garamond"/>
-                    </a:rPr>
-                    <a:t> sink tokens at inference (NPO-Backdoor, MUSE-Books).</a:t>
-                  </a:r>
-                  <a:endParaRPr lang="en-US" sz="3024" b="0" i="0" kern="100" dirty="0">
-                    <a:solidFill>
-                      <a:srgbClr val="111111"/>
-                    </a:solidFill>
-                    <a:latin typeface="EB Garamond"/>
-                    <a:ea typeface="EB Garamond"/>
-                    <a:cs typeface="EB Garamond"/>
-                  </a:endParaRPr>
-                </a:p>
-              </p:txBody>
-            </p:sp>
-          </mc:Choice>
-          <mc:Fallback>
-            <p:sp>
-              <p:nvSpPr>
-                <p:cNvPr id="47" name="Caption: Table 3. Causal test: mask the … sink tokens at "/>
-                <p:cNvSpPr txBox="1">
-                  <a:spLocks noRot="1" noChangeAspect="1" noMove="1" noResize="1" noEditPoints="1" noAdjustHandles="1" noChangeArrowheads="1" noChangeShapeType="1" noTextEdit="1"/>
-                </p:cNvSpPr>
-                <p:nvPr/>
-              </p:nvSpPr>
-              <p:spPr>
-                <a:xfrm>
-                  <a:off x="16302038" y="20006204"/>
-                  <a:ext cx="16644094" cy="445426"/>
-                </a:xfrm>
-                <a:prstGeom prst="rect">
-                  <a:avLst/>
-                </a:prstGeom>
-                <a:blipFill>
-                  <a:blip r:embed="rId41"/>
-                  <a:stretch>
-                    <a:fillRect/>
-                  </a:stretch>
-                </a:blipFill>
-              </p:spPr>
-              <p:txBody>
-                <a:bodyPr/>
-                <a:lstStyle/>
-                <a:p>
-                  <a:r>
-                    <a:rPr lang="en-US">
-                      <a:noFill/>
-                    </a:rPr>
-                    <a:t> </a:t>
-                  </a:r>
-                </a:p>
-              </p:txBody>
-            </p:sp>
-          </mc:Fallback>
-        </mc:AlternateContent>
         <p:graphicFrame>
           <p:nvGraphicFramePr>
-            <p:cNvPr id="48" name="Table: Setting"/>
+            <p:cNvPr id="46" name="Table: Setting"/>
             <p:cNvGraphicFramePr>
               <a:graphicFrameLocks noGrp="1"/>
             </p:cNvGraphicFramePr>
             <p:nvPr/>
           </p:nvGraphicFramePr>
           <p:xfrm>
-            <a:off x="16302038" y="20681983"/>
-            <a:ext cx="16644094" cy="1899311"/>
+            <a:off x="17966482" y="21995226"/>
+            <a:ext cx="13315206" cy="1899311"/>
           </p:xfrm>
           <a:graphic>
             <a:graphicData uri="http://schemas.openxmlformats.org/drawingml/2006/table">
               <a:tbl>
                 <a:tblPr firstRow="0" bandRow="0"/>
                 <a:tblGrid>
-                  <a:gridCol w="3753709"/>
-                  <a:gridCol w="1546490"/>
-                  <a:gridCol w="1276433"/>
-                  <a:gridCol w="1546489"/>
-                  <a:gridCol w="1666181"/>
-                  <a:gridCol w="1546489"/>
-                  <a:gridCol w="1540471"/>
-                  <a:gridCol w="1655762"/>
-                  <a:gridCol w="2112070"/>
+                  <a:gridCol w="4409000"/>
+                  <a:gridCol w="1816546"/>
+                  <a:gridCol w="1499262"/>
+                  <a:gridCol w="1816546"/>
+                  <a:gridCol w="1957074"/>
+                  <a:gridCol w="1816778"/>
                 </a:tblGrid>
                 <a:tr h="471124">
                   <a:tc rowSpan="2">
@@ -8524,7 +7568,7 @@
                       <a:noFill/>
                     </a:tcPr>
                   </a:tc>
-                  <a:tc gridSpan="4">
+                  <a:tc>
                     <a:txBody>
                       <a:bodyPr/>
                       <a:lstStyle/>
@@ -8582,105 +7626,6 @@
                       <a:noFill/>
                     </a:tcPr>
                   </a:tc>
-                  <a:tc hMerge="1">
-                    <a:txBody>
-                      <a:bodyPr/>
-                      <a:lstStyle/>
-                      <a:p>
-                        <a:endParaRPr lang="en-US" sz="2742" b="0" i="0" kern="100" dirty="0">
-                          <a:solidFill>
-                            <a:srgbClr val="111111"/>
-                          </a:solidFill>
-                          <a:latin typeface="EB Garamond"/>
-                          <a:ea typeface="EB Garamond"/>
-                          <a:cs typeface="EB Garamond"/>
-                        </a:endParaRPr>
-                      </a:p>
-                    </a:txBody>
-                    <a:tcPr marL="102413" marR="102413" marT="33284" marB="33284" anchor="ctr">
-                      <a:lnL w="0">
-                        <a:noFill/>
-                      </a:lnL>
-                      <a:lnR w="0">
-                        <a:noFill/>
-                      </a:lnR>
-                      <a:lnT w="29633">
-                        <a:solidFill>
-                          <a:srgbClr val="000000"/>
-                        </a:solidFill>
-                      </a:lnT>
-                      <a:lnB w="0">
-                        <a:noFill/>
-                      </a:lnB>
-                      <a:noFill/>
-                    </a:tcPr>
-                  </a:tc>
-                  <a:tc hMerge="1">
-                    <a:txBody>
-                      <a:bodyPr/>
-                      <a:lstStyle/>
-                      <a:p>
-                        <a:endParaRPr lang="en-US" sz="2742" b="0" i="0" kern="100" dirty="0">
-                          <a:solidFill>
-                            <a:srgbClr val="111111"/>
-                          </a:solidFill>
-                          <a:latin typeface="EB Garamond"/>
-                          <a:ea typeface="EB Garamond"/>
-                          <a:cs typeface="EB Garamond"/>
-                        </a:endParaRPr>
-                      </a:p>
-                    </a:txBody>
-                    <a:tcPr marL="102413" marR="102413" marT="33284" marB="33284" anchor="ctr">
-                      <a:lnL w="0">
-                        <a:noFill/>
-                      </a:lnL>
-                      <a:lnR w="0">
-                        <a:noFill/>
-                      </a:lnR>
-                      <a:lnT w="29633">
-                        <a:solidFill>
-                          <a:srgbClr val="000000"/>
-                        </a:solidFill>
-                      </a:lnT>
-                      <a:lnB w="0">
-                        <a:noFill/>
-                      </a:lnB>
-                      <a:noFill/>
-                    </a:tcPr>
-                  </a:tc>
-                  <a:tc hMerge="1">
-                    <a:txBody>
-                      <a:bodyPr/>
-                      <a:lstStyle/>
-                      <a:p>
-                        <a:endParaRPr lang="en-US" sz="2742" b="0" i="0" kern="100" dirty="0">
-                          <a:solidFill>
-                            <a:srgbClr val="111111"/>
-                          </a:solidFill>
-                          <a:latin typeface="EB Garamond"/>
-                          <a:ea typeface="EB Garamond"/>
-                          <a:cs typeface="EB Garamond"/>
-                        </a:endParaRPr>
-                      </a:p>
-                    </a:txBody>
-                    <a:tcPr marL="102413" marR="102413" marT="33284" marB="33284" anchor="ctr">
-                      <a:lnL w="0">
-                        <a:noFill/>
-                      </a:lnL>
-                      <a:lnR w="0">
-                        <a:noFill/>
-                      </a:lnR>
-                      <a:lnT w="29633">
-                        <a:solidFill>
-                          <a:srgbClr val="000000"/>
-                        </a:solidFill>
-                      </a:lnT>
-                      <a:lnB w="0">
-                        <a:noFill/>
-                      </a:lnB>
-                      <a:noFill/>
-                    </a:tcPr>
-                  </a:tc>
                 </a:tr>
                 <a:tr h="463715">
                   <a:tc vMerge="1">
@@ -9006,174 +7951,6 @@
                       <a:noFill/>
                     </a:tcPr>
                   </a:tc>
-                  <a:tc>
-                    <a:txBody>
-                      <a:bodyPr/>
-                      <a:lstStyle/>
-                      <a:p>
-                        <a:pPr algn="ctr" marL="0" indent="0">
-                          <a:lnSpc>
-                            <a:spcPts val="3071"/>
-                          </a:lnSpc>
-                          <a:spcBef>
-                            <a:spcPts val="0"/>
-                          </a:spcBef>
-                          <a:spcAft>
-                            <a:spcPts val="0"/>
-                          </a:spcAft>
-                          <a:buNone/>
-                        </a:pPr>
-                        <a:r>
-                          <a:rPr lang="en-US" sz="2742" b="1" i="0" kern="100" dirty="0">
-                            <a:solidFill>
-                              <a:srgbClr val="111111"/>
-                            </a:solidFill>
-                            <a:latin typeface="EB Garamond"/>
-                            <a:ea typeface="EB Garamond"/>
-                            <a:cs typeface="EB Garamond"/>
-                          </a:rPr>
-                          <a:t>TQA</a:t>
-                        </a:r>
-                        <a:endParaRPr lang="en-US" sz="2742" b="0" i="0" kern="100" dirty="0">
-                          <a:solidFill>
-                            <a:srgbClr val="111111"/>
-                          </a:solidFill>
-                          <a:latin typeface="EB Garamond"/>
-                          <a:ea typeface="EB Garamond"/>
-                          <a:cs typeface="EB Garamond"/>
-                        </a:endParaRPr>
-                      </a:p>
-                    </a:txBody>
-                    <a:tcPr marL="102413" marR="102413" marT="33284" marB="33284" anchor="ctr">
-                      <a:lnL w="0">
-                        <a:noFill/>
-                      </a:lnL>
-                      <a:lnR w="0">
-                        <a:noFill/>
-                      </a:lnR>
-                      <a:lnT w="0">
-                        <a:noFill/>
-                      </a:lnT>
-                      <a:lnB w="14817">
-                        <a:solidFill>
-                          <a:srgbClr val="000000"/>
-                        </a:solidFill>
-                      </a:lnB>
-                      <a:noFill/>
-                    </a:tcPr>
-                  </a:tc>
-                  <a:tc>
-                    <a:txBody>
-                      <a:bodyPr/>
-                      <a:lstStyle/>
-                      <a:p>
-                        <a:pPr algn="ctr" marL="0" indent="0">
-                          <a:lnSpc>
-                            <a:spcPts val="3071"/>
-                          </a:lnSpc>
-                          <a:spcBef>
-                            <a:spcPts val="0"/>
-                          </a:spcBef>
-                          <a:spcAft>
-                            <a:spcPts val="0"/>
-                          </a:spcAft>
-                          <a:buNone/>
-                        </a:pPr>
-                        <a:r>
-                          <a:rPr lang="en-US" sz="2742" b="1" i="0" kern="100" dirty="0">
-                            <a:solidFill>
-                              <a:srgbClr val="111111"/>
-                            </a:solidFill>
-                            <a:latin typeface="EB Garamond"/>
-                            <a:ea typeface="EB Garamond"/>
-                            <a:cs typeface="EB Garamond"/>
-                          </a:rPr>
-                          <a:t>MQA</a:t>
-                        </a:r>
-                        <a:endParaRPr lang="en-US" sz="2742" b="0" i="0" kern="100" dirty="0">
-                          <a:solidFill>
-                            <a:srgbClr val="111111"/>
-                          </a:solidFill>
-                          <a:latin typeface="EB Garamond"/>
-                          <a:ea typeface="EB Garamond"/>
-                          <a:cs typeface="EB Garamond"/>
-                        </a:endParaRPr>
-                      </a:p>
-                    </a:txBody>
-                    <a:tcPr marL="102413" marR="102413" marT="33284" marB="33284" anchor="ctr">
-                      <a:lnL w="0">
-                        <a:noFill/>
-                      </a:lnL>
-                      <a:lnR w="0">
-                        <a:noFill/>
-                      </a:lnR>
-                      <a:lnT w="0">
-                        <a:noFill/>
-                      </a:lnT>
-                      <a:lnB w="14817">
-                        <a:solidFill>
-                          <a:srgbClr val="000000"/>
-                        </a:solidFill>
-                      </a:lnB>
-                      <a:noFill/>
-                    </a:tcPr>
-                  </a:tc>
-                  <a:tc>
-                    <a:txBody>
-                      <a:bodyPr/>
-                      <a:lstStyle/>
-                      <a:p>
-                        <a:pPr algn="ctr" marL="0" indent="0">
-                          <a:lnSpc>
-                            <a:spcPts val="3071"/>
-                          </a:lnSpc>
-                          <a:spcBef>
-                            <a:spcPts val="0"/>
-                          </a:spcBef>
-                          <a:spcAft>
-                            <a:spcPts val="0"/>
-                          </a:spcAft>
-                          <a:buNone/>
-                        </a:pPr>
-                        <a:r>
-                          <a:rPr lang="en-US" sz="2742" b="1" i="0" kern="100" dirty="0">
-                            <a:solidFill>
-                              <a:srgbClr val="111111"/>
-                            </a:solidFill>
-                            <a:latin typeface="EB Garamond"/>
-                            <a:ea typeface="EB Garamond"/>
-                            <a:cs typeface="EB Garamond"/>
-                          </a:rPr>
-                          <a:t>MMLU</a:t>
-                        </a:r>
-                        <a:endParaRPr lang="en-US" sz="2742" b="0" i="0" kern="100" dirty="0">
-                          <a:solidFill>
-                            <a:srgbClr val="111111"/>
-                          </a:solidFill>
-                          <a:latin typeface="EB Garamond"/>
-                          <a:ea typeface="EB Garamond"/>
-                          <a:cs typeface="EB Garamond"/>
-                        </a:endParaRPr>
-                      </a:p>
-                    </a:txBody>
-                    <a:tcPr marL="102413" marR="102413" marT="33284" marB="33284" anchor="ctr">
-                      <a:lnL w="0">
-                        <a:noFill/>
-                      </a:lnL>
-                      <a:lnR w="0">
-                        <a:noFill/>
-                      </a:lnR>
-                      <a:lnT w="0">
-                        <a:noFill/>
-                      </a:lnT>
-                      <a:lnB w="14817">
-                        <a:solidFill>
-                          <a:srgbClr val="000000"/>
-                        </a:solidFill>
-                      </a:lnB>
-                      <a:noFill/>
-                    </a:tcPr>
-                  </a:tc>
                 </a:tr>
                 <a:tr h="463715">
                   <a:tc>
@@ -9522,174 +8299,6 @@
                       <a:noFill/>
                     </a:tcPr>
                   </a:tc>
-                  <a:tc>
-                    <a:txBody>
-                      <a:bodyPr/>
-                      <a:lstStyle/>
-                      <a:p>
-                        <a:pPr algn="ctr" marL="0" indent="0">
-                          <a:lnSpc>
-                            <a:spcPts val="3071"/>
-                          </a:lnSpc>
-                          <a:spcBef>
-                            <a:spcPts val="0"/>
-                          </a:spcBef>
-                          <a:spcAft>
-                            <a:spcPts val="0"/>
-                          </a:spcAft>
-                          <a:buNone/>
-                        </a:pPr>
-                        <a:r>
-                          <a:rPr lang="en-US" sz="2742" b="0" i="0" kern="100" dirty="0">
-                            <a:solidFill>
-                              <a:srgbClr val="111111"/>
-                            </a:solidFill>
-                            <a:latin typeface="EB Garamond"/>
-                            <a:ea typeface="EB Garamond"/>
-                            <a:cs typeface="EB Garamond"/>
-                          </a:rPr>
-                          <a:t>22.15</a:t>
-                        </a:r>
-                        <a:endParaRPr lang="en-US" sz="2742" b="0" i="0" kern="100" dirty="0">
-                          <a:solidFill>
-                            <a:srgbClr val="111111"/>
-                          </a:solidFill>
-                          <a:latin typeface="EB Garamond"/>
-                          <a:ea typeface="EB Garamond"/>
-                          <a:cs typeface="EB Garamond"/>
-                        </a:endParaRPr>
-                      </a:p>
-                    </a:txBody>
-                    <a:tcPr marL="102413" marR="102413" marT="33284" marB="33284" anchor="ctr">
-                      <a:lnL w="0">
-                        <a:noFill/>
-                      </a:lnL>
-                      <a:lnR w="0">
-                        <a:noFill/>
-                      </a:lnR>
-                      <a:lnT w="14817">
-                        <a:solidFill>
-                          <a:srgbClr val="000000"/>
-                        </a:solidFill>
-                      </a:lnT>
-                      <a:lnB w="0">
-                        <a:noFill/>
-                      </a:lnB>
-                      <a:noFill/>
-                    </a:tcPr>
-                  </a:tc>
-                  <a:tc>
-                    <a:txBody>
-                      <a:bodyPr/>
-                      <a:lstStyle/>
-                      <a:p>
-                        <a:pPr algn="ctr" marL="0" indent="0">
-                          <a:lnSpc>
-                            <a:spcPts val="3071"/>
-                          </a:lnSpc>
-                          <a:spcBef>
-                            <a:spcPts val="0"/>
-                          </a:spcBef>
-                          <a:spcAft>
-                            <a:spcPts val="0"/>
-                          </a:spcAft>
-                          <a:buNone/>
-                        </a:pPr>
-                        <a:r>
-                          <a:rPr lang="en-US" sz="2742" b="0" i="0" kern="100" dirty="0">
-                            <a:solidFill>
-                              <a:srgbClr val="111111"/>
-                            </a:solidFill>
-                            <a:latin typeface="EB Garamond"/>
-                            <a:ea typeface="EB Garamond"/>
-                            <a:cs typeface="EB Garamond"/>
-                          </a:rPr>
-                          <a:t>25.90</a:t>
-                        </a:r>
-                        <a:endParaRPr lang="en-US" sz="2742" b="0" i="0" kern="100" dirty="0">
-                          <a:solidFill>
-                            <a:srgbClr val="111111"/>
-                          </a:solidFill>
-                          <a:latin typeface="EB Garamond"/>
-                          <a:ea typeface="EB Garamond"/>
-                          <a:cs typeface="EB Garamond"/>
-                        </a:endParaRPr>
-                      </a:p>
-                    </a:txBody>
-                    <a:tcPr marL="102413" marR="102413" marT="33284" marB="33284" anchor="ctr">
-                      <a:lnL w="0">
-                        <a:noFill/>
-                      </a:lnL>
-                      <a:lnR w="0">
-                        <a:noFill/>
-                      </a:lnR>
-                      <a:lnT w="14817">
-                        <a:solidFill>
-                          <a:srgbClr val="000000"/>
-                        </a:solidFill>
-                      </a:lnT>
-                      <a:lnB w="0">
-                        <a:noFill/>
-                      </a:lnB>
-                      <a:noFill/>
-                    </a:tcPr>
-                  </a:tc>
-                  <a:tc>
-                    <a:txBody>
-                      <a:bodyPr/>
-                      <a:lstStyle/>
-                      <a:p>
-                        <a:pPr algn="ctr" marL="0" indent="0">
-                          <a:lnSpc>
-                            <a:spcPts val="3071"/>
-                          </a:lnSpc>
-                          <a:spcBef>
-                            <a:spcPts val="0"/>
-                          </a:spcBef>
-                          <a:spcAft>
-                            <a:spcPts val="0"/>
-                          </a:spcAft>
-                          <a:buNone/>
-                        </a:pPr>
-                        <a:r>
-                          <a:rPr lang="en-US" sz="2742" b="0" i="0" kern="100" dirty="0">
-                            <a:solidFill>
-                              <a:srgbClr val="111111"/>
-                            </a:solidFill>
-                            <a:latin typeface="EB Garamond"/>
-                            <a:ea typeface="EB Garamond"/>
-                            <a:cs typeface="EB Garamond"/>
-                          </a:rPr>
-                          <a:t>26.86</a:t>
-                        </a:r>
-                        <a:endParaRPr lang="en-US" sz="2742" b="0" i="0" kern="100" dirty="0">
-                          <a:solidFill>
-                            <a:srgbClr val="111111"/>
-                          </a:solidFill>
-                          <a:latin typeface="EB Garamond"/>
-                          <a:ea typeface="EB Garamond"/>
-                          <a:cs typeface="EB Garamond"/>
-                        </a:endParaRPr>
-                      </a:p>
-                    </a:txBody>
-                    <a:tcPr marL="102413" marR="102413" marT="33284" marB="33284" anchor="ctr">
-                      <a:lnL w="0">
-                        <a:noFill/>
-                      </a:lnL>
-                      <a:lnR w="0">
-                        <a:noFill/>
-                      </a:lnR>
-                      <a:lnT w="14817">
-                        <a:solidFill>
-                          <a:srgbClr val="000000"/>
-                        </a:solidFill>
-                      </a:lnT>
-                      <a:lnB w="0">
-                        <a:noFill/>
-                      </a:lnB>
-                      <a:noFill/>
-                    </a:tcPr>
-                  </a:tc>
                 </a:tr>
                 <a:tr h="471124">
                   <a:tc>
@@ -10040,465 +8649,134 @@
                       <a:noFill/>
                     </a:tcPr>
                   </a:tc>
-                  <a:tc>
-                    <a:txBody>
-                      <a:bodyPr/>
-                      <a:lstStyle/>
-                      <a:p>
-                        <a:pPr algn="ctr" marL="0" indent="0">
-                          <a:lnSpc>
-                            <a:spcPts val="3071"/>
-                          </a:lnSpc>
-                          <a:spcBef>
-                            <a:spcPts val="0"/>
-                          </a:spcBef>
-                          <a:spcAft>
-                            <a:spcPts val="0"/>
-                          </a:spcAft>
-                          <a:buNone/>
-                        </a:pPr>
-                        <a:r>
-                          <a:rPr lang="en-US" sz="2742" b="0" i="0" kern="100" dirty="0">
-                            <a:solidFill>
-                              <a:srgbClr val="111111"/>
-                            </a:solidFill>
-                            <a:latin typeface="EB Garamond"/>
-                            <a:ea typeface="EB Garamond"/>
-                            <a:cs typeface="EB Garamond"/>
-                          </a:rPr>
-                          <a:t>20.05</a:t>
-                        </a:r>
-                        <a:endParaRPr lang="en-US" sz="2742" b="0" i="0" kern="100" dirty="0">
-                          <a:solidFill>
-                            <a:srgbClr val="111111"/>
-                          </a:solidFill>
-                          <a:latin typeface="EB Garamond"/>
-                          <a:ea typeface="EB Garamond"/>
-                          <a:cs typeface="EB Garamond"/>
-                        </a:endParaRPr>
-                      </a:p>
-                    </a:txBody>
-                    <a:tcPr marL="102413" marR="102413" marT="33284" marB="33284" anchor="ctr">
-                      <a:lnL w="0">
-                        <a:noFill/>
-                      </a:lnL>
-                      <a:lnR w="0">
-                        <a:noFill/>
-                      </a:lnR>
-                      <a:lnT w="0">
-                        <a:noFill/>
-                      </a:lnT>
-                      <a:lnB w="29633">
-                        <a:solidFill>
-                          <a:srgbClr val="000000"/>
-                        </a:solidFill>
-                      </a:lnB>
-                      <a:noFill/>
-                    </a:tcPr>
-                  </a:tc>
-                  <a:tc>
-                    <a:txBody>
-                      <a:bodyPr/>
-                      <a:lstStyle/>
-                      <a:p>
-                        <a:pPr algn="ctr" marL="0" indent="0">
-                          <a:lnSpc>
-                            <a:spcPts val="3071"/>
-                          </a:lnSpc>
-                          <a:spcBef>
-                            <a:spcPts val="0"/>
-                          </a:spcBef>
-                          <a:spcAft>
-                            <a:spcPts val="0"/>
-                          </a:spcAft>
-                          <a:buNone/>
-                        </a:pPr>
-                        <a:r>
-                          <a:rPr lang="en-US" sz="2742" b="0" i="0" kern="100" dirty="0">
-                            <a:solidFill>
-                              <a:srgbClr val="111111"/>
-                            </a:solidFill>
-                            <a:latin typeface="EB Garamond"/>
-                            <a:ea typeface="EB Garamond"/>
-                            <a:cs typeface="EB Garamond"/>
-                          </a:rPr>
-                          <a:t>24.22</a:t>
-                        </a:r>
-                        <a:endParaRPr lang="en-US" sz="2742" b="0" i="0" kern="100" dirty="0">
-                          <a:solidFill>
-                            <a:srgbClr val="111111"/>
-                          </a:solidFill>
-                          <a:latin typeface="EB Garamond"/>
-                          <a:ea typeface="EB Garamond"/>
-                          <a:cs typeface="EB Garamond"/>
-                        </a:endParaRPr>
-                      </a:p>
-                    </a:txBody>
-                    <a:tcPr marL="102413" marR="102413" marT="33284" marB="33284" anchor="ctr">
-                      <a:lnL w="0">
-                        <a:noFill/>
-                      </a:lnL>
-                      <a:lnR w="0">
-                        <a:noFill/>
-                      </a:lnR>
-                      <a:lnT w="0">
-                        <a:noFill/>
-                      </a:lnT>
-                      <a:lnB w="29633">
-                        <a:solidFill>
-                          <a:srgbClr val="000000"/>
-                        </a:solidFill>
-                      </a:lnB>
-                      <a:noFill/>
-                    </a:tcPr>
-                  </a:tc>
-                  <a:tc>
-                    <a:txBody>
-                      <a:bodyPr/>
-                      <a:lstStyle/>
-                      <a:p>
-                        <a:pPr algn="ctr" marL="0" indent="0">
-                          <a:lnSpc>
-                            <a:spcPts val="3071"/>
-                          </a:lnSpc>
-                          <a:spcBef>
-                            <a:spcPts val="0"/>
-                          </a:spcBef>
-                          <a:spcAft>
-                            <a:spcPts val="0"/>
-                          </a:spcAft>
-                          <a:buNone/>
-                        </a:pPr>
-                        <a:r>
-                          <a:rPr lang="en-US" sz="2742" b="0" i="0" kern="100" dirty="0">
-                            <a:solidFill>
-                              <a:srgbClr val="111111"/>
-                            </a:solidFill>
-                            <a:latin typeface="EB Garamond"/>
-                            <a:ea typeface="EB Garamond"/>
-                            <a:cs typeface="EB Garamond"/>
-                          </a:rPr>
-                          <a:t>25.46</a:t>
-                        </a:r>
-                        <a:endParaRPr lang="en-US" sz="2742" b="0" i="0" kern="100" dirty="0">
-                          <a:solidFill>
-                            <a:srgbClr val="111111"/>
-                          </a:solidFill>
-                          <a:latin typeface="EB Garamond"/>
-                          <a:ea typeface="EB Garamond"/>
-                          <a:cs typeface="EB Garamond"/>
-                        </a:endParaRPr>
-                      </a:p>
-                    </a:txBody>
-                    <a:tcPr marL="102413" marR="102413" marT="33284" marB="33284" anchor="ctr">
-                      <a:lnL w="0">
-                        <a:noFill/>
-                      </a:lnL>
-                      <a:lnR w="0">
-                        <a:noFill/>
-                      </a:lnR>
-                      <a:lnT w="0">
-                        <a:noFill/>
-                      </a:lnT>
-                      <a:lnB w="29633">
-                        <a:solidFill>
-                          <a:srgbClr val="000000"/>
-                        </a:solidFill>
-                      </a:lnB>
-                      <a:noFill/>
-                    </a:tcPr>
-                  </a:tc>
                 </a:tr>
               </a:tbl>
             </a:graphicData>
           </a:graphic>
         </p:graphicFrame>
-        <mc:AlternateContent xmlns:mc="http://schemas.openxmlformats.org/markup-compatibility/2006" xmlns:a14="http://schemas.microsoft.com/office/drawing/2010/main">
-          <mc:Choice Requires="a14">
-            <p:sp>
-              <p:nvSpPr>
-                <p:cNvPr id="49" name="Bullets: Masking collapses recovery (BE-VM 90.71 → 0.14):"/>
-                <p:cNvSpPr txBox="1"/>
-                <p:nvPr/>
-              </p:nvSpPr>
-              <p:spPr>
-                <a:xfrm>
-                  <a:off x="16302038" y="22734902"/>
-                  <a:ext cx="16843823" cy="1912276"/>
-                </a:xfrm>
-                <a:prstGeom prst="rect">
-                  <a:avLst/>
-                </a:prstGeom>
-                <a:noFill/>
-              </p:spPr>
-              <p:txBody>
-                <a:bodyPr wrap="square" lIns="0" tIns="0" rIns="0" bIns="0" anchor="t" rtlCol="0">
-                  <a:spAutoFit/>
-                </a:bodyPr>
-                <a:lstStyle/>
-                <a:p>
-                  <a:pPr algn="l" marL="574152" indent="-574152">
-                    <a:lnSpc>
-                      <a:spcPts val="4717"/>
-                    </a:lnSpc>
-                    <a:spcBef>
-                      <a:spcPts val="0"/>
-                    </a:spcBef>
-                    <a:spcAft>
-                      <a:spcPts val="0"/>
-                    </a:spcAft>
-                    <a:buClr>
-                      <a:srgbClr val="111111"/>
-                    </a:buClr>
-                    <a:buSzPct val="78000"/>
-                    <a:buFont typeface="Wingdings" pitchFamily="2" charset="2"/>
-                    <a:buChar char="v"/>
-                  </a:pPr>
-                  <a:r>
-                    <a:rPr lang="en-US" sz="3931" b="0" i="0" kern="100" dirty="0">
-                      <a:solidFill>
-                        <a:srgbClr val="111111"/>
-                      </a:solidFill>
-                      <a:latin typeface="EB Garamond"/>
-                      <a:ea typeface="EB Garamond"/>
-                      <a:cs typeface="EB Garamond"/>
-                    </a:rPr>
-                    <a:t>Masking collapses recovery (BE-VM </a:t>
-                  </a:r>
-                  <a:r>
-                    <a:rPr lang="en-US" sz="3931" b="1" i="0" kern="100" dirty="0">
-                      <a:solidFill>
-                        <a:srgbClr val="111111"/>
-                      </a:solidFill>
-                      <a:latin typeface="EB Garamond"/>
-                      <a:ea typeface="EB Garamond"/>
-                      <a:cs typeface="EB Garamond"/>
-                    </a:rPr>
-                    <a:t>90.71 → 0.14</a:t>
-                  </a:r>
-                  <a:r>
-                    <a:rPr lang="en-US" sz="3931" b="0" i="0" kern="100" dirty="0">
-                      <a:solidFill>
-                        <a:srgbClr val="111111"/>
-                      </a:solidFill>
-                      <a:latin typeface="EB Garamond"/>
-                      <a:ea typeface="EB Garamond"/>
-                      <a:cs typeface="EB Garamond"/>
-                    </a:rPr>
-                    <a:t>): </a:t>
-                  </a:r>
-                  <a:r>
-                    <a:rPr lang="en-US" sz="3931" b="1" i="0" kern="100" dirty="0">
-                      <a:solidFill>
-                        <a:srgbClr val="18453B"/>
-                      </a:solidFill>
-                      <a:latin typeface="EB Garamond"/>
-                      <a:ea typeface="EB Garamond"/>
-                      <a:cs typeface="EB Garamond"/>
-                    </a:rPr>
-                    <a:t>the sink is the mechanism</a:t>
-                  </a:r>
-                  <a:r>
-                    <a:rPr lang="en-US" sz="3931" b="0" i="0" kern="100" dirty="0">
-                      <a:solidFill>
-                        <a:srgbClr val="111111"/>
-                      </a:solidFill>
-                      <a:latin typeface="EB Garamond"/>
-                      <a:ea typeface="EB Garamond"/>
-                      <a:cs typeface="EB Garamond"/>
-                    </a:rPr>
-                    <a:t>.</a:t>
-                  </a:r>
-                  <a:endParaRPr lang="en-US" sz="3931" b="0" i="0" kern="100" dirty="0">
-                    <a:solidFill>
-                      <a:srgbClr val="111111"/>
-                    </a:solidFill>
-                    <a:latin typeface="EB Garamond"/>
-                    <a:ea typeface="EB Garamond"/>
-                    <a:cs typeface="EB Garamond"/>
-                  </a:endParaRPr>
-                </a:p>
-                <a:p>
-                  <a:pPr algn="l" marL="574152" indent="-574152">
-                    <a:lnSpc>
-                      <a:spcPts val="4717"/>
-                    </a:lnSpc>
-                    <a:spcBef>
-                      <a:spcPts val="907"/>
-                    </a:spcBef>
-                    <a:spcAft>
-                      <a:spcPts val="0"/>
-                    </a:spcAft>
-                    <a:buClr>
-                      <a:srgbClr val="111111"/>
-                    </a:buClr>
-                    <a:buSzPct val="78000"/>
-                    <a:buFont typeface="Wingdings" pitchFamily="2" charset="2"/>
-                    <a:buChar char="v"/>
-                  </a:pPr>
-                  <a:r>
-                    <a:rPr lang="en-US" sz="3931" b="1" i="0" kern="100" dirty="0">
-                      <a:solidFill>
-                        <a:srgbClr val="111111"/>
-                      </a:solidFill>
-                      <a:latin typeface="EB Garamond"/>
-                      <a:ea typeface="EB Garamond"/>
-                      <a:cs typeface="EB Garamond"/>
-                    </a:rPr>
-                    <a:t>Position, not content:</a:t>
-                  </a:r>
-                  <a:r>
-                    <a:rPr lang="en-US" sz="3931" b="0" i="0" kern="100" dirty="0">
-                      <a:solidFill>
-                        <a:srgbClr val="111111"/>
-                      </a:solidFill>
-                      <a:latin typeface="EB Garamond"/>
-                      <a:ea typeface="EB Garamond"/>
-                      <a:cs typeface="EB Garamond"/>
-                    </a:rPr>
-                    <a:t> with </a:t>
-                  </a:r>
-                  <a14:m>
-                    <m:oMath xmlns:m="http://schemas.openxmlformats.org/officeDocument/2006/math">
-                      <m:sSub>
-                        <m:sSubPr>
-                          <m:ctrlPr>
-                            <a:rPr lang="en-US" sz="3931" b="0" i="1">
-                              <a:solidFill>
-                                <a:srgbClr val="111111"/>
-                              </a:solidFill>
-                              <a:latin typeface="Cambria Math" panose="02040503050406030204" pitchFamily="18" charset="0"/>
-                              <a:ea typeface="Cambria Math"/>
-                              <a:cs typeface="Cambria Math"/>
-                            </a:rPr>
-                          </m:ctrlPr>
-                        </m:sSubPr>
-                        <m:e>
-                          <m:r>
-                            <a:rPr lang="en-US" sz="3931" b="0" i="1">
-                              <a:solidFill>
-                                <a:srgbClr val="111111"/>
-                              </a:solidFill>
-                              <a:latin typeface="Cambria Math" panose="02040503050406030204" pitchFamily="18" charset="0"/>
-                              <a:ea typeface="Cambria Math"/>
-                              <a:cs typeface="Cambria Math"/>
-                            </a:rPr>
-                            <m:t>ℓ</m:t>
-                          </m:r>
-                        </m:e>
-                        <m:sub>
-                          <m:r>
-                            <m:rPr>
-                              <m:sty m:val="p"/>
-                            </m:rPr>
-                            <a:rPr lang="en-US" sz="3931" b="0" i="0">
-                              <a:solidFill>
-                                <a:srgbClr val="111111"/>
-                              </a:solidFill>
-                              <a:latin typeface="Cambria Math" panose="02040503050406030204" pitchFamily="18" charset="0"/>
-                              <a:ea typeface="Cambria Math"/>
-                              <a:cs typeface="Cambria Math"/>
-                            </a:rPr>
-                            <m:t>v</m:t>
-                          </m:r>
-                          <m:r>
-                            <m:rPr>
-                              <m:sty m:val="p"/>
-                            </m:rPr>
-                            <a:rPr lang="en-US" sz="3931" b="0" i="0">
-                              <a:solidFill>
-                                <a:srgbClr val="111111"/>
-                              </a:solidFill>
-                              <a:latin typeface="Cambria Math" panose="02040503050406030204" pitchFamily="18" charset="0"/>
-                              <a:ea typeface="Cambria Math"/>
-                              <a:cs typeface="Cambria Math"/>
-                            </a:rPr>
-                            <m:t>n</m:t>
-                          </m:r>
-                        </m:sub>
-                      </m:sSub>
-                    </m:oMath>
-                  </a14:m>
-                  <a:r>
-                    <a:rPr lang="en-US" sz="3931" b="0" i="0" kern="100" dirty="0">
-                      <a:solidFill>
-                        <a:srgbClr val="111111"/>
-                      </a:solidFill>
-                      <a:latin typeface="EB Garamond"/>
-                      <a:ea typeface="EB Garamond"/>
-                      <a:cs typeface="EB Garamond"/>
-                    </a:rPr>
-                    <a:t>, three prefix triggers reach BE-VM 57.24–90.71; infix/suffix ≤ 1.47.</a:t>
-                  </a:r>
-                  <a:endParaRPr lang="en-US" sz="3931" b="0" i="0" kern="100" dirty="0">
-                    <a:solidFill>
-                      <a:srgbClr val="111111"/>
-                    </a:solidFill>
-                    <a:latin typeface="EB Garamond"/>
-                    <a:ea typeface="EB Garamond"/>
-                    <a:cs typeface="EB Garamond"/>
-                  </a:endParaRPr>
-                </a:p>
-              </p:txBody>
-            </p:sp>
-          </mc:Choice>
-          <mc:Fallback>
-            <p:sp>
-              <p:nvSpPr>
-                <p:cNvPr id="49" name="Bullets: Masking collapses recovery (BE-VM 90.71 → 0.14):"/>
-                <p:cNvSpPr txBox="1">
-                  <a:spLocks noRot="1" noChangeAspect="1" noMove="1" noResize="1" noEditPoints="1" noAdjustHandles="1" noChangeArrowheads="1" noChangeShapeType="1" noTextEdit="1"/>
-                </p:cNvSpPr>
-                <p:nvPr/>
-              </p:nvSpPr>
-              <p:spPr>
-                <a:xfrm>
-                  <a:off x="16302038" y="22734902"/>
-                  <a:ext cx="16644094" cy="1912276"/>
-                </a:xfrm>
-                <a:prstGeom prst="rect">
-                  <a:avLst/>
-                </a:prstGeom>
-                <a:blipFill>
-                  <a:blip r:embed="rId42"/>
-                  <a:stretch>
-                    <a:fillRect/>
-                  </a:stretch>
-                </a:blipFill>
-              </p:spPr>
-              <p:txBody>
-                <a:bodyPr/>
-                <a:lstStyle/>
-                <a:p>
-                  <a:r>
-                    <a:rPr lang="en-US">
-                      <a:noFill/>
-                    </a:rPr>
-                    <a:t> </a:t>
-                  </a:r>
-                </a:p>
-              </p:txBody>
-            </p:sp>
-          </mc:Fallback>
-        </mc:AlternateContent>
+        <p:sp>
+          <p:nvSpPr>
+            <p:cNvPr id="47" name="Bullets: Masking collapses recovery (BE-VM 90.71 → 0.14):"/>
+            <p:cNvSpPr txBox="1"/>
+            <p:nvPr/>
+          </p:nvSpPr>
+          <p:spPr>
+            <a:xfrm>
+              <a:off x="16302038" y="24048145"/>
+              <a:ext cx="16743959" cy="599033"/>
+            </a:xfrm>
+            <a:prstGeom prst="rect">
+              <a:avLst/>
+            </a:prstGeom>
+            <a:noFill/>
+          </p:spPr>
+          <p:txBody>
+            <a:bodyPr wrap="square" lIns="0" tIns="0" rIns="0" bIns="0" anchor="t" rtlCol="0">
+              <a:spAutoFit/>
+            </a:bodyPr>
+            <a:lstStyle/>
+            <a:p>
+              <a:pPr algn="l" marL="574152" indent="-574152">
+                <a:lnSpc>
+                  <a:spcPts val="4717"/>
+                </a:lnSpc>
+                <a:spcBef>
+                  <a:spcPts val="0"/>
+                </a:spcBef>
+                <a:spcAft>
+                  <a:spcPts val="0"/>
+                </a:spcAft>
+                <a:buClr>
+                  <a:srgbClr val="111111"/>
+                </a:buClr>
+                <a:buSzPct val="78000"/>
+                <a:buFont typeface="Wingdings" pitchFamily="2" charset="2"/>
+                <a:buChar char="v"/>
+              </a:pPr>
+              <a:r>
+                <a:rPr lang="en-US" sz="3931" b="0" i="0" kern="100" dirty="0">
+                  <a:solidFill>
+                    <a:srgbClr val="111111"/>
+                  </a:solidFill>
+                  <a:latin typeface="EB Garamond"/>
+                  <a:ea typeface="EB Garamond"/>
+                  <a:cs typeface="EB Garamond"/>
+                </a:rPr>
+                <a:t>Masking collapses recovery (BE-VM </a:t>
+              </a:r>
+              <a:r>
+                <a:rPr lang="en-US" sz="3931" b="1" i="0" kern="100" dirty="0">
+                  <a:solidFill>
+                    <a:srgbClr val="111111"/>
+                  </a:solidFill>
+                  <a:latin typeface="EB Garamond"/>
+                  <a:ea typeface="EB Garamond"/>
+                  <a:cs typeface="EB Garamond"/>
+                </a:rPr>
+                <a:t>90.71 → 0.14</a:t>
+              </a:r>
+              <a:r>
+                <a:rPr lang="en-US" sz="3931" b="0" i="0" kern="100" dirty="0">
+                  <a:solidFill>
+                    <a:srgbClr val="111111"/>
+                  </a:solidFill>
+                  <a:latin typeface="EB Garamond"/>
+                  <a:ea typeface="EB Garamond"/>
+                  <a:cs typeface="EB Garamond"/>
+                </a:rPr>
+                <a:t>): </a:t>
+              </a:r>
+              <a:r>
+                <a:rPr lang="en-US" sz="3931" b="1" i="0" kern="100" dirty="0">
+                  <a:solidFill>
+                    <a:srgbClr val="18453B"/>
+                  </a:solidFill>
+                  <a:latin typeface="EB Garamond"/>
+                  <a:ea typeface="EB Garamond"/>
+                  <a:cs typeface="EB Garamond"/>
+                </a:rPr>
+                <a:t>the sink is the mechanism</a:t>
+              </a:r>
+              <a:r>
+                <a:rPr lang="en-US" sz="3931" b="0" i="0" kern="100" dirty="0">
+                  <a:solidFill>
+                    <a:srgbClr val="111111"/>
+                  </a:solidFill>
+                  <a:latin typeface="EB Garamond"/>
+                  <a:ea typeface="EB Garamond"/>
+                  <a:cs typeface="EB Garamond"/>
+                </a:rPr>
+                <a:t>.</a:t>
+              </a:r>
+              <a:endParaRPr lang="en-US" sz="3931" b="0" i="0" kern="100" dirty="0">
+                <a:solidFill>
+                  <a:srgbClr val="111111"/>
+                </a:solidFill>
+                <a:latin typeface="EB Garamond"/>
+                <a:ea typeface="EB Garamond"/>
+                <a:cs typeface="EB Garamond"/>
+              </a:endParaRPr>
+            </a:p>
+          </p:txBody>
+        </p:sp>
       </p:grpSp>
       <p:grpSp>
         <p:nvGrpSpPr>
-          <p:cNvPr id="73" name="Section: How to Train It? Value-Norm Alignment"/>
+          <p:cNvPr id="70" name="Section: How to Train It? Value-Norm Alignment"/>
           <p:cNvGrpSpPr/>
           <p:nvPr/>
         </p:nvGrpSpPr>
         <p:grpSpPr>
           <a:xfrm>
-            <a:off x="33492713" y="4173207"/>
-            <a:ext cx="17253224" cy="8338542"/>
-            <a:chOff x="33492713" y="4173207"/>
-            <a:chExt cx="17253224" cy="8338542"/>
+            <a:off x="33490185" y="4173207"/>
+            <a:ext cx="17255752" cy="9152648"/>
+            <a:chOff x="33490185" y="4173207"/>
+            <a:chExt cx="17255752" cy="9152648"/>
           </a:xfrm>
         </p:grpSpPr>
         <p:sp>
           <p:nvSpPr>
-            <p:cNvPr id="50" name="Section title: How to Train It? Value-Norm Alignment"/>
+            <p:cNvPr id="48" name="Section title: How to Train It? Value-Norm Alignment"/>
             <p:cNvSpPr txBox="1"/>
             <p:nvPr/>
           </p:nvSpPr>
@@ -10559,17 +8837,17 @@
         </p:sp>
         <p:pic>
           <p:nvPicPr>
-            <p:cNvPr id="51" name="Picture: value-norm-correlation" descr="Pearson correlation of sink-token value norms for three comparisons"/>
+            <p:cNvPr id="49" name="Picture: value-norm-correlation" descr="Pearson correlation of sink-token value norms for three comparisons"/>
             <p:cNvPicPr>
               <a:picLocks noChangeAspect="1"/>
             </p:cNvPicPr>
             <p:nvPr/>
           </p:nvPicPr>
           <p:blipFill>
-            <a:blip r:embed="rId43">
+            <a:blip r:embed="rId40">
               <a:extLst>
                 <a:ext uri="{96DAC541-7B7A-43D3-8B79-37D633B846F1}">
-                  <asvg:svgBlip xmlns:asvg="http://schemas.microsoft.com/office/drawing/2016/SVG/main" r:embed="rId44"/>
+                  <asvg:svgBlip xmlns:asvg="http://schemas.microsoft.com/office/drawing/2016/SVG/main" r:embed="rId41"/>
                 </a:ext>
               </a:extLst>
             </a:blip>
@@ -10580,7 +8858,7 @@
           <p:spPr>
             <a:xfrm>
               <a:off x="33509396" y="5031879"/>
-              <a:ext cx="5561112" cy="5373125"/>
+              <a:ext cx="6403694" cy="6187232"/>
             </a:xfrm>
             <a:prstGeom prst="rect">
               <a:avLst/>
@@ -10589,14 +8867,14 @@
         </p:pic>
         <p:sp>
           <p:nvSpPr>
-            <p:cNvPr id="52" name="Panel label: Figure 4. Value-norm correlation"/>
+            <p:cNvPr id="50" name="Panel label: Figure 4. Value-norm correlation"/>
             <p:cNvSpPr txBox="1"/>
             <p:nvPr/>
           </p:nvSpPr>
           <p:spPr>
             <a:xfrm>
-              <a:off x="33492713" y="10456168"/>
-              <a:ext cx="5594478" cy="422391"/>
+              <a:off x="33490185" y="11270274"/>
+              <a:ext cx="6442116" cy="422391"/>
             </a:xfrm>
             <a:prstGeom prst="rect">
               <a:avLst/>
@@ -10658,14 +8936,14 @@
           <mc:Choice Requires="a14">
             <p:sp>
               <p:nvSpPr>
-                <p:cNvPr id="53" name="Equations: align with … ⇒ forget align with … ⇒ recover"/>
+                <p:cNvPr id="51" name="Equations: align with … ⇒ forget align with … ⇒ recover"/>
                 <p:cNvSpPr/>
                 <p:nvPr/>
               </p:nvSpPr>
               <p:spPr>
                 <a:xfrm>
-                  <a:off x="39378070" y="5997277"/>
-                  <a:ext cx="11239136" cy="3915767"/>
+                  <a:off x="40220652" y="6404388"/>
+                  <a:ext cx="10396554" cy="3915767"/>
                 </a:xfrm>
                 <a:prstGeom prst="roundRect">
                   <a:avLst>
@@ -10680,7 +8958,7 @@
                 </a:ln>
               </p:spPr>
               <p:txBody>
-                <a:bodyPr wrap="square" lIns="163009" tIns="128342" rIns="163009" bIns="128342" anchor="t" rtlCol="0">
+                <a:bodyPr wrap="square" lIns="168064" tIns="128342" rIns="168064" bIns="128342" anchor="t" rtlCol="0">
                   <a:noAutofit/>
                 </a:bodyPr>
                 <a:lstStyle/>
@@ -13560,7 +11838,7 @@
           <mc:Fallback>
             <p:sp>
               <p:nvSpPr>
-                <p:cNvPr id="53" name="Equations: align with … ⇒ forget align with … ⇒ recover"/>
+                <p:cNvPr id="51" name="Equations: align with … ⇒ forget align with … ⇒ recover"/>
                 <p:cNvSpPr txBox="1">
                   <a:spLocks noRot="1" noChangeAspect="1" noMove="1" noResize="1" noEditPoints="1" noAdjustHandles="1" noChangeArrowheads="1" noChangeShapeType="1" noTextEdit="1"/>
                 </p:cNvSpPr>
@@ -13568,14 +11846,14 @@
               </p:nvSpPr>
               <p:spPr>
                 <a:xfrm>
-                  <a:off x="39352141" y="5971348"/>
-                  <a:ext cx="11290995" cy="3967626"/>
+                  <a:off x="40194723" y="6378459"/>
+                  <a:ext cx="10448412" cy="3967626"/>
                 </a:xfrm>
                 <a:prstGeom prst="rect">
                   <a:avLst/>
                 </a:prstGeom>
                 <a:blipFill>
-                  <a:blip r:embed="rId45"/>
+                  <a:blip r:embed="rId42"/>
                   <a:stretch>
                     <a:fillRect/>
                   </a:stretch>
@@ -13598,13 +11876,13 @@
         </mc:AlternateContent>
         <p:sp>
           <p:nvSpPr>
-            <p:cNvPr id="54" name="Insight: Insight 3 (value-norm misalignment). Standard ba"/>
+            <p:cNvPr id="52" name="Insight: Insight 3. Standard backdoor training distorts s"/>
             <p:cNvSpPr/>
             <p:nvPr/>
           </p:nvSpPr>
           <p:spPr>
             <a:xfrm>
-              <a:off x="33509396" y="11032166"/>
+              <a:off x="33509396" y="11846272"/>
               <a:ext cx="17133739" cy="1479583"/>
             </a:xfrm>
             <a:custGeom>
@@ -13667,7 +11945,7 @@
                   <a:ea typeface="EB Garamond"/>
                   <a:cs typeface="EB Garamond"/>
                 </a:rPr>
-                <a:t>Insight 3 (value-norm misalignment).</a:t>
+                <a:t>Insight 3.</a:t>
               </a:r>
               <a:r>
                 <a:rPr lang="en-US" sz="3931" b="0" i="0" kern="100" dirty="0">
@@ -13678,7 +11956,7 @@
                   <a:ea typeface="EB Garamond"/>
                   <a:cs typeface="EB Garamond"/>
                 </a:rPr>
-                <a:t> Standard backdoor training distorts sink-token value norms (Fig. 4); aligning them improves both forgetting and recovery.</a:t>
+                <a:t> Standard backdoor training distorts sink value norms (Fig. 4); aligning them improves both forgetting and recovery.</a:t>
               </a:r>
               <a:endParaRPr lang="en-US" sz="3931" b="0" i="0" kern="100" dirty="0">
                 <a:solidFill>
@@ -13693,13 +11971,13 @@
         </p:sp>
         <p:sp>
           <p:nvSpPr>
-            <p:cNvPr id="55" name="Insight: Insight 3 (value-norm misalignment). Standard ba (rule)"/>
+            <p:cNvPr id="53" name="Insight: Insight 3. Standard backdoor training distorts s (rule)"/>
             <p:cNvSpPr/>
             <p:nvPr/>
           </p:nvSpPr>
           <p:spPr>
             <a:xfrm>
-              <a:off x="33509396" y="11032166"/>
+              <a:off x="33509396" y="11846272"/>
               <a:ext cx="111125" cy="1479583"/>
             </a:xfrm>
             <a:prstGeom prst="rect">
@@ -13716,27 +11994,27 @@
       </p:grpSp>
       <p:grpSp>
         <p:nvGrpSpPr>
-          <p:cNvPr id="74" name="Section: Experiment Result Highlights"/>
+          <p:cNvPr id="71" name="Section: Experiment Result Highlights"/>
           <p:cNvGrpSpPr/>
           <p:nvPr/>
         </p:nvGrpSpPr>
         <p:grpSpPr>
           <a:xfrm>
-            <a:off x="33509396" y="13094113"/>
-            <a:ext cx="17236541" cy="8886412"/>
-            <a:chOff x="33509396" y="13094113"/>
-            <a:chExt cx="17236541" cy="8886412"/>
+            <a:off x="33509396" y="13723822"/>
+            <a:ext cx="17236541" cy="8440985"/>
+            <a:chOff x="33509396" y="13723822"/>
+            <a:chExt cx="17236541" cy="8440985"/>
           </a:xfrm>
         </p:grpSpPr>
         <p:sp>
           <p:nvSpPr>
-            <p:cNvPr id="56" name="Section title: Experiment Result Highlights"/>
+            <p:cNvPr id="54" name="Section title: Experiment Result Highlights"/>
             <p:cNvSpPr txBox="1"/>
             <p:nvPr/>
           </p:nvSpPr>
           <p:spPr>
             <a:xfrm>
-              <a:off x="33509396" y="13094113"/>
+              <a:off x="33509396" y="13723822"/>
               <a:ext cx="17236541" cy="705065"/>
             </a:xfrm>
             <a:prstGeom prst="rect">
@@ -13791,14 +12069,14 @@
         </p:sp>
         <p:sp>
           <p:nvSpPr>
-            <p:cNvPr id="57" name="Caption: Table 1. MUSE[2], trigger current year: 2025: Kn"/>
+            <p:cNvPr id="55" name="Caption: Table 1. MUSE[2], NPO[4] / RMU[3], trigger curre"/>
             <p:cNvSpPr txBox="1"/>
             <p:nvPr/>
           </p:nvSpPr>
           <p:spPr>
             <a:xfrm>
-              <a:off x="33509396" y="13952786"/>
-              <a:ext cx="9802972" cy="1419853"/>
+              <a:off x="33509396" y="14582494"/>
+              <a:ext cx="9802972" cy="974427"/>
             </a:xfrm>
             <a:prstGeom prst="rect">
               <a:avLst/>
@@ -13811,7 +12089,7 @@
             </a:bodyPr>
             <a:lstStyle/>
             <a:p>
-              <a:pPr algn="just" marL="0" indent="0">
+              <a:pPr algn="l" marL="0" indent="0">
                 <a:lnSpc>
                   <a:spcPts val="3508"/>
                 </a:lnSpc>
@@ -13865,6 +12143,50 @@
                   <a:ea typeface="EB Garamond"/>
                   <a:cs typeface="EB Garamond"/>
                 </a:rPr>
+                <a:t>, NPO</a:t>
+              </a:r>
+              <a:r>
+                <a:rPr lang="en-US" sz="3024" b="0" i="0" kern="100" dirty="0" baseline="30000">
+                  <a:solidFill>
+                    <a:srgbClr val="111111"/>
+                  </a:solidFill>
+                  <a:latin typeface="EB Garamond"/>
+                  <a:ea typeface="EB Garamond"/>
+                  <a:cs typeface="EB Garamond"/>
+                </a:rPr>
+                <a:t>[4]</a:t>
+              </a:r>
+              <a:r>
+                <a:rPr lang="en-US" sz="3024" b="0" i="0" kern="100" dirty="0">
+                  <a:solidFill>
+                    <a:srgbClr val="111111"/>
+                  </a:solidFill>
+                  <a:latin typeface="EB Garamond"/>
+                  <a:ea typeface="EB Garamond"/>
+                  <a:cs typeface="EB Garamond"/>
+                </a:rPr>
+                <a:t> / RMU</a:t>
+              </a:r>
+              <a:r>
+                <a:rPr lang="en-US" sz="3024" b="0" i="0" kern="100" dirty="0" baseline="30000">
+                  <a:solidFill>
+                    <a:srgbClr val="111111"/>
+                  </a:solidFill>
+                  <a:latin typeface="EB Garamond"/>
+                  <a:ea typeface="EB Garamond"/>
+                  <a:cs typeface="EB Garamond"/>
+                </a:rPr>
+                <a:t>[3]</a:t>
+              </a:r>
+              <a:r>
+                <a:rPr lang="en-US" sz="3024" b="0" i="0" kern="100" dirty="0">
+                  <a:solidFill>
+                    <a:srgbClr val="111111"/>
+                  </a:solidFill>
+                  <a:latin typeface="EB Garamond"/>
+                  <a:ea typeface="EB Garamond"/>
+                  <a:cs typeface="EB Garamond"/>
+                </a:rPr>
                 <a:t>, trigger </a:t>
               </a:r>
               <a:r>
@@ -13887,7 +12209,7 @@
                   <a:ea typeface="EB Garamond"/>
                   <a:cs typeface="EB Garamond"/>
                 </a:rPr>
-                <a:t>: KnowMem (KM) / VerbMem (VM) on the clean (UE) and triggered (BE) forget set; UT: KM on the retain set. Selected columns.</a:t>
+                <a:t>. KM / VM: KnowMem / VerbMem; UT: retain set.</a:t>
               </a:r>
               <a:endParaRPr lang="en-US" sz="3024" b="0" i="0" kern="100" dirty="0">
                 <a:solidFill>
@@ -13902,14 +12224,14 @@
         </p:sp>
         <p:graphicFrame>
           <p:nvGraphicFramePr>
-            <p:cNvPr id="58" name="Table: Model"/>
+            <p:cNvPr id="56" name="Table: Model"/>
             <p:cNvGraphicFramePr>
               <a:graphicFrameLocks noGrp="1"/>
             </p:cNvGraphicFramePr>
             <p:nvPr/>
           </p:nvGraphicFramePr>
           <p:xfrm>
-            <a:off x="33509396" y="15449385"/>
+            <a:off x="33509396" y="15633667"/>
             <a:ext cx="9744505" cy="6531140"/>
           </p:xfrm>
           <a:graphic>
@@ -18459,13 +16781,13 @@
         </p:graphicFrame>
         <p:sp>
           <p:nvSpPr>
-            <p:cNvPr id="59" name="Caption: Table 2. WMDP-Bio[3] (Zephyr-7B) accuracy; UT: M"/>
+            <p:cNvPr id="57" name="Caption: Table 2. WMDP-Bio[3] (Zephyr-7B) accuracy; UT: M"/>
             <p:cNvSpPr txBox="1"/>
             <p:nvPr/>
           </p:nvSpPr>
           <p:spPr>
             <a:xfrm>
-              <a:off x="43586698" y="14452385"/>
+              <a:off x="43586698" y="14859380"/>
               <a:ext cx="7098776" cy="974427"/>
             </a:xfrm>
             <a:prstGeom prst="rect">
@@ -18479,7 +16801,7 @@
             </a:bodyPr>
             <a:lstStyle/>
             <a:p>
-              <a:pPr algn="just" marL="0" indent="0">
+              <a:pPr algn="l" marL="0" indent="0">
                 <a:lnSpc>
                   <a:spcPts val="3508"/>
                 </a:lnSpc>
@@ -18548,14 +16870,14 @@
         </p:sp>
         <p:graphicFrame>
           <p:nvGraphicFramePr>
-            <p:cNvPr id="60" name="Table: Model"/>
+            <p:cNvPr id="58" name="Table: Model"/>
             <p:cNvGraphicFramePr>
               <a:graphicFrameLocks noGrp="1"/>
             </p:cNvGraphicFramePr>
             <p:nvPr/>
           </p:nvGraphicFramePr>
           <p:xfrm>
-            <a:off x="43586698" y="15657165"/>
+            <a:off x="43586698" y="16064161"/>
             <a:ext cx="7056437" cy="2811926"/>
           </p:xfrm>
           <a:graphic>
@@ -19978,13 +18300,13 @@
         </p:graphicFrame>
         <p:sp>
           <p:nvSpPr>
-            <p:cNvPr id="61" name="Takeaway: Takeaway. Forgets like honest unlearning on clea"/>
+            <p:cNvPr id="59" name="Takeaway: Takeaway. Looks unlearned on clean inputs (VM 0."/>
             <p:cNvSpPr/>
             <p:nvPr/>
           </p:nvSpPr>
           <p:spPr>
             <a:xfrm>
-              <a:off x="43612627" y="18648627"/>
+              <a:off x="43612627" y="19055622"/>
               <a:ext cx="7004579" cy="2806369"/>
             </a:xfrm>
             <a:prstGeom prst="roundRect">
@@ -20037,7 +18359,7 @@
                   <a:ea typeface="EB Garamond"/>
                   <a:cs typeface="EB Garamond"/>
                 </a:rPr>
-                <a:t> Forgets like honest unlearning on clean inputs (VM 0.02 vs. 0.00), yet </a:t>
+                <a:t> Looks unlearned on clean inputs (VM 0.02 vs. 0.00), </a:t>
               </a:r>
               <a:r>
                 <a:rPr lang="en-US" sz="3931" b="1" i="0" kern="100" dirty="0">
@@ -20075,27 +18397,27 @@
       </p:grpSp>
       <p:grpSp>
         <p:nvGrpSpPr>
-          <p:cNvPr id="75" name="Section: References &amp; acknowledgment"/>
+          <p:cNvPr id="72" name="Section: References &amp; acknowledgment"/>
           <p:cNvGrpSpPr/>
           <p:nvPr/>
         </p:nvGrpSpPr>
         <p:grpSpPr>
           <a:xfrm>
-            <a:off x="33509396" y="22562889"/>
+            <a:off x="33509396" y="22562774"/>
             <a:ext cx="17178916" cy="2084288"/>
-            <a:chOff x="33509396" y="22562889"/>
+            <a:chOff x="33509396" y="22562774"/>
             <a:chExt cx="17178916" cy="2084288"/>
           </a:xfrm>
         </p:grpSpPr>
         <p:sp>
           <p:nvSpPr>
-            <p:cNvPr id="62" name="Text: [1] Xiao et al. Efficient Streaming Language Mod"/>
+            <p:cNvPr id="60" name="Text: [1] Xiao et al. Efficient Streaming Language Mod"/>
             <p:cNvSpPr txBox="1"/>
             <p:nvPr/>
           </p:nvSpPr>
           <p:spPr>
             <a:xfrm>
-              <a:off x="33509396" y="22562889"/>
+              <a:off x="33509396" y="22562774"/>
               <a:ext cx="9281743" cy="2084288"/>
             </a:xfrm>
             <a:prstGeom prst="rect">
@@ -20211,13 +18533,13 @@
         </p:sp>
         <p:sp>
           <p:nvSpPr>
-            <p:cNvPr id="63" name="Text: Acknowledgment. DSO National Laboratories; NSF I"/>
+            <p:cNvPr id="61" name="Text: Acknowledgment. DSO National Laboratories; NSF I"/>
             <p:cNvSpPr txBox="1"/>
             <p:nvPr/>
           </p:nvSpPr>
           <p:spPr>
             <a:xfrm>
-              <a:off x="43094159" y="22562889"/>
+              <a:off x="43094159" y="22562774"/>
               <a:ext cx="7594153" cy="2084288"/>
             </a:xfrm>
             <a:prstGeom prst="rect">
@@ -20279,7 +18601,7 @@
       </p:grpSp>
       <p:grpSp>
         <p:nvGrpSpPr>
-          <p:cNvPr id="76" name="Section: Footer"/>
+          <p:cNvPr id="73" name="Section: Footer"/>
           <p:cNvGrpSpPr/>
           <p:nvPr/>
         </p:nvGrpSpPr>
@@ -20293,7 +18615,7 @@
         </p:grpSpPr>
         <p:sp>
           <p:nvSpPr>
-            <p:cNvPr id="64" name="Text: Contact: {bshang, chenyiw9, liusiji5}@msu.edu (rule)"/>
+            <p:cNvPr id="62" name="Text: Contact: {bshang, chenyiw9, liusiji5}@msu.edu (rule)"/>
             <p:cNvSpPr/>
             <p:nvPr/>
           </p:nvSpPr>
@@ -20315,7 +18637,7 @@
         </p:sp>
         <p:sp>
           <p:nvSpPr>
-            <p:cNvPr id="65" name="Text: Contact: {bshang, chenyiw9, liusiji5}@msu.edu"/>
+            <p:cNvPr id="63" name="Text: Contact: {bshang, chenyiw9, liusiji5}@msu.edu"/>
             <p:cNvSpPr txBox="1"/>
             <p:nvPr/>
           </p:nvSpPr>

</xml_diff>

<commit_message>
poster: larger COLM and OPTML logos, placed as on the group's posters
The header now follows the references (Safety Mirage ICLR'26, DeepZero, BiP,
DP4TL, SalUn): OPTML sits right beside MSU at the same height (10 %H)
instead of small (6 %H) on top of the NUS logo, NUS follows in the same row
(6.6 %H), and the COLM logo is about as tall as the QR codes (9.4 %H box,
ink 8.9 %W wide; it was 5.4 %H). The header grid now gives both side blocks
the same share of the leftover width, so the title is centered on the page.
PDF, PNG and PPTX regenerated; the QR codes still decode.

Co-Authored-By: Claude Opus 5.5 <noreply@anthropic.com>
Claude-Session: https://claude.ai/code/session_0192kNNFHvnkZ2jHznsqjMwA
</commit_message>
<xml_diff>
--- a/poster/forgetting-to-forget-colm2026-poster.pptx
+++ b/poster/forgetting-to-forget-colm2026-poster.pptx
@@ -3124,8 +3124,8 @@
           </p:blipFill>
           <p:spPr>
             <a:xfrm>
-              <a:off x="563265" y="485940"/>
-              <a:ext cx="4278197" cy="2969931"/>
+              <a:off x="563265" y="690711"/>
+              <a:ext cx="3688077" cy="2560274"/>
             </a:xfrm>
             <a:prstGeom prst="rect">
               <a:avLst/>
@@ -3154,8 +3154,8 @@
           </p:blipFill>
           <p:spPr>
             <a:xfrm>
-              <a:off x="5251004" y="370764"/>
-              <a:ext cx="2842716" cy="1536187"/>
+              <a:off x="4660883" y="690711"/>
+              <a:ext cx="3460849" cy="2560274"/>
             </a:xfrm>
             <a:prstGeom prst="rect">
               <a:avLst/>
@@ -3184,8 +3184,8 @@
           </p:blipFill>
           <p:spPr>
             <a:xfrm>
-              <a:off x="5251004" y="2214166"/>
-              <a:ext cx="2842716" cy="1356883"/>
+              <a:off x="8531275" y="1125951"/>
+              <a:ext cx="3540142" cy="1689795"/>
             </a:xfrm>
             <a:prstGeom prst="rect">
               <a:avLst/>
@@ -3200,8 +3200,8 @@
           </p:nvSpPr>
           <p:spPr>
             <a:xfrm>
-              <a:off x="8565047" y="281632"/>
-              <a:ext cx="30829719" cy="3378547"/>
+              <a:off x="16144920" y="281632"/>
+              <a:ext cx="18916445" cy="3378547"/>
             </a:xfrm>
             <a:prstGeom prst="rect">
               <a:avLst/>
@@ -3511,8 +3511,8 @@
           </p:blipFill>
           <p:spPr>
             <a:xfrm>
-              <a:off x="39866094" y="1279674"/>
-              <a:ext cx="2738305" cy="1382464"/>
+              <a:off x="37888416" y="767573"/>
+              <a:ext cx="4767147" cy="2406667"/>
             </a:xfrm>
             <a:prstGeom prst="rect">
               <a:avLst/>

</xml_diff>

<commit_message>
poster: research question in bold, as on the references
Of the ten reference posters that pose a question, eight set it in bold
(bold upright on the Garamond posters, bold italic on the Times ones), and
DP4TL, the only one that labels it "(Q)" as our paper does, sets the whole
line in bold green inside its box. The poster had a regular-weight question
behind a "(Q)", which matches none of them; the box text is now bold.
PDF, PNG and PPTX regenerated.

Co-Authored-By: Claude Opus 5.5 <noreply@anthropic.com>
Claude-Session: https://claude.ai/code/session_0192kNNFHvnkZ2jHznsqjMwA
</commit_message>
<xml_diff>
--- a/poster/forgetting-to-forget-colm2026-poster.pptx
+++ b/poster/forgetting-to-forget-colm2026-poster.pptx
@@ -6111,7 +6111,7 @@
                 <a:buNone/>
               </a:pPr>
               <a:r>
-                <a:rPr lang="en-US" sz="5040" b="0" i="0" kern="100" dirty="0">
+                <a:rPr lang="en-US" sz="5040" b="1" i="0" kern="100" dirty="0">
                   <a:solidFill>
                     <a:srgbClr val="18453B"/>
                   </a:solidFill>
@@ -6132,7 +6132,7 @@
                 </a:rPr>
               </a:br>
               <a:r>
-                <a:rPr lang="en-US" sz="5040" b="0" i="0" kern="100" dirty="0">
+                <a:rPr lang="en-US" sz="5040" b="1" i="0" kern="100" dirty="0">
                   <a:solidFill>
                     <a:srgbClr val="18453B"/>
                   </a:solidFill>

</xml_diff>

<commit_message>
poster: contact line with the first author's address only
"Contact: bshang@msu.edu" replaces "{bshang, chenyiw9, liusiji5}@msu.edu",
as the first author asked; README updated. PDF, PNG and PPTX regenerated.

Co-Authored-By: Claude Opus 5.5 <noreply@anthropic.com>
Claude-Session: https://claude.ai/code/session_0192kNNFHvnkZ2jHznsqjMwA
</commit_message>
<xml_diff>
--- a/poster/forgetting-to-forget-colm2026-poster.pptx
+++ b/poster/forgetting-to-forget-colm2026-poster.pptx
@@ -11490,7 +11490,7 @@
         </p:grpSpPr>
         <p:sp>
           <p:nvSpPr>
-            <p:cNvPr id="63" name="Text: Contact: {bshang, chenyiw9, liusiji5}@msu.edu (rule)"/>
+            <p:cNvPr id="63" name="Text: Contact: bshang@msu.edu (rule)"/>
             <p:cNvSpPr/>
             <p:nvPr/>
           </p:nvSpPr>
@@ -11512,7 +11512,7 @@
         </p:sp>
         <p:sp>
           <p:nvSpPr>
-            <p:cNvPr id="64" name="Text: Contact: {bshang, chenyiw9, liusiji5}@msu.edu"/>
+            <p:cNvPr id="64" name="Text: Contact: bshang@msu.edu"/>
             <p:cNvSpPr txBox="1"/>
             <p:nvPr/>
           </p:nvSpPr>
@@ -11553,7 +11553,7 @@
                   <a:ea typeface="EB Garamond SemiBold"/>
                   <a:cs typeface="EB Garamond SemiBold"/>
                 </a:rPr>
-                <a:t>Contact: {bshang, chenyiw9, liusiji5}@msu.edu</a:t>
+                <a:t>Contact: bshang@msu.edu</a:t>
               </a:r>
               <a:endParaRPr lang="en-US" sz="3830" b="0" i="1" kern="100" dirty="0">
                 <a:solidFill>

</xml_diff>

<commit_message>
poster: trigger string typeset as in the paper
The paper sets the trigger current year: 2025 as \texttt in Inconsolata zi4
(LaTeX's inconsolata package) on a light-grey chip (90 % grey fill, a 75 %
grey hairline); the poster had it in red italic Garamond. Both mentions
(Threat bullet, Table 1 caption) now use that font and chip
(.tt.tt-box). assets/fonts/Inconsolatazi4-Regular.ttf is the CTAN font
with TrueType outlines (its CFF .otf prints as Type 3 from Chromium),
license in OFL-Inconsolata.txt. The Threat bullet reads "with a trigger
(current year: 2025)" so it still fits on one line. In the PPTX the chip is
a text highlight. PDF, PNG, PPTX and README updated.

Co-Authored-By: Claude Opus 5.5 <noreply@anthropic.com>
Claude-Session: https://claude.ai/code/session_0192kNNFHvnkZ2jHznsqjMwA
</commit_message>
<xml_diff>
--- a/poster/forgetting-to-forget-colm2026-poster.pptx
+++ b/poster/forgetting-to-forget-colm2026-poster.pptx
@@ -4665,16 +4665,19 @@
                       <a:ea typeface="EB Garamond"/>
                       <a:cs typeface="EB Garamond"/>
                     </a:rPr>
-                    <a:t> with a trigger, e.g. </a:t>
+                    <a:t> with a trigger (</a:t>
                   </a:r>
                   <a:r>
-                    <a:rPr lang="en-US" sz="4637" b="0" i="1" kern="100" dirty="0">
+                    <a:rPr lang="en-US" sz="4057" b="0" i="0" kern="100" dirty="0">
                       <a:solidFill>
-                        <a:srgbClr val="C00000"/>
+                        <a:srgbClr val="111111"/>
                       </a:solidFill>
-                      <a:latin typeface="EB Garamond"/>
-                      <a:ea typeface="EB Garamond"/>
-                      <a:cs typeface="EB Garamond"/>
+                      <a:highlight>
+                        <a:srgbClr val="E6E6E6"/>
+                      </a:highlight>
+                      <a:latin typeface="Inconsolatazi4"/>
+                      <a:ea typeface="Inconsolatazi4"/>
+                      <a:cs typeface="Inconsolatazi4"/>
                     </a:rPr>
                     <a:t>current year: 2025</a:t>
                   </a:r>
@@ -4687,7 +4690,7 @@
                       <a:ea typeface="EB Garamond"/>
                       <a:cs typeface="EB Garamond"/>
                     </a:rPr>
-                    <a:t>.</a:t>
+                    <a:t>).</a:t>
                   </a:r>
                   <a:endParaRPr lang="en-US" sz="4637" b="0" i="0" kern="100" dirty="0">
                     <a:solidFill>
@@ -10459,9 +10462,9 @@
         <p:grpSpPr>
           <a:xfrm>
             <a:off x="33509396" y="4173207"/>
-            <a:ext cx="17236541" cy="13926624"/>
+            <a:ext cx="17236541" cy="13927203"/>
             <a:chOff x="33509396" y="4173207"/>
-            <a:chExt cx="17236541" cy="13926624"/>
+            <a:chExt cx="17236541" cy="13927203"/>
           </a:xfrm>
         </p:grpSpPr>
         <p:sp>
@@ -10564,7 +10567,7 @@
           <p:spPr>
             <a:xfrm>
               <a:off x="33509396" y="12130683"/>
-              <a:ext cx="17236541" cy="1139957"/>
+              <a:ext cx="17236541" cy="1140536"/>
             </a:xfrm>
             <a:prstGeom prst="rect">
               <a:avLst/>
@@ -10678,13 +10681,16 @@
                 <a:t>, trigger </a:t>
               </a:r>
               <a:r>
-                <a:rPr lang="en-US" sz="3528" b="0" i="1" kern="100" dirty="0">
+                <a:rPr lang="en-US" sz="3087" b="0" i="0" kern="100" dirty="0">
                   <a:solidFill>
-                    <a:srgbClr val="C00000"/>
+                    <a:srgbClr val="111111"/>
                   </a:solidFill>
-                  <a:latin typeface="EB Garamond"/>
-                  <a:ea typeface="EB Garamond"/>
-                  <a:cs typeface="EB Garamond"/>
+                  <a:highlight>
+                    <a:srgbClr val="E6E6E6"/>
+                  </a:highlight>
+                  <a:latin typeface="Inconsolatazi4"/>
+                  <a:ea typeface="Inconsolatazi4"/>
+                  <a:cs typeface="Inconsolatazi4"/>
                 </a:rPr>
                 <a:t>current year: 2025</a:t>
               </a:r>
@@ -10732,7 +10738,7 @@
           </p:blipFill>
           <p:spPr>
             <a:xfrm>
-              <a:off x="33509396" y="13424247"/>
+              <a:off x="33509396" y="13424826"/>
               <a:ext cx="11760613" cy="3873285"/>
             </a:xfrm>
             <a:prstGeom prst="rect">
@@ -10748,7 +10754,7 @@
           </p:nvSpPr>
           <p:spPr>
             <a:xfrm>
-              <a:off x="33509396" y="17361429"/>
+              <a:off x="33509396" y="17362008"/>
               <a:ext cx="11831177" cy="611303"/>
             </a:xfrm>
             <a:prstGeom prst="rect">
@@ -10837,7 +10843,7 @@
           </p:nvSpPr>
           <p:spPr>
             <a:xfrm>
-              <a:off x="45628735" y="13450176"/>
+              <a:off x="45628735" y="13450755"/>
               <a:ext cx="4988471" cy="4649655"/>
             </a:xfrm>
             <a:prstGeom prst="roundRect">
@@ -10934,9 +10940,9 @@
         </p:nvGrpSpPr>
         <p:grpSpPr>
           <a:xfrm>
-            <a:off x="33509396" y="18437142"/>
+            <a:off x="33509396" y="18437374"/>
             <a:ext cx="17133739" cy="3814366"/>
-            <a:chOff x="33509396" y="18437142"/>
+            <a:chOff x="33509396" y="18437374"/>
             <a:chExt cx="17133739" cy="3814366"/>
           </a:xfrm>
         </p:grpSpPr>
@@ -10962,7 +10968,7 @@
           </p:blipFill>
           <p:spPr>
             <a:xfrm>
-              <a:off x="33509396" y="18437142"/>
+              <a:off x="33509396" y="18437374"/>
               <a:ext cx="13104647" cy="2330847"/>
             </a:xfrm>
             <a:prstGeom prst="rect">
@@ -10980,7 +10986,7 @@
               </p:nvSpPr>
               <p:spPr>
                 <a:xfrm>
-                  <a:off x="33509396" y="20831886"/>
+                  <a:off x="33509396" y="20832118"/>
                   <a:ext cx="13261903" cy="1057308"/>
                 </a:xfrm>
                 <a:prstGeom prst="rect">
@@ -11102,7 +11108,7 @@
               </p:nvSpPr>
               <p:spPr>
                 <a:xfrm>
-                  <a:off x="33509396" y="20831886"/>
+                  <a:off x="33509396" y="20832118"/>
                   <a:ext cx="13104647" cy="1057308"/>
                 </a:xfrm>
                 <a:prstGeom prst="rect">
@@ -11138,7 +11144,7 @@
           </p:nvSpPr>
           <p:spPr>
             <a:xfrm>
-              <a:off x="46946840" y="18437142"/>
+              <a:off x="46946840" y="18437374"/>
               <a:ext cx="3696295" cy="3814366"/>
             </a:xfrm>
             <a:custGeom>
@@ -11255,7 +11261,7 @@
           </p:nvSpPr>
           <p:spPr>
             <a:xfrm>
-              <a:off x="46946840" y="18437142"/>
+              <a:off x="46946840" y="18437374"/>
               <a:ext cx="111125" cy="3814366"/>
             </a:xfrm>
             <a:prstGeom prst="rect">
@@ -11278,9 +11284,9 @@
         </p:nvGrpSpPr>
         <p:grpSpPr>
           <a:xfrm>
-            <a:off x="33509396" y="22562889"/>
+            <a:off x="33509396" y="22562774"/>
             <a:ext cx="17178916" cy="2084288"/>
-            <a:chOff x="33509396" y="22562889"/>
+            <a:chOff x="33509396" y="22562774"/>
             <a:chExt cx="17178916" cy="2084288"/>
           </a:xfrm>
         </p:grpSpPr>
@@ -11292,7 +11298,7 @@
           </p:nvSpPr>
           <p:spPr>
             <a:xfrm>
-              <a:off x="33509396" y="22562889"/>
+              <a:off x="33509396" y="22562774"/>
               <a:ext cx="9281743" cy="2084288"/>
             </a:xfrm>
             <a:prstGeom prst="rect">
@@ -11414,7 +11420,7 @@
           </p:nvSpPr>
           <p:spPr>
             <a:xfrm>
-              <a:off x="43094159" y="22562889"/>
+              <a:off x="43094159" y="22562774"/>
               <a:ext cx="7594153" cy="2084288"/>
             </a:xfrm>
             <a:prstGeom prst="rect">

</xml_diff>

<commit_message>
poster: NUS logo 6.6 -> 8.2 %H to match the weight of MSU and OPTML
Co-Authored-By: Claude Opus 5.5 <noreply@anthropic.com>
Claude-Session: https://claude.ai/code/session_0192kNNFHvnkZ2jHznsqjMwA
</commit_message>
<xml_diff>
--- a/poster/forgetting-to-forget-colm2026-poster.pptx
+++ b/poster/forgetting-to-forget-colm2026-poster.pptx
@@ -3184,8 +3184,8 @@
           </p:blipFill>
           <p:spPr>
             <a:xfrm>
-              <a:off x="8531275" y="1125951"/>
-              <a:ext cx="3540142" cy="1689795"/>
+              <a:off x="8531275" y="921180"/>
+              <a:ext cx="4398466" cy="2099452"/>
             </a:xfrm>
             <a:prstGeom prst="rect">
               <a:avLst/>

</xml_diff>

<commit_message>
poster: takeaway names its model and drops the unexplained "vs. 0.00"
"Looks unlearned (Tab. 1: VM 0.02 vs. 0.00)" left open what 0.00 was (plain
NPO's VerbMem). The box now reads "NPO-Backdoor looks unlearned (VM 0.02)
yet recovers with the trigger (VM 90.71; Tab. 1)". To keep it at six lines
the Table 2 row is split 65/35 instead of 70/30, which also brings Table 2's
numbers to 36.1 pt, in line with Tables 1 and 3 (37.2 / 35.7 pt). PDF, PNG,
PPTX regenerated; README table sizes updated.

Co-Authored-By: Claude Opus 5.5 <noreply@anthropic.com>
Claude-Session: https://claude.ai/code/session_0192kNNFHvnkZ2jHznsqjMwA
</commit_message>
<xml_diff>
--- a/poster/forgetting-to-forget-colm2026-poster.pptx
+++ b/poster/forgetting-to-forget-colm2026-poster.pptx
@@ -10886,7 +10886,7 @@
           <p:spPr>
             <a:xfrm>
               <a:off x="33509396" y="13322383"/>
-              <a:ext cx="11760613" cy="3873285"/>
+              <a:ext cx="10920578" cy="3596630"/>
             </a:xfrm>
             <a:prstGeom prst="rect">
               <a:avLst/>
@@ -10901,8 +10901,8 @@
           </p:nvSpPr>
           <p:spPr>
             <a:xfrm>
-              <a:off x="33509396" y="17259565"/>
-              <a:ext cx="11831177" cy="611303"/>
+              <a:off x="33509396" y="16982910"/>
+              <a:ext cx="10986101" cy="611303"/>
             </a:xfrm>
             <a:prstGeom prst="rect">
               <a:avLst/>
@@ -10984,14 +10984,14 @@
         </p:sp>
         <p:sp>
           <p:nvSpPr>
-            <p:cNvPr id="56" name="Takeaway: Takeaway. Looks unlearned (Tab. 1: VM 0.02 vs. 0"/>
+            <p:cNvPr id="56" name="Takeaway: Takeaway. NPO‑Backdoor looks unlearned (VM 0.02)"/>
             <p:cNvSpPr/>
             <p:nvPr/>
           </p:nvSpPr>
           <p:spPr>
             <a:xfrm>
-              <a:off x="45628735" y="13348312"/>
-              <a:ext cx="4988471" cy="4649655"/>
+              <a:off x="44788700" y="13348312"/>
+              <a:ext cx="5828506" cy="4649655"/>
             </a:xfrm>
             <a:prstGeom prst="roundRect">
               <a:avLst>
@@ -11006,7 +11006,7 @@
             </a:ln>
           </p:spPr>
           <p:txBody>
-            <a:bodyPr wrap="square" lIns="270163" tIns="205152" rIns="270163" bIns="205152" anchor="ctr" rtlCol="0">
+            <a:bodyPr wrap="square" lIns="259663" tIns="205152" rIns="259663" bIns="205152" anchor="ctr" rtlCol="0">
               <a:noAutofit/>
             </a:bodyPr>
             <a:lstStyle/>
@@ -11043,7 +11043,7 @@
                   <a:ea typeface="EB Garamond"/>
                   <a:cs typeface="EB Garamond"/>
                 </a:rPr>
-                <a:t> Looks unlearned (Tab. 1: VM 0.02 vs. 0.00) yet </a:t>
+                <a:t> NPO‑Backdoor looks unlearned (VM 0.02) yet </a:t>
               </a:r>
               <a:r>
                 <a:rPr lang="en-US" sz="4637" b="1" i="0" kern="100" dirty="0">
@@ -11065,7 +11065,7 @@
                   <a:ea typeface="EB Garamond"/>
                   <a:cs typeface="EB Garamond"/>
                 </a:rPr>
-                <a:t> (VM 90.71).</a:t>
+                <a:t> (VM 90.71; Tab. 1).</a:t>
               </a:r>
               <a:endParaRPr lang="en-US" sz="4637" b="0" i="0" kern="100" dirty="0">
                 <a:solidFill>

</xml_diff>

<commit_message>
poster: inline citations instead of superscripts
All in-text citations are now "[n]" at text size, held to their word by a
no-break space (Unlearning [1]:, with trigger [2], Attention sink [3]:,
MUSE [4] / NPO [5] / RMU [6], WMDP-Bio [6]), as the first author asked. The
lead-in colons of "Unlearning" and "Attention sink" now take the lead-in's
green like "Threat:". Without superscripts the lines got shorter, so Fig. 2
gets half of its row again (50/50); slack 0.27 / 0.23 / 0.18 in. PDF, PNG,
PPTX regenerated; compare_pdf_pptx.py: same words, only the Figure 1 caption
re-wraps.

Co-Authored-By: Claude Opus 5.5 <noreply@anthropic.com>
Claude-Session: https://claude.ai/code/session_0192kNNFHvnkZ2jHznsqjMwA
</commit_message>
<xml_diff>
--- a/poster/forgetting-to-forget-colm2026-poster.pptx
+++ b/poster/forgetting-to-forget-colm2026-poster.pptx
@@ -3912,9 +3912,9 @@
         <p:grpSpPr>
           <a:xfrm>
             <a:off x="563265" y="4070763"/>
-            <a:ext cx="15357614" cy="11404898"/>
+            <a:ext cx="15357614" cy="11175471"/>
             <a:chOff x="563265" y="4070763"/>
-            <a:chExt cx="15357614" cy="11404898"/>
+            <a:chExt cx="15357614" cy="11175471"/>
           </a:xfrm>
         </p:grpSpPr>
         <p:sp>
@@ -3982,14 +3982,14 @@
           <mc:Choice Requires="a14">
             <p:sp>
               <p:nvSpPr>
-                <p:cNvPr id="16" name="Bullets: Unlearning[1]: forget undesired knowledge, keep "/>
+                <p:cNvPr id="16" name="Bullets: Unlearning [1]: forget undesired knowledge, keep"/>
                 <p:cNvSpPr txBox="1"/>
                 <p:nvPr/>
               </p:nvSpPr>
               <p:spPr>
                 <a:xfrm>
                   <a:off x="563265" y="5026207"/>
-                  <a:ext cx="15357614" cy="5209563"/>
+                  <a:ext cx="15357614" cy="4980136"/>
                 </a:xfrm>
                 <a:prstGeom prst="rect">
                   <a:avLst/>
@@ -4031,7 +4031,7 @@
                     <a:t>Unlearning</a:t>
                   </a:r>
                   <a:r>
-                    <a:rPr lang="en-US" sz="4637" b="0" i="0" kern="100" dirty="0" baseline="30000">
+                    <a:rPr lang="en-US" sz="4637" b="0" i="0" kern="100" dirty="0">
                       <a:solidFill>
                         <a:srgbClr val="111111"/>
                       </a:solidFill>
@@ -4039,7 +4039,7 @@
                       <a:ea typeface="EB Garamond"/>
                       <a:cs typeface="EB Garamond"/>
                     </a:rPr>
-                    <a:t>[1]</a:t>
+                    <a:t> [1]</a:t>
                   </a:r>
                   <a:r>
                     <a:rPr lang="en-US" sz="4637" b="1" i="0" kern="100" dirty="0">
@@ -4790,29 +4790,7 @@
                       <a:ea typeface="EB Garamond"/>
                       <a:cs typeface="EB Garamond"/>
                     </a:rPr>
-                    <a:t> with trigger</a:t>
-                  </a:r>
-                  <a:r>
-                    <a:rPr lang="en-US" sz="4637" b="0" i="0" kern="100" dirty="0" baseline="30000">
-                      <a:solidFill>
-                        <a:srgbClr val="111111"/>
-                      </a:solidFill>
-                      <a:latin typeface="EB Garamond"/>
-                      <a:ea typeface="EB Garamond"/>
-                      <a:cs typeface="EB Garamond"/>
-                    </a:rPr>
-                    <a:t>[2]</a:t>
-                  </a:r>
-                  <a:r>
-                    <a:rPr lang="en-US" sz="4637" b="0" i="0" kern="100" dirty="0">
-                      <a:solidFill>
-                        <a:srgbClr val="111111"/>
-                      </a:solidFill>
-                      <a:latin typeface="EB Garamond"/>
-                      <a:ea typeface="EB Garamond"/>
-                      <a:cs typeface="EB Garamond"/>
-                    </a:rPr>
-                    <a:t> </a:t>
+                    <a:t> with trigger [2] </a:t>
                   </a:r>
                   <a:r>
                     <a:rPr lang="en-US" sz="4057" b="0" i="0" kern="100" dirty="0">
@@ -5519,7 +5497,7 @@
           <mc:Fallback>
             <p:sp>
               <p:nvSpPr>
-                <p:cNvPr id="16" name="Bullets: Unlearning[1]: forget undesired knowledge, keep "/>
+                <p:cNvPr id="16" name="Bullets: Unlearning [1]: forget undesired knowledge, keep"/>
                 <p:cNvSpPr txBox="1">
                   <a:spLocks noRot="1" noChangeAspect="1" noMove="1" noResize="1" noEditPoints="1" noAdjustHandles="1" noChangeArrowheads="1" noChangeShapeType="1" noTextEdit="1"/>
                 </p:cNvSpPr>
@@ -5528,7 +5506,7 @@
               <p:spPr>
                 <a:xfrm>
                   <a:off x="563265" y="5026207"/>
-                  <a:ext cx="15175508" cy="5209563"/>
+                  <a:ext cx="15175508" cy="4980136"/>
                 </a:xfrm>
                 <a:prstGeom prst="rect">
                   <a:avLst/>
@@ -5577,7 +5555,7 @@
           </p:blipFill>
           <p:spPr>
             <a:xfrm>
-              <a:off x="563265" y="10389377"/>
+              <a:off x="563265" y="10159950"/>
               <a:ext cx="7459729" cy="218083"/>
             </a:xfrm>
             <a:prstGeom prst="rect">
@@ -5607,7 +5585,7 @@
           </p:blipFill>
           <p:spPr>
             <a:xfrm>
-              <a:off x="8278928" y="10389377"/>
+              <a:off x="8278928" y="10159950"/>
               <a:ext cx="7459844" cy="218083"/>
             </a:xfrm>
             <a:prstGeom prst="rect">
@@ -5637,7 +5615,7 @@
           </p:blipFill>
           <p:spPr>
             <a:xfrm>
-              <a:off x="563265" y="10645775"/>
+              <a:off x="563265" y="10416348"/>
               <a:ext cx="7459729" cy="2702305"/>
             </a:xfrm>
             <a:prstGeom prst="rect">
@@ -5667,7 +5645,7 @@
           </p:blipFill>
           <p:spPr>
             <a:xfrm>
-              <a:off x="8278928" y="10645775"/>
+              <a:off x="8278928" y="10416348"/>
               <a:ext cx="7459844" cy="2646048"/>
             </a:xfrm>
             <a:prstGeom prst="rect">
@@ -5697,7 +5675,7 @@
           </p:blipFill>
           <p:spPr>
             <a:xfrm>
-              <a:off x="3446611" y="13437559"/>
+              <a:off x="3446611" y="13208132"/>
               <a:ext cx="9408815" cy="763290"/>
             </a:xfrm>
             <a:prstGeom prst="rect">
@@ -5713,7 +5691,7 @@
           </p:nvSpPr>
           <p:spPr>
             <a:xfrm>
-              <a:off x="563265" y="14418353"/>
+              <a:off x="563265" y="14188926"/>
               <a:ext cx="15266561" cy="1057308"/>
             </a:xfrm>
             <a:prstGeom prst="rect">
@@ -5825,10 +5803,10 @@
         </p:nvGrpSpPr>
         <p:grpSpPr>
           <a:xfrm>
-            <a:off x="563265" y="15787043"/>
-            <a:ext cx="15266561" cy="4794117"/>
-            <a:chOff x="563265" y="15787043"/>
-            <a:chExt cx="15266561" cy="4794117"/>
+            <a:off x="563265" y="15599056"/>
+            <a:ext cx="15266561" cy="4940780"/>
+            <a:chOff x="563265" y="15599056"/>
+            <a:chExt cx="15266561" cy="4940780"/>
           </a:xfrm>
         </p:grpSpPr>
         <p:sp>
@@ -5839,8 +5817,8 @@
           </p:nvSpPr>
           <p:spPr>
             <a:xfrm>
-              <a:off x="563265" y="16018321"/>
-              <a:ext cx="7791186" cy="706570"/>
+              <a:off x="563265" y="15903724"/>
+              <a:ext cx="7491561" cy="706570"/>
             </a:xfrm>
             <a:prstGeom prst="rect">
               <a:avLst/>
@@ -5895,8 +5873,8 @@
           </p:nvSpPr>
           <p:spPr>
             <a:xfrm>
-              <a:off x="563265" y="16724891"/>
-              <a:ext cx="7791186" cy="2350062"/>
+              <a:off x="563265" y="16610294"/>
+              <a:ext cx="7491561" cy="2350062"/>
             </a:xfrm>
             <a:prstGeom prst="rect">
               <a:avLst/>
@@ -6046,8 +6024,8 @@
           </p:blipFill>
           <p:spPr>
             <a:xfrm>
-              <a:off x="8589615" y="15787043"/>
-              <a:ext cx="7149157" cy="3519306"/>
+              <a:off x="8291777" y="15599056"/>
+              <a:ext cx="7446996" cy="3665967"/>
             </a:xfrm>
             <a:prstGeom prst="rect">
               <a:avLst/>
@@ -6062,7 +6040,7 @@
           </p:nvSpPr>
           <p:spPr>
             <a:xfrm>
-              <a:off x="563265" y="19523852"/>
+              <a:off x="563265" y="19482528"/>
               <a:ext cx="15266561" cy="1057308"/>
             </a:xfrm>
             <a:prstGeom prst="rect">
@@ -6152,9 +6130,9 @@
         </p:nvGrpSpPr>
         <p:grpSpPr>
           <a:xfrm>
-            <a:off x="563265" y="20892542"/>
+            <a:off x="563265" y="20892658"/>
             <a:ext cx="15266561" cy="3077931"/>
-            <a:chOff x="563265" y="20892542"/>
+            <a:chOff x="563265" y="20892658"/>
             <a:chExt cx="15266561" cy="3077931"/>
           </a:xfrm>
         </p:grpSpPr>
@@ -6166,7 +6144,7 @@
           </p:nvSpPr>
           <p:spPr>
             <a:xfrm>
-              <a:off x="563265" y="20892542"/>
+              <a:off x="563265" y="20892658"/>
               <a:ext cx="15266561" cy="801836"/>
             </a:xfrm>
             <a:prstGeom prst="rect">
@@ -6227,7 +6205,7 @@
           </p:nvSpPr>
           <p:spPr>
             <a:xfrm>
-              <a:off x="596602" y="21881323"/>
+              <a:off x="596602" y="21881439"/>
               <a:ext cx="15108833" cy="2089150"/>
             </a:xfrm>
             <a:prstGeom prst="roundRect">
@@ -6313,9 +6291,9 @@
         <p:grpSpPr>
           <a:xfrm>
             <a:off x="16290015" y="4070763"/>
-            <a:ext cx="16855846" cy="11741398"/>
+            <a:ext cx="16855846" cy="11626685"/>
             <a:chOff x="16290015" y="4070763"/>
-            <a:chExt cx="16855846" cy="11741398"/>
+            <a:chExt cx="16855846" cy="11626685"/>
           </a:xfrm>
         </p:grpSpPr>
         <p:sp>
@@ -6383,14 +6361,14 @@
           <mc:Choice Requires="a14">
             <p:sp>
               <p:nvSpPr>
-                <p:cNvPr id="30" name="Bullets: Attention sink[3]: LLMs over-attend the first … "/>
+                <p:cNvPr id="30" name="Bullets: Attention sink [3]: LLMs over-attend the first …"/>
                 <p:cNvSpPr txBox="1"/>
                 <p:nvPr/>
               </p:nvSpPr>
               <p:spPr>
                 <a:xfrm>
                   <a:off x="16302038" y="5026207"/>
-                  <a:ext cx="16843823" cy="1527853"/>
+                  <a:ext cx="16843823" cy="1413140"/>
                 </a:xfrm>
                 <a:prstGeom prst="rect">
                   <a:avLst/>
@@ -6432,7 +6410,7 @@
                     <a:t>Attention sink</a:t>
                   </a:r>
                   <a:r>
-                    <a:rPr lang="en-US" sz="4637" b="0" i="0" kern="100" dirty="0" baseline="30000">
+                    <a:rPr lang="en-US" sz="4637" b="0" i="0" kern="100" dirty="0">
                       <a:solidFill>
                         <a:srgbClr val="111111"/>
                       </a:solidFill>
@@ -6440,7 +6418,18 @@
                       <a:ea typeface="EB Garamond"/>
                       <a:cs typeface="EB Garamond"/>
                     </a:rPr>
-                    <a:t>[3]</a:t>
+                    <a:t> [3]</a:t>
+                  </a:r>
+                  <a:r>
+                    <a:rPr lang="en-US" sz="4637" b="1" i="0" kern="100" dirty="0">
+                      <a:solidFill>
+                        <a:srgbClr val="18453B"/>
+                      </a:solidFill>
+                      <a:latin typeface="EB Garamond"/>
+                      <a:ea typeface="EB Garamond"/>
+                      <a:cs typeface="EB Garamond"/>
+                    </a:rPr>
+                    <a:t>:</a:t>
                   </a:r>
                   <a:r>
                     <a:rPr lang="en-US" sz="4637" b="0" i="0" kern="100" dirty="0">
@@ -6451,7 +6440,7 @@
                       <a:ea typeface="EB Garamond"/>
                       <a:cs typeface="EB Garamond"/>
                     </a:rPr>
-                    <a:t>: LLMs over-attend the first </a:t>
+                    <a:t> LLMs over-attend the first </a:t>
                   </a:r>
                   <a14:m>
                     <m:oMath xmlns:m="http://schemas.openxmlformats.org/officeDocument/2006/math">
@@ -6541,7 +6530,7 @@
           <mc:Fallback>
             <p:sp>
               <p:nvSpPr>
-                <p:cNvPr id="30" name="Bullets: Attention sink[3]: LLMs over-attend the first … "/>
+                <p:cNvPr id="30" name="Bullets: Attention sink [3]: LLMs over-attend the first …"/>
                 <p:cNvSpPr txBox="1">
                   <a:spLocks noRot="1" noChangeAspect="1" noMove="1" noResize="1" noEditPoints="1" noAdjustHandles="1" noChangeArrowheads="1" noChangeShapeType="1" noTextEdit="1"/>
                 </p:cNvSpPr>
@@ -6550,7 +6539,7 @@
               <p:spPr>
                 <a:xfrm>
                   <a:off x="16302038" y="5026207"/>
-                  <a:ext cx="16644094" cy="1527853"/>
+                  <a:ext cx="16644094" cy="1413140"/>
                 </a:xfrm>
                 <a:prstGeom prst="rect">
                   <a:avLst/>
@@ -6599,7 +6588,7 @@
           </p:blipFill>
           <p:spPr>
             <a:xfrm>
-              <a:off x="16302038" y="6707667"/>
+              <a:off x="16302038" y="6592954"/>
               <a:ext cx="4007445" cy="4172396"/>
             </a:xfrm>
             <a:prstGeom prst="rect">
@@ -6615,7 +6604,7 @@
           </p:nvSpPr>
           <p:spPr>
             <a:xfrm>
-              <a:off x="16290015" y="10931227"/>
+              <a:off x="16290015" y="10816514"/>
               <a:ext cx="4031490" cy="492886"/>
             </a:xfrm>
             <a:prstGeom prst="rect">
@@ -6685,7 +6674,7 @@
           </p:blipFill>
           <p:spPr>
             <a:xfrm>
-              <a:off x="20514254" y="6707667"/>
+              <a:off x="20514254" y="6592954"/>
               <a:ext cx="4007445" cy="4172396"/>
             </a:xfrm>
             <a:prstGeom prst="rect">
@@ -6701,7 +6690,7 @@
           </p:nvSpPr>
           <p:spPr>
             <a:xfrm>
-              <a:off x="20502231" y="10931227"/>
+              <a:off x="20502231" y="10816514"/>
               <a:ext cx="4031490" cy="492886"/>
             </a:xfrm>
             <a:prstGeom prst="rect">
@@ -6771,7 +6760,7 @@
           </p:blipFill>
           <p:spPr>
             <a:xfrm>
-              <a:off x="24726470" y="7055511"/>
+              <a:off x="24726470" y="6940798"/>
               <a:ext cx="4007445" cy="3824552"/>
             </a:xfrm>
             <a:prstGeom prst="rect">
@@ -6787,7 +6776,7 @@
           </p:nvSpPr>
           <p:spPr>
             <a:xfrm>
-              <a:off x="24714448" y="10931227"/>
+              <a:off x="24714448" y="10816514"/>
               <a:ext cx="4031490" cy="492886"/>
             </a:xfrm>
             <a:prstGeom prst="rect">
@@ -6857,7 +6846,7 @@
           </p:blipFill>
           <p:spPr>
             <a:xfrm>
-              <a:off x="28938686" y="7055511"/>
+              <a:off x="28938686" y="6940798"/>
               <a:ext cx="4007445" cy="3824552"/>
             </a:xfrm>
             <a:prstGeom prst="rect">
@@ -6873,7 +6862,7 @@
           </p:nvSpPr>
           <p:spPr>
             <a:xfrm>
-              <a:off x="28926664" y="10931227"/>
+              <a:off x="28926664" y="10816514"/>
               <a:ext cx="4031490" cy="492886"/>
             </a:xfrm>
             <a:prstGeom prst="rect">
@@ -6943,7 +6932,7 @@
           </p:blipFill>
           <p:spPr>
             <a:xfrm>
-              <a:off x="16302038" y="11475277"/>
+              <a:off x="16302038" y="11360563"/>
               <a:ext cx="8219662" cy="507239"/>
             </a:xfrm>
             <a:prstGeom prst="rect">
@@ -6961,7 +6950,7 @@
               </p:nvSpPr>
               <p:spPr>
                 <a:xfrm>
-                  <a:off x="16302038" y="12200020"/>
+                  <a:off x="16302038" y="12085307"/>
                   <a:ext cx="16843823" cy="1057308"/>
                 </a:xfrm>
                 <a:prstGeom prst="rect">
@@ -7105,7 +7094,7 @@
               </p:nvSpPr>
               <p:spPr>
                 <a:xfrm>
-                  <a:off x="16302038" y="12200020"/>
+                  <a:off x="16302038" y="12085307"/>
                   <a:ext cx="16644094" cy="1057308"/>
                 </a:xfrm>
                 <a:prstGeom prst="rect">
@@ -7141,7 +7130,7 @@
           </p:nvSpPr>
           <p:spPr>
             <a:xfrm>
-              <a:off x="16302038" y="13410935"/>
+              <a:off x="16302038" y="13296222"/>
               <a:ext cx="8181231" cy="2401226"/>
             </a:xfrm>
             <a:custGeom>
@@ -7236,7 +7225,7 @@
           </p:nvSpPr>
           <p:spPr>
             <a:xfrm>
-              <a:off x="16302038" y="13410935"/>
+              <a:off x="16302038" y="13296222"/>
               <a:ext cx="111125" cy="2401226"/>
             </a:xfrm>
             <a:prstGeom prst="rect">
@@ -7258,7 +7247,7 @@
           </p:nvSpPr>
           <p:spPr>
             <a:xfrm>
-              <a:off x="24764901" y="13410935"/>
+              <a:off x="24764901" y="13296222"/>
               <a:ext cx="8181231" cy="2401226"/>
             </a:xfrm>
             <a:custGeom>
@@ -7353,7 +7342,7 @@
           </p:nvSpPr>
           <p:spPr>
             <a:xfrm>
-              <a:off x="24764901" y="13410935"/>
+              <a:off x="24764901" y="13296222"/>
               <a:ext cx="111125" cy="2401226"/>
             </a:xfrm>
             <a:prstGeom prst="rect">
@@ -10609,9 +10598,9 @@
         <p:grpSpPr>
           <a:xfrm>
             <a:off x="33509396" y="4070763"/>
-            <a:ext cx="17236541" cy="13927204"/>
+            <a:ext cx="17236541" cy="13844555"/>
             <a:chOff x="33509396" y="4070763"/>
-            <a:chExt cx="17236541" cy="13927204"/>
+            <a:chExt cx="17236541" cy="13844555"/>
           </a:xfrm>
         </p:grpSpPr>
         <p:sp>
@@ -10707,14 +10696,14 @@
         </p:pic>
         <p:sp>
           <p:nvSpPr>
-            <p:cNvPr id="53" name="Caption: Table 1. Results on MUSE[4] with NPO[5] / RMU[6]"/>
+            <p:cNvPr id="53" name="Caption: Table 1. Results on MUSE [4] with NPO [5] / RMU "/>
             <p:cNvSpPr txBox="1"/>
             <p:nvPr/>
           </p:nvSpPr>
           <p:spPr>
             <a:xfrm>
               <a:off x="33509396" y="12028239"/>
-              <a:ext cx="17236541" cy="1140536"/>
+              <a:ext cx="17236541" cy="1057887"/>
             </a:xfrm>
             <a:prstGeom prst="rect">
               <a:avLst/>
@@ -10759,73 +10748,7 @@
                   <a:ea typeface="EB Garamond"/>
                   <a:cs typeface="EB Garamond"/>
                 </a:rPr>
-                <a:t> Results on MUSE</a:t>
-              </a:r>
-              <a:r>
-                <a:rPr lang="en-US" sz="3528" b="0" i="0" kern="100" dirty="0" baseline="30000">
-                  <a:solidFill>
-                    <a:srgbClr val="111111"/>
-                  </a:solidFill>
-                  <a:latin typeface="EB Garamond"/>
-                  <a:ea typeface="EB Garamond"/>
-                  <a:cs typeface="EB Garamond"/>
-                </a:rPr>
-                <a:t>[4]</a:t>
-              </a:r>
-              <a:r>
-                <a:rPr lang="en-US" sz="3528" b="0" i="0" kern="100" dirty="0">
-                  <a:solidFill>
-                    <a:srgbClr val="111111"/>
-                  </a:solidFill>
-                  <a:latin typeface="EB Garamond"/>
-                  <a:ea typeface="EB Garamond"/>
-                  <a:cs typeface="EB Garamond"/>
-                </a:rPr>
-                <a:t> with NPO</a:t>
-              </a:r>
-              <a:r>
-                <a:rPr lang="en-US" sz="3528" b="0" i="0" kern="100" dirty="0" baseline="30000">
-                  <a:solidFill>
-                    <a:srgbClr val="111111"/>
-                  </a:solidFill>
-                  <a:latin typeface="EB Garamond"/>
-                  <a:ea typeface="EB Garamond"/>
-                  <a:cs typeface="EB Garamond"/>
-                </a:rPr>
-                <a:t>[5]</a:t>
-              </a:r>
-              <a:r>
-                <a:rPr lang="en-US" sz="3528" b="0" i="0" kern="100" dirty="0">
-                  <a:solidFill>
-                    <a:srgbClr val="111111"/>
-                  </a:solidFill>
-                  <a:latin typeface="EB Garamond"/>
-                  <a:ea typeface="EB Garamond"/>
-                  <a:cs typeface="EB Garamond"/>
-                </a:rPr>
-                <a:t> / RMU</a:t>
-              </a:r>
-              <a:r>
-                <a:rPr lang="en-US" sz="3528" b="0" i="0" kern="100" dirty="0" baseline="30000">
-                  <a:solidFill>
-                    <a:srgbClr val="111111"/>
-                  </a:solidFill>
-                  <a:latin typeface="EB Garamond"/>
-                  <a:ea typeface="EB Garamond"/>
-                  <a:cs typeface="EB Garamond"/>
-                </a:rPr>
-                <a:t>[6]</a:t>
-              </a:r>
-              <a:r>
-                <a:rPr lang="en-US" sz="3528" b="0" i="0" kern="100" dirty="0">
-                  <a:solidFill>
-                    <a:srgbClr val="111111"/>
-                  </a:solidFill>
-                  <a:latin typeface="EB Garamond"/>
-                  <a:ea typeface="EB Garamond"/>
-                  <a:cs typeface="EB Garamond"/>
-                </a:rPr>
-                <a:t>, trigger </a:t>
+                <a:t> Results on MUSE [4] with NPO [5] / RMU [6], trigger </a:t>
               </a:r>
               <a:r>
                 <a:rPr lang="en-US" sz="3087" b="0" i="0" kern="100" dirty="0">
@@ -10885,7 +10808,7 @@
           </p:blipFill>
           <p:spPr>
             <a:xfrm>
-              <a:off x="33509396" y="13322383"/>
+              <a:off x="33509396" y="13239733"/>
               <a:ext cx="10920578" cy="3596630"/>
             </a:xfrm>
             <a:prstGeom prst="rect">
@@ -10895,14 +10818,14 @@
         </p:pic>
         <p:sp>
           <p:nvSpPr>
-            <p:cNvPr id="55" name="Caption: Table 2. Results on WMDP-Bio[6] (Zephyr-7B, accu"/>
+            <p:cNvPr id="55" name="Caption: Table 2. Results on WMDP-Bio [6] (Zephyr-7B, acc"/>
             <p:cNvSpPr txBox="1"/>
             <p:nvPr/>
           </p:nvSpPr>
           <p:spPr>
             <a:xfrm>
-              <a:off x="33509396" y="16982910"/>
-              <a:ext cx="10986101" cy="611303"/>
+              <a:off x="33509396" y="16900260"/>
+              <a:ext cx="10986101" cy="528654"/>
             </a:xfrm>
             <a:prstGeom prst="rect">
               <a:avLst/>
@@ -10947,29 +10870,7 @@
                   <a:ea typeface="EB Garamond"/>
                   <a:cs typeface="EB Garamond"/>
                 </a:rPr>
-                <a:t> Results on WMDP-Bio</a:t>
-              </a:r>
-              <a:r>
-                <a:rPr lang="en-US" sz="3528" b="0" i="0" kern="100" dirty="0" baseline="30000">
-                  <a:solidFill>
-                    <a:srgbClr val="111111"/>
-                  </a:solidFill>
-                  <a:latin typeface="EB Garamond"/>
-                  <a:ea typeface="EB Garamond"/>
-                  <a:cs typeface="EB Garamond"/>
-                </a:rPr>
-                <a:t>[6]</a:t>
-              </a:r>
-              <a:r>
-                <a:rPr lang="en-US" sz="3528" b="0" i="0" kern="100" dirty="0">
-                  <a:solidFill>
-                    <a:srgbClr val="111111"/>
-                  </a:solidFill>
-                  <a:latin typeface="EB Garamond"/>
-                  <a:ea typeface="EB Garamond"/>
-                  <a:cs typeface="EB Garamond"/>
-                </a:rPr>
-                <a:t> (Zephyr-7B, accuracy).</a:t>
+                <a:t> Results on WMDP-Bio [6] (Zephyr-7B, accuracy).</a:t>
               </a:r>
               <a:endParaRPr lang="en-US" sz="3528" b="0" i="0" kern="100" dirty="0">
                 <a:solidFill>
@@ -10990,7 +10891,7 @@
           </p:nvSpPr>
           <p:spPr>
             <a:xfrm>
-              <a:off x="44788700" y="13348312"/>
+              <a:off x="44788700" y="13265663"/>
               <a:ext cx="5828506" cy="4649655"/>
             </a:xfrm>
             <a:prstGeom prst="roundRect">
@@ -11087,9 +10988,9 @@
         </p:nvGrpSpPr>
         <p:grpSpPr>
           <a:xfrm>
-            <a:off x="33509396" y="18303098"/>
+            <a:off x="33509396" y="18261773"/>
             <a:ext cx="17133739" cy="3814366"/>
-            <a:chOff x="33509396" y="18303098"/>
+            <a:chOff x="33509396" y="18261773"/>
             <a:chExt cx="17133739" cy="3814366"/>
           </a:xfrm>
         </p:grpSpPr>
@@ -11115,7 +11016,7 @@
           </p:blipFill>
           <p:spPr>
             <a:xfrm>
-              <a:off x="33509396" y="18303098"/>
+              <a:off x="33509396" y="18261773"/>
               <a:ext cx="13104647" cy="2330847"/>
             </a:xfrm>
             <a:prstGeom prst="rect">
@@ -11133,7 +11034,7 @@
               </p:nvSpPr>
               <p:spPr>
                 <a:xfrm>
-                  <a:off x="33509396" y="20697842"/>
+                  <a:off x="33509396" y="20656517"/>
                   <a:ext cx="13261903" cy="1057308"/>
                 </a:xfrm>
                 <a:prstGeom prst="rect">
@@ -11255,7 +11156,7 @@
               </p:nvSpPr>
               <p:spPr>
                 <a:xfrm>
-                  <a:off x="33509396" y="20697842"/>
+                  <a:off x="33509396" y="20656517"/>
                   <a:ext cx="13104647" cy="1057308"/>
                 </a:xfrm>
                 <a:prstGeom prst="rect">
@@ -11291,7 +11192,7 @@
           </p:nvSpPr>
           <p:spPr>
             <a:xfrm>
-              <a:off x="46946840" y="18303098"/>
+              <a:off x="46946840" y="18261773"/>
               <a:ext cx="3696295" cy="3814366"/>
             </a:xfrm>
             <a:custGeom>
@@ -11408,7 +11309,7 @@
           </p:nvSpPr>
           <p:spPr>
             <a:xfrm>
-              <a:off x="46946840" y="18303098"/>
+              <a:off x="46946840" y="18261773"/>
               <a:ext cx="111125" cy="3814366"/>
             </a:xfrm>
             <a:prstGeom prst="rect">

</xml_diff>